<commit_message>
Deck: the rebuilt PPTX itself (previous commit carried only build.js)
Co-Authored-By: Claude Opus 5.5 <noreply@anthropic.com>
Claude-Session: https://claude.ai/code/session_011KQSFKCwgub7G5EKjwmTaV
</commit_message>
<xml_diff>
--- a/TIET_Update_Submission_ppt.pptx
+++ b/TIET_Update_Submission_ppt.pptx
@@ -19,9 +19,10 @@
     <p:sldId id="267" r:id="rId13"/>
     <p:sldId id="268" r:id="rId14"/>
     <p:sldId id="269" r:id="rId15"/>
+    <p:sldId id="270" r:id="rId16"/>
   </p:sldIdLst>
   <p:notesMasterIdLst>
-    <p:notesMasterId r:id="rId16"/>
+    <p:notesMasterId r:id="rId17"/>
   </p:notesMasterIdLst>
   <p:sldSz cx="12192000" cy="6858000"/>
   <p:notesSz cx="6858000" cy="12192000"/>
@@ -515,7 +516,7 @@
           <a:p>
             <a:r>
               <a:rPr lang="en-US" dirty="0"/>
-              <a:t>Theme 3, Teachable Voice Automation. Team Update from TIET. One sentence: you teach the phone a task by doing it once while it listens and watches; after that you just say it, with different values or wording, and it does it through the accessibility service, stopping before payment. The phone shows the task it learned from one Zomato demo.</a:t>
+              <a:t>Theme 3, Teachable Voice Automation. Team Update from TIET: Shikhar Goel and Ishpreet Singh, third-year Computer Engineering. One sentence: you teach the phone a task by doing it once while it listens and watches; after that you just say it, with different values or wording, and it does it through the accessibility service, stopping before payment. The phone shows the task it learned from one Zomato demo.</a:t>
             </a:r>
             <a:endParaRPr lang="en-US" dirty="0"/>
           </a:p>
@@ -603,7 +604,7 @@
           <a:p>
             <a:r>
               <a:rPr lang="en-US" dirty="0"/>
-              <a:t>The theme's own test table, in order, with what our build does on each. Details and timings for every row are in the evaluation documents in the repository.</a:t>
+              <a:t>To check that nothing is tuned to our three target apps, we taught a task on GitHub's Android app, which the assistant had never seen: open a repository by name. One demonstration; then new repository names ran in about 17 to 18 seconds with no language-model calls, and a paraphrase was understood too. The repository name became a slot on its own.</a:t>
             </a:r>
             <a:endParaRPr lang="en-US" dirty="0"/>
           </a:p>
@@ -691,7 +692,7 @@
           <a:p>
             <a:r>
               <a:rPr lang="en-US" dirty="0"/>
-              <a:t>If the jury remembers one thing: the language model is a fallback, not the engine. Replays on known screens are deterministic and verified, which is what makes a single demonstration dependable.</a:t>
+              <a:t>The theme's own test table, in order, with what our build does on each. Details and timings for every row are in the evaluation documents in the repository.</a:t>
             </a:r>
             <a:endParaRPr lang="en-US" dirty="0"/>
           </a:p>
@@ -779,7 +780,7 @@
           <a:p>
             <a:r>
               <a:rPr lang="en-US" dirty="0"/>
-              <a:t>Plain native Android in Kotlin; no root, no app SDKs. One hosted model through Fireworks' OpenAI-compatible API. Everything is reproducible with the Dockerfile, and the test benches drive the phone over adb.</a:t>
+              <a:t>If the jury remembers one thing: the language model is a fallback, not the engine. Replays on known screens are deterministic and verified, which is what makes a single demonstration dependable.</a:t>
             </a:r>
             <a:endParaRPr lang="en-US" dirty="0"/>
           </a:p>
@@ -867,7 +868,7 @@
           <a:p>
             <a:r>
               <a:rPr lang="en-US" dirty="0"/>
-              <a:t>These are all in the README too. The sideloading one matters for anyone installing the APK in India: Play Protect's enhanced fraud protection blocks apps with an accessibility service when they come from a browser or chat app; adb install or pausing the scan works.</a:t>
+              <a:t>Plain native Android in Kotlin; no root, no app SDKs. One hosted model through Fireworks' OpenAI-compatible API. Everything is reproducible with the Dockerfile, and the test benches drive the phone over adb.</a:t>
             </a:r>
             <a:endParaRPr lang="en-US" dirty="0"/>
           </a:p>
@@ -955,7 +956,7 @@
           <a:p>
             <a:r>
               <a:rPr lang="en-US" dirty="0"/>
-              <a:t>Where it goes next: an on-device model for privacy and speed, sharing taught tasks, routines, and more Indian languages. Thank you; the repository has the code, README, Dockerfile and every evaluation table.</a:t>
+              <a:t>These are all in the README too. The sideloading one matters for anyone installing the APK in India: Play Protect's enhanced fraud protection blocks apps with an accessibility service when they come from a browser or chat app; adb install or pausing the scan works.</a:t>
             </a:r>
             <a:endParaRPr lang="en-US" dirty="0"/>
           </a:p>
@@ -979,6 +980,94 @@
             <a:fld id="{F7021451-1387-4CA6-816F-3879F97B5CBC}" type="slidenum">
               <a:rPr lang="en-US"/>
               <a:t>14</a:t>
+            </a:fld>
+            <a:endParaRPr lang="en-US"/>
+          </a:p>
+        </p:txBody>
+      </p:sp>
+    </p:spTree>
+    <p:extLst>
+      <p:ext uri="{BB962C8B-B14F-4D97-AF65-F5344CB8AC3E}">
+        <p14:creationId xmlns:p14="http://schemas.microsoft.com/office/powerpoint/2010/main" val="1024086991"/>
+      </p:ext>
+    </p:extLst>
+  </p:cSld>
+  <p:clrMapOvr>
+    <a:masterClrMapping/>
+  </p:clrMapOvr>
+</p:notes>
+</file>
+
+<file path=ppt/notesSlides/notesSlide15.xml><?xml version="1.0" encoding="utf-8"?>
+<p:notes xmlns:a="http://schemas.openxmlformats.org/drawingml/2006/main" xmlns:r="http://schemas.openxmlformats.org/officeDocument/2006/relationships" xmlns:p="http://schemas.openxmlformats.org/presentationml/2006/main">
+  <p:cSld>
+    <p:spTree>
+      <p:nvGrpSpPr>
+        <p:cNvPr id="1" name=""/>
+        <p:cNvGrpSpPr/>
+        <p:nvPr/>
+      </p:nvGrpSpPr>
+      <p:grpSpPr>
+        <a:xfrm>
+          <a:off x="0" y="0"/>
+          <a:ext cx="0" cy="0"/>
+          <a:chOff x="0" y="0"/>
+          <a:chExt cx="0" cy="0"/>
+        </a:xfrm>
+      </p:grpSpPr>
+      <p:sp>
+        <p:nvSpPr>
+          <p:cNvPr id="2" name="Slide Image Placeholder 1"/>
+          <p:cNvSpPr>
+            <a:spLocks noGrp="1" noRot="1" noChangeAspect="1"/>
+          </p:cNvSpPr>
+          <p:nvPr>
+            <p:ph type="sldImg"/>
+          </p:nvPr>
+        </p:nvSpPr>
+        <p:spPr/>
+      </p:sp>
+      <p:sp>
+        <p:nvSpPr>
+          <p:cNvPr id="3" name="Notes Placeholder 2"/>
+          <p:cNvSpPr>
+            <a:spLocks noGrp="1"/>
+          </p:cNvSpPr>
+          <p:nvPr>
+            <p:ph type="body" idx="1"/>
+          </p:nvPr>
+        </p:nvSpPr>
+        <p:spPr/>
+        <p:txBody>
+          <a:bodyPr/>
+          <a:lstStyle/>
+          <a:p>
+            <a:r>
+              <a:rPr lang="en-US" dirty="0"/>
+              <a:t>Where it goes next: an on-device model for privacy and speed, sharing taught tasks, routines, and more Indian languages. Thank you; the repository has the code, README, Dockerfile and every evaluation table.</a:t>
+            </a:r>
+            <a:endParaRPr lang="en-US" dirty="0"/>
+          </a:p>
+        </p:txBody>
+      </p:sp>
+      <p:sp>
+        <p:nvSpPr>
+          <p:cNvPr id="4" name="Slide Number Placeholder 3"/>
+          <p:cNvSpPr>
+            <a:spLocks noGrp="1"/>
+          </p:cNvSpPr>
+          <p:nvPr>
+            <p:ph type="sldNum" sz="quarter" idx="10"/>
+          </p:nvPr>
+        </p:nvSpPr>
+        <p:spPr/>
+        <p:txBody>
+          <a:bodyPr/>
+          <a:lstStyle/>
+          <a:p>
+            <a:fld id="{F7021451-1387-4CA6-816F-3879F97B5CBC}" type="slidenum">
+              <a:rPr lang="en-US"/>
+              <a:t>15</a:t>
             </a:fld>
             <a:endParaRPr lang="en-US"/>
           </a:p>
@@ -1659,7 +1748,7 @@
           <a:p>
             <a:r>
               <a:rPr lang="en-US" dirty="0"/>
-              <a:t>All numbers come from benches that force-stop the app before each run and log every step; the method and every table are in the docs folder. The judges' own sentence reached payment eight times out of eight without a single language-model call.</a:t>
+              <a:t>All numbers come from benches that force-stop the app before each run and log every step; the method and every table are in the docs folder. The judges' own sentence reached payment eight times out of eight without a single language-model call. On 30 September we ran every sentence from the theme's test table verbatim, including the rubric's own garlic-bread example, and all were handled.</a:t>
             </a:r>
             <a:endParaRPr lang="en-US" dirty="0"/>
           </a:p>
@@ -2135,7 +2224,7 @@
         </p:nvSpPr>
         <p:spPr>
           <a:xfrm>
-            <a:off x="548640" y="2743200"/>
+            <a:off x="548640" y="2697480"/>
             <a:ext cx="6949440" cy="914400"/>
           </a:xfrm>
           <a:prstGeom prst="rect">
@@ -2174,7 +2263,7 @@
         </p:nvSpPr>
         <p:spPr>
           <a:xfrm>
-            <a:off x="548640" y="3840480"/>
+            <a:off x="548640" y="3703320"/>
             <a:ext cx="5852160" cy="548640"/>
           </a:xfrm>
           <a:prstGeom prst="roundRect">
@@ -2201,7 +2290,7 @@
         </p:nvSpPr>
         <p:spPr>
           <a:xfrm>
-            <a:off x="612648" y="3904488"/>
+            <a:off x="612648" y="3767328"/>
             <a:ext cx="420624" cy="420624"/>
           </a:xfrm>
           <a:prstGeom prst="ellipse">
@@ -2234,7 +2323,7 @@
         </p:blipFill>
         <p:spPr>
           <a:xfrm>
-            <a:off x="696773" y="3988613"/>
+            <a:off x="696773" y="3851453"/>
             <a:ext cx="252374" cy="252374"/>
           </a:xfrm>
           <a:prstGeom prst="rect">
@@ -2250,7 +2339,7 @@
         </p:nvSpPr>
         <p:spPr>
           <a:xfrm>
-            <a:off x="1152144" y="3840480"/>
+            <a:off x="1152144" y="3703320"/>
             <a:ext cx="5157216" cy="548640"/>
           </a:xfrm>
           <a:prstGeom prst="rect">
@@ -2291,8 +2380,8 @@
         </p:nvSpPr>
         <p:spPr>
           <a:xfrm>
-            <a:off x="548640" y="4663440"/>
-            <a:ext cx="6949440" cy="1005840"/>
+            <a:off x="548640" y="4480560"/>
+            <a:ext cx="6949440" cy="640080"/>
           </a:xfrm>
           <a:prstGeom prst="rect">
             <a:avLst/>
@@ -2306,7 +2395,7 @@
           <a:p>
             <a:pPr indent="0" marL="0">
               <a:spcAft>
-                <a:spcPts val="400"/>
+                <a:spcPts val="200"/>
               </a:spcAft>
               <a:buNone/>
             </a:pPr>
@@ -2326,12 +2415,12 @@
           <a:p>
             <a:pPr indent="0" marL="0">
               <a:spcAft>
-                <a:spcPts val="400"/>
+                <a:spcPts val="200"/>
               </a:spcAft>
               <a:buNone/>
             </a:pPr>
             <a:r>
-              <a:rPr lang="en-US" sz="1500" dirty="0">
+              <a:rPr lang="en-US" sz="1400" dirty="0">
                 <a:solidFill>
                   <a:srgbClr val="C8CDE6"/>
                 </a:solidFill>
@@ -2339,7 +2428,7 @@
                 <a:ea typeface="Calibri" pitchFamily="34" charset="-122"/>
                 <a:cs typeface="Calibri" pitchFamily="34" charset="-120"/>
               </a:rPr>
-              <a:t>Thapar Institute of Engineering and Technology (TIET)</a:t>
+              <a:t>Thapar Institute of Engineering and Technology (TIET), Patiala</a:t>
             </a:r>
             <a:endParaRPr lang="en-US" sz="1800" dirty="0"/>
           </a:p>
@@ -2353,31 +2442,143 @@
         </p:nvSpPr>
         <p:spPr>
           <a:xfrm>
-            <a:off x="548640" y="5943600"/>
-            <a:ext cx="7315200" cy="320040"/>
-          </a:xfrm>
-          <a:prstGeom prst="rect">
-            <a:avLst/>
-          </a:prstGeom>
-          <a:noFill/>
-          <a:ln/>
-        </p:spPr>
-        <p:txBody>
-          <a:bodyPr wrap="square" lIns="0" tIns="0" rIns="0" bIns="0" rtlCol="0" anchor="ctr"/>
-          <a:lstStyle/>
-          <a:p>
-            <a:pPr indent="0" marL="0">
-              <a:buNone/>
-            </a:pPr>
-            <a:r>
-              <a:rPr lang="en-US" sz="1200" dirty="0">
-                <a:solidFill>
-                  <a:srgbClr val="8A91B4"/>
+            <a:off x="548640" y="5166360"/>
+            <a:ext cx="3200400" cy="566928"/>
+          </a:xfrm>
+          <a:prstGeom prst="rect">
+            <a:avLst/>
+          </a:prstGeom>
+          <a:noFill/>
+          <a:ln/>
+        </p:spPr>
+        <p:txBody>
+          <a:bodyPr wrap="square" lIns="0" tIns="0" rIns="0" bIns="0" rtlCol="0" anchor="t"/>
+          <a:lstStyle/>
+          <a:p>
+            <a:pPr indent="0" marL="0">
+              <a:buNone/>
+            </a:pPr>
+            <a:r>
+              <a:rPr lang="en-US" sz="1500" b="1" dirty="0">
+                <a:solidFill>
+                  <a:srgbClr val="FFFFFF"/>
                 </a:solidFill>
                 <a:latin typeface="Calibri" pitchFamily="34" charset="0"/>
                 <a:ea typeface="Calibri" pitchFamily="34" charset="-122"/>
                 <a:cs typeface="Calibri" pitchFamily="34" charset="-120"/>
               </a:rPr>
+              <a:t>Shikhar Goel</a:t>
+            </a:r>
+            <a:endParaRPr lang="en-US" sz="1500" dirty="0"/>
+          </a:p>
+          <a:p>
+            <a:pPr indent="0" marL="0">
+              <a:buNone/>
+            </a:pPr>
+            <a:r>
+              <a:rPr lang="en-US" sz="1250" dirty="0">
+                <a:solidFill>
+                  <a:srgbClr val="C8CDE6"/>
+                </a:solidFill>
+                <a:latin typeface="Calibri" pitchFamily="34" charset="0"/>
+                <a:ea typeface="Calibri" pitchFamily="34" charset="-122"/>
+                <a:cs typeface="Calibri" pitchFamily="34" charset="-120"/>
+              </a:rPr>
+              <a:t>3rd year, Computer Engineering</a:t>
+            </a:r>
+            <a:endParaRPr lang="en-US" sz="1500" dirty="0"/>
+          </a:p>
+        </p:txBody>
+      </p:sp>
+      <p:sp>
+        <p:nvSpPr>
+          <p:cNvPr id="11" name="Text 8"/>
+          <p:cNvSpPr txBox="1"/>
+          <p:nvPr/>
+        </p:nvSpPr>
+        <p:spPr>
+          <a:xfrm>
+            <a:off x="3931920" y="5166360"/>
+            <a:ext cx="3200400" cy="566928"/>
+          </a:xfrm>
+          <a:prstGeom prst="rect">
+            <a:avLst/>
+          </a:prstGeom>
+          <a:noFill/>
+          <a:ln/>
+        </p:spPr>
+        <p:txBody>
+          <a:bodyPr wrap="square" lIns="0" tIns="0" rIns="0" bIns="0" rtlCol="0" anchor="t"/>
+          <a:lstStyle/>
+          <a:p>
+            <a:pPr indent="0" marL="0">
+              <a:buNone/>
+            </a:pPr>
+            <a:r>
+              <a:rPr lang="en-US" sz="1500" b="1" dirty="0">
+                <a:solidFill>
+                  <a:srgbClr val="FFFFFF"/>
+                </a:solidFill>
+                <a:latin typeface="Calibri" pitchFamily="34" charset="0"/>
+                <a:ea typeface="Calibri" pitchFamily="34" charset="-122"/>
+                <a:cs typeface="Calibri" pitchFamily="34" charset="-120"/>
+              </a:rPr>
+              <a:t>Ishpreet Singh</a:t>
+            </a:r>
+            <a:endParaRPr lang="en-US" sz="1500" dirty="0"/>
+          </a:p>
+          <a:p>
+            <a:pPr indent="0" marL="0">
+              <a:buNone/>
+            </a:pPr>
+            <a:r>
+              <a:rPr lang="en-US" sz="1250" dirty="0">
+                <a:solidFill>
+                  <a:srgbClr val="C8CDE6"/>
+                </a:solidFill>
+                <a:latin typeface="Calibri" pitchFamily="34" charset="0"/>
+                <a:ea typeface="Calibri" pitchFamily="34" charset="-122"/>
+                <a:cs typeface="Calibri" pitchFamily="34" charset="-120"/>
+              </a:rPr>
+              <a:t>3rd year, Computer Engineering</a:t>
+            </a:r>
+            <a:endParaRPr lang="en-US" sz="1500" dirty="0"/>
+          </a:p>
+        </p:txBody>
+      </p:sp>
+      <p:sp>
+        <p:nvSpPr>
+          <p:cNvPr id="12" name="Text 9"/>
+          <p:cNvSpPr txBox="1"/>
+          <p:nvPr/>
+        </p:nvSpPr>
+        <p:spPr>
+          <a:xfrm>
+            <a:off x="548640" y="5943600"/>
+            <a:ext cx="7315200" cy="320040"/>
+          </a:xfrm>
+          <a:prstGeom prst="rect">
+            <a:avLst/>
+          </a:prstGeom>
+          <a:noFill/>
+          <a:ln/>
+        </p:spPr>
+        <p:txBody>
+          <a:bodyPr wrap="square" lIns="0" tIns="0" rIns="0" bIns="0" rtlCol="0" anchor="ctr"/>
+          <a:lstStyle/>
+          <a:p>
+            <a:pPr indent="0" marL="0">
+              <a:buNone/>
+            </a:pPr>
+            <a:r>
+              <a:rPr lang="en-US" sz="1200" dirty="0">
+                <a:solidFill>
+                  <a:srgbClr val="8A91B4"/>
+                </a:solidFill>
+                <a:latin typeface="Calibri" pitchFamily="34" charset="0"/>
+                <a:ea typeface="Calibri" pitchFamily="34" charset="-122"/>
+                <a:cs typeface="Calibri" pitchFamily="34" charset="-120"/>
+              </a:rPr>
               <a:t>Zomato · Amazon · Myntra   |   Accessibility Service only   |   Stops at payment and login</a:t>
             </a:r>
             <a:endParaRPr lang="en-US" sz="1200" dirty="0"/>
@@ -2386,7 +2587,7 @@
       </p:sp>
       <p:sp>
         <p:nvSpPr>
-          <p:cNvPr id="11" name="Shape 8"/>
+          <p:cNvPr id="13" name="Shape 10"/>
           <p:cNvSpPr/>
           <p:nvPr/>
         </p:nvSpPr>
@@ -2420,7 +2621,7 @@
       </p:sp>
       <p:pic>
         <p:nvPicPr>
-          <p:cNvPr id="12" name="Image 1" descr="/home/claude/deck/img/learned.png">    </p:cNvPr>
+          <p:cNvPr id="14" name="Image 1" descr="/home/claude/deck/img/learned.png">    </p:cNvPr>
           <p:cNvPicPr>
             <a:picLocks noChangeAspect="1"/>
           </p:cNvPicPr>
@@ -2444,7 +2645,7 @@
       </p:pic>
       <p:sp>
         <p:nvSpPr>
-          <p:cNvPr id="14" name="Text 9"/>
+          <p:cNvPr id="16" name="Text 11"/>
           <p:cNvSpPr txBox="1"/>
           <p:nvPr/>
         </p:nvSpPr>
@@ -2483,7 +2684,7 @@
       </p:sp>
       <p:sp>
         <p:nvSpPr>
-          <p:cNvPr id="15" name="Text 10"/>
+          <p:cNvPr id="17" name="Text 12"/>
           <p:cNvSpPr txBox="1"/>
           <p:nvPr/>
         </p:nvSpPr>
@@ -2585,7 +2786,7 @@
                 <a:ea typeface="Arial" pitchFamily="34" charset="-122"/>
                 <a:cs typeface="Arial" pitchFamily="34" charset="-120"/>
               </a:rPr>
-              <a:t>THEME 3 TEST CASES</a:t>
+              <a:t>NO HARD-CODED FLOWS</a:t>
             </a:r>
             <a:endParaRPr lang="en-US" sz="1200" dirty="0"/>
           </a:p>
@@ -2624,6 +2825,1410 @@
                 <a:ea typeface="Arial" pitchFamily="34" charset="-122"/>
                 <a:cs typeface="Arial" pitchFamily="34" charset="-120"/>
               </a:rPr>
+              <a:t>Taught on an app it had never seen</a:t>
+            </a:r>
+            <a:endParaRPr lang="en-US" sz="3000" dirty="0"/>
+          </a:p>
+        </p:txBody>
+      </p:sp>
+      <p:sp>
+        <p:nvSpPr>
+          <p:cNvPr id="4" name="Shape 2"/>
+          <p:cNvSpPr/>
+          <p:nvPr/>
+        </p:nvSpPr>
+        <p:spPr>
+          <a:xfrm>
+            <a:off x="548640" y="1554480"/>
+            <a:ext cx="4846320" cy="4480560"/>
+          </a:xfrm>
+          <a:prstGeom prst="roundRect">
+            <a:avLst>
+              <a:gd name="adj" fmla="val 2449"/>
+            </a:avLst>
+          </a:prstGeom>
+          <a:solidFill>
+            <a:srgbClr val="F4F5FA"/>
+          </a:solidFill>
+          <a:ln w="12700">
+            <a:solidFill>
+              <a:srgbClr val="F4F5FA"/>
+            </a:solidFill>
+            <a:prstDash val="solid"/>
+          </a:ln>
+        </p:spPr>
+      </p:sp>
+      <p:sp>
+        <p:nvSpPr>
+          <p:cNvPr id="5" name="Text 3"/>
+          <p:cNvSpPr txBox="1"/>
+          <p:nvPr/>
+        </p:nvSpPr>
+        <p:spPr>
+          <a:xfrm>
+            <a:off x="822960" y="1755648"/>
+            <a:ext cx="4389120" cy="274320"/>
+          </a:xfrm>
+          <a:prstGeom prst="rect">
+            <a:avLst/>
+          </a:prstGeom>
+          <a:noFill/>
+          <a:ln/>
+        </p:spPr>
+        <p:txBody>
+          <a:bodyPr wrap="square" lIns="0" tIns="0" rIns="0" bIns="0" rtlCol="0" anchor="ctr"/>
+          <a:lstStyle/>
+          <a:p>
+            <a:pPr indent="0" marL="0">
+              <a:buNone/>
+            </a:pPr>
+            <a:r>
+              <a:rPr lang="en-US" sz="1100" b="1" spc="200" kern="0" dirty="0">
+                <a:solidFill>
+                  <a:srgbClr val="5C637A"/>
+                </a:solidFill>
+                <a:latin typeface="Arial" pitchFamily="34" charset="0"/>
+                <a:ea typeface="Arial" pitchFamily="34" charset="-122"/>
+                <a:cs typeface="Arial" pitchFamily="34" charset="-120"/>
+              </a:rPr>
+              <a:t>TAUGHT ONCE, BY TAPPING THROUGH IT</a:t>
+            </a:r>
+            <a:endParaRPr lang="en-US" sz="1100" dirty="0"/>
+          </a:p>
+        </p:txBody>
+      </p:sp>
+      <p:sp>
+        <p:nvSpPr>
+          <p:cNvPr id="6" name="Shape 4"/>
+          <p:cNvSpPr/>
+          <p:nvPr/>
+        </p:nvSpPr>
+        <p:spPr>
+          <a:xfrm>
+            <a:off x="822960" y="2103120"/>
+            <a:ext cx="4297680" cy="502920"/>
+          </a:xfrm>
+          <a:prstGeom prst="roundRect">
+            <a:avLst>
+              <a:gd name="adj" fmla="val 50000"/>
+            </a:avLst>
+          </a:prstGeom>
+          <a:solidFill>
+            <a:srgbClr val="121833"/>
+          </a:solidFill>
+          <a:ln w="12700">
+            <a:solidFill>
+              <a:srgbClr val="121833"/>
+            </a:solidFill>
+            <a:prstDash val="solid"/>
+          </a:ln>
+        </p:spPr>
+      </p:sp>
+      <p:sp>
+        <p:nvSpPr>
+          <p:cNvPr id="7" name="Shape 5"/>
+          <p:cNvSpPr/>
+          <p:nvPr/>
+        </p:nvSpPr>
+        <p:spPr>
+          <a:xfrm>
+            <a:off x="886968" y="2167128"/>
+            <a:ext cx="374904" cy="374904"/>
+          </a:xfrm>
+          <a:prstGeom prst="ellipse">
+            <a:avLst/>
+          </a:prstGeom>
+          <a:solidFill>
+            <a:srgbClr val="FF5B3A"/>
+          </a:solidFill>
+          <a:ln w="12700">
+            <a:solidFill>
+              <a:srgbClr val="FF5B3A"/>
+            </a:solidFill>
+            <a:prstDash val="solid"/>
+          </a:ln>
+        </p:spPr>
+      </p:sp>
+      <p:pic>
+        <p:nvPicPr>
+          <p:cNvPr id="8" name="Image 0" descr="preencoded.png">    </p:cNvPr>
+          <p:cNvPicPr>
+            <a:picLocks noChangeAspect="1"/>
+          </p:cNvPicPr>
+          <p:nvPr/>
+        </p:nvPicPr>
+        <p:blipFill>
+          <a:blip r:embed="rId1"/>
+          <a:stretch>
+            <a:fillRect/>
+          </a:stretch>
+        </p:blipFill>
+        <p:spPr>
+          <a:xfrm>
+            <a:off x="961949" y="2242109"/>
+            <a:ext cx="224942" cy="224942"/>
+          </a:xfrm>
+          <a:prstGeom prst="rect">
+            <a:avLst/>
+          </a:prstGeom>
+        </p:spPr>
+      </p:pic>
+      <p:sp>
+        <p:nvSpPr>
+          <p:cNvPr id="9" name="Text 6"/>
+          <p:cNvSpPr txBox="1"/>
+          <p:nvPr/>
+        </p:nvSpPr>
+        <p:spPr>
+          <a:xfrm>
+            <a:off x="1380744" y="2103120"/>
+            <a:ext cx="3648456" cy="502920"/>
+          </a:xfrm>
+          <a:prstGeom prst="rect">
+            <a:avLst/>
+          </a:prstGeom>
+          <a:noFill/>
+          <a:ln/>
+        </p:spPr>
+        <p:txBody>
+          <a:bodyPr wrap="square" lIns="0" tIns="0" rIns="0" bIns="0" rtlCol="0" anchor="ctr">
+            <a:normAutofit/>
+          </a:bodyPr>
+          <a:lstStyle/>
+          <a:p>
+            <a:pPr indent="0" marL="0">
+              <a:buNone/>
+            </a:pPr>
+            <a:r>
+              <a:rPr lang="en-US" sz="1400" i="1" dirty="0">
+                <a:solidFill>
+                  <a:srgbClr val="FFFFFF"/>
+                </a:solidFill>
+                <a:latin typeface="Calibri" pitchFamily="34" charset="0"/>
+                <a:ea typeface="Calibri" pitchFamily="34" charset="-122"/>
+                <a:cs typeface="Calibri" pitchFamily="34" charset="-120"/>
+              </a:rPr>
+              <a:t>“Open the pytorch repository on GitHub”</a:t>
+            </a:r>
+            <a:endParaRPr lang="en-US" sz="1400" dirty="0"/>
+          </a:p>
+        </p:txBody>
+      </p:sp>
+      <p:sp>
+        <p:nvSpPr>
+          <p:cNvPr id="10" name="Text 7"/>
+          <p:cNvSpPr txBox="1"/>
+          <p:nvPr/>
+        </p:nvSpPr>
+        <p:spPr>
+          <a:xfrm>
+            <a:off x="822960" y="2880360"/>
+            <a:ext cx="4297680" cy="320040"/>
+          </a:xfrm>
+          <a:prstGeom prst="rect">
+            <a:avLst/>
+          </a:prstGeom>
+          <a:noFill/>
+          <a:ln/>
+        </p:spPr>
+        <p:txBody>
+          <a:bodyPr wrap="square" lIns="0" tIns="0" rIns="0" bIns="0" rtlCol="0" anchor="ctr"/>
+          <a:lstStyle/>
+          <a:p>
+            <a:pPr indent="0" marL="0">
+              <a:buNone/>
+            </a:pPr>
+            <a:r>
+              <a:rPr lang="en-US" sz="1300" b="1" dirty="0">
+                <a:solidFill>
+                  <a:srgbClr val="5C637A"/>
+                </a:solidFill>
+                <a:latin typeface="Arial" pitchFamily="34" charset="0"/>
+                <a:ea typeface="Arial" pitchFamily="34" charset="-122"/>
+                <a:cs typeface="Arial" pitchFamily="34" charset="-120"/>
+              </a:rPr>
+              <a:t>What it learned</a:t>
+            </a:r>
+            <a:endParaRPr lang="en-US" sz="1300" dirty="0"/>
+          </a:p>
+        </p:txBody>
+      </p:sp>
+      <p:sp>
+        <p:nvSpPr>
+          <p:cNvPr id="11" name="Text 8"/>
+          <p:cNvSpPr txBox="1"/>
+          <p:nvPr/>
+        </p:nvSpPr>
+        <p:spPr>
+          <a:xfrm>
+            <a:off x="822960" y="3200400"/>
+            <a:ext cx="4389120" cy="411480"/>
+          </a:xfrm>
+          <a:prstGeom prst="rect">
+            <a:avLst/>
+          </a:prstGeom>
+          <a:noFill/>
+          <a:ln/>
+        </p:spPr>
+        <p:txBody>
+          <a:bodyPr wrap="square" lIns="0" tIns="0" rIns="0" bIns="0" rtlCol="0" anchor="ctr"/>
+          <a:lstStyle/>
+          <a:p>
+            <a:pPr indent="0" marL="0">
+              <a:buNone/>
+            </a:pPr>
+            <a:r>
+              <a:rPr lang="en-US" sz="1700" b="1" dirty="0">
+                <a:solidFill>
+                  <a:srgbClr val="1A1F36"/>
+                </a:solidFill>
+                <a:latin typeface="Arial" pitchFamily="34" charset="0"/>
+                <a:ea typeface="Arial" pitchFamily="34" charset="-122"/>
+                <a:cs typeface="Arial" pitchFamily="34" charset="-120"/>
+              </a:rPr>
+              <a:t>Open </a:t>
+            </a:r>
+            <a:pPr indent="0" marL="0">
+              <a:buNone/>
+            </a:pPr>
+            <a:r>
+              <a:rPr lang="en-US" sz="1700" b="1" dirty="0">
+                <a:solidFill>
+                  <a:srgbClr val="FF5B3A"/>
+                </a:solidFill>
+                <a:latin typeface="Arial" pitchFamily="34" charset="0"/>
+                <a:ea typeface="Arial" pitchFamily="34" charset="-122"/>
+                <a:cs typeface="Arial" pitchFamily="34" charset="-120"/>
+              </a:rPr>
+              <a:t>{repository}</a:t>
+            </a:r>
+            <a:pPr indent="0" marL="0">
+              <a:buNone/>
+            </a:pPr>
+            <a:r>
+              <a:rPr lang="en-US" sz="1700" b="1" dirty="0">
+                <a:solidFill>
+                  <a:srgbClr val="1A1F36"/>
+                </a:solidFill>
+                <a:latin typeface="Arial" pitchFamily="34" charset="0"/>
+                <a:ea typeface="Arial" pitchFamily="34" charset="-122"/>
+                <a:cs typeface="Arial" pitchFamily="34" charset="-120"/>
+              </a:rPr>
+              <a:t> repository on GitHub</a:t>
+            </a:r>
+            <a:endParaRPr lang="en-US" sz="1700" dirty="0"/>
+          </a:p>
+        </p:txBody>
+      </p:sp>
+      <p:sp>
+        <p:nvSpPr>
+          <p:cNvPr id="12" name="Text 9"/>
+          <p:cNvSpPr txBox="1"/>
+          <p:nvPr/>
+        </p:nvSpPr>
+        <p:spPr>
+          <a:xfrm>
+            <a:off x="822960" y="3703320"/>
+            <a:ext cx="4389120" cy="1691640"/>
+          </a:xfrm>
+          <a:prstGeom prst="rect">
+            <a:avLst/>
+          </a:prstGeom>
+          <a:noFill/>
+          <a:ln/>
+        </p:spPr>
+        <p:txBody>
+          <a:bodyPr wrap="square" lIns="0" tIns="0" rIns="0" bIns="0" rtlCol="0" anchor="t"/>
+          <a:lstStyle/>
+          <a:p>
+            <a:pPr indent="0" marL="0">
+              <a:spcAft>
+                <a:spcPts val="700"/>
+              </a:spcAft>
+              <a:buNone/>
+            </a:pPr>
+            <a:r>
+              <a:rPr lang="en-US" sz="1450" b="1" dirty="0">
+                <a:solidFill>
+                  <a:srgbClr val="0E9F8A"/>
+                </a:solidFill>
+                <a:latin typeface="Calibri" pitchFamily="34" charset="0"/>
+                <a:ea typeface="Calibri" pitchFamily="34" charset="-122"/>
+                <a:cs typeface="Calibri" pitchFamily="34" charset="-120"/>
+              </a:rPr>
+              <a:t>1   </a:t>
+            </a:r>
+            <a:pPr indent="0" marL="0">
+              <a:spcAft>
+                <a:spcPts val="700"/>
+              </a:spcAft>
+              <a:buNone/>
+            </a:pPr>
+            <a:r>
+              <a:rPr lang="en-US" sz="1450" dirty="0">
+                <a:solidFill>
+                  <a:srgbClr val="1A1F36"/>
+                </a:solidFill>
+                <a:latin typeface="Calibri" pitchFamily="34" charset="0"/>
+                <a:ea typeface="Calibri" pitchFamily="34" charset="-122"/>
+                <a:cs typeface="Calibri" pitchFamily="34" charset="-120"/>
+              </a:rPr>
+              <a:t>Launch GitHub</a:t>
+            </a:r>
+            <a:endParaRPr lang="en-US" sz="1450" dirty="0"/>
+          </a:p>
+          <a:p>
+            <a:pPr indent="0" marL="0">
+              <a:spcAft>
+                <a:spcPts val="700"/>
+              </a:spcAft>
+              <a:buNone/>
+            </a:pPr>
+            <a:r>
+              <a:rPr lang="en-US" sz="1450" b="1" dirty="0">
+                <a:solidFill>
+                  <a:srgbClr val="0E9F8A"/>
+                </a:solidFill>
+                <a:latin typeface="Calibri" pitchFamily="34" charset="0"/>
+                <a:ea typeface="Calibri" pitchFamily="34" charset="-122"/>
+                <a:cs typeface="Calibri" pitchFamily="34" charset="-120"/>
+              </a:rPr>
+              <a:t>2   </a:t>
+            </a:r>
+            <a:pPr indent="0" marL="0">
+              <a:spcAft>
+                <a:spcPts val="700"/>
+              </a:spcAft>
+              <a:buNone/>
+            </a:pPr>
+            <a:r>
+              <a:rPr lang="en-US" sz="1450" dirty="0">
+                <a:solidFill>
+                  <a:srgbClr val="1A1F36"/>
+                </a:solidFill>
+                <a:latin typeface="Calibri" pitchFamily="34" charset="0"/>
+                <a:ea typeface="Calibri" pitchFamily="34" charset="-122"/>
+                <a:cs typeface="Calibri" pitchFamily="34" charset="-120"/>
+              </a:rPr>
+              <a:t>Open search</a:t>
+            </a:r>
+            <a:endParaRPr lang="en-US" sz="1450" dirty="0"/>
+          </a:p>
+          <a:p>
+            <a:pPr indent="0" marL="0">
+              <a:spcAft>
+                <a:spcPts val="700"/>
+              </a:spcAft>
+              <a:buNone/>
+            </a:pPr>
+            <a:r>
+              <a:rPr lang="en-US" sz="1450" b="1" dirty="0">
+                <a:solidFill>
+                  <a:srgbClr val="0E9F8A"/>
+                </a:solidFill>
+                <a:latin typeface="Calibri" pitchFamily="34" charset="0"/>
+                <a:ea typeface="Calibri" pitchFamily="34" charset="-122"/>
+                <a:cs typeface="Calibri" pitchFamily="34" charset="-120"/>
+              </a:rPr>
+              <a:t>3   </a:t>
+            </a:r>
+            <a:pPr indent="0" marL="0">
+              <a:spcAft>
+                <a:spcPts val="700"/>
+              </a:spcAft>
+              <a:buNone/>
+            </a:pPr>
+            <a:r>
+              <a:rPr lang="en-US" sz="1450" dirty="0">
+                <a:solidFill>
+                  <a:srgbClr val="1A1F36"/>
+                </a:solidFill>
+                <a:latin typeface="Calibri" pitchFamily="34" charset="0"/>
+                <a:ea typeface="Calibri" pitchFamily="34" charset="-122"/>
+                <a:cs typeface="Calibri" pitchFamily="34" charset="-120"/>
+              </a:rPr>
+              <a:t>Enter </a:t>
+            </a:r>
+            <a:pPr indent="0" marL="0">
+              <a:spcAft>
+                <a:spcPts val="700"/>
+              </a:spcAft>
+              <a:buNone/>
+            </a:pPr>
+            <a:r>
+              <a:rPr lang="en-US" sz="1450" b="1" dirty="0">
+                <a:solidFill>
+                  <a:srgbClr val="FF5B3A"/>
+                </a:solidFill>
+                <a:latin typeface="Calibri" pitchFamily="34" charset="0"/>
+                <a:ea typeface="Calibri" pitchFamily="34" charset="-122"/>
+                <a:cs typeface="Calibri" pitchFamily="34" charset="-120"/>
+              </a:rPr>
+              <a:t>{repository}</a:t>
+            </a:r>
+            <a:endParaRPr lang="en-US" sz="1450" dirty="0"/>
+          </a:p>
+          <a:p>
+            <a:pPr indent="0" marL="0">
+              <a:spcAft>
+                <a:spcPts val="700"/>
+              </a:spcAft>
+              <a:buNone/>
+            </a:pPr>
+            <a:r>
+              <a:rPr lang="en-US" sz="1450" b="1" dirty="0">
+                <a:solidFill>
+                  <a:srgbClr val="0E9F8A"/>
+                </a:solidFill>
+                <a:latin typeface="Calibri" pitchFamily="34" charset="0"/>
+                <a:ea typeface="Calibri" pitchFamily="34" charset="-122"/>
+                <a:cs typeface="Calibri" pitchFamily="34" charset="-120"/>
+              </a:rPr>
+              <a:t>4   </a:t>
+            </a:r>
+            <a:pPr indent="0" marL="0">
+              <a:spcAft>
+                <a:spcPts val="700"/>
+              </a:spcAft>
+              <a:buNone/>
+            </a:pPr>
+            <a:r>
+              <a:rPr lang="en-US" sz="1450" dirty="0">
+                <a:solidFill>
+                  <a:srgbClr val="1A1F36"/>
+                </a:solidFill>
+                <a:latin typeface="Calibri" pitchFamily="34" charset="0"/>
+                <a:ea typeface="Calibri" pitchFamily="34" charset="-122"/>
+                <a:cs typeface="Calibri" pitchFamily="34" charset="-120"/>
+              </a:rPr>
+              <a:t>Select </a:t>
+            </a:r>
+            <a:pPr indent="0" marL="0">
+              <a:spcAft>
+                <a:spcPts val="700"/>
+              </a:spcAft>
+              <a:buNone/>
+            </a:pPr>
+            <a:r>
+              <a:rPr lang="en-US" sz="1450" b="1" dirty="0">
+                <a:solidFill>
+                  <a:srgbClr val="FF5B3A"/>
+                </a:solidFill>
+                <a:latin typeface="Calibri" pitchFamily="34" charset="0"/>
+                <a:ea typeface="Calibri" pitchFamily="34" charset="-122"/>
+                <a:cs typeface="Calibri" pitchFamily="34" charset="-120"/>
+              </a:rPr>
+              <a:t>{repository}</a:t>
+            </a:r>
+            <a:pPr indent="0" marL="0">
+              <a:spcAft>
+                <a:spcPts val="700"/>
+              </a:spcAft>
+              <a:buNone/>
+            </a:pPr>
+            <a:r>
+              <a:rPr lang="en-US" sz="1450" dirty="0">
+                <a:solidFill>
+                  <a:srgbClr val="1A1F36"/>
+                </a:solidFill>
+                <a:latin typeface="Calibri" pitchFamily="34" charset="0"/>
+                <a:ea typeface="Calibri" pitchFamily="34" charset="-122"/>
+                <a:cs typeface="Calibri" pitchFamily="34" charset="-120"/>
+              </a:rPr>
+              <a:t> in the results</a:t>
+            </a:r>
+            <a:endParaRPr lang="en-US" sz="1450" dirty="0"/>
+          </a:p>
+          <a:p>
+            <a:pPr indent="0" marL="0">
+              <a:spcAft>
+                <a:spcPts val="700"/>
+              </a:spcAft>
+              <a:buNone/>
+            </a:pPr>
+            <a:r>
+              <a:rPr lang="en-US" sz="1450" b="1" dirty="0">
+                <a:solidFill>
+                  <a:srgbClr val="0E9F8A"/>
+                </a:solidFill>
+                <a:latin typeface="Calibri" pitchFamily="34" charset="0"/>
+                <a:ea typeface="Calibri" pitchFamily="34" charset="-122"/>
+                <a:cs typeface="Calibri" pitchFamily="34" charset="-120"/>
+              </a:rPr>
+              <a:t>5   </a:t>
+            </a:r>
+            <a:pPr indent="0" marL="0">
+              <a:spcAft>
+                <a:spcPts val="700"/>
+              </a:spcAft>
+              <a:buNone/>
+            </a:pPr>
+            <a:r>
+              <a:rPr lang="en-US" sz="1450" dirty="0">
+                <a:solidFill>
+                  <a:srgbClr val="1A1F36"/>
+                </a:solidFill>
+                <a:latin typeface="Calibri" pitchFamily="34" charset="0"/>
+                <a:ea typeface="Calibri" pitchFamily="34" charset="-122"/>
+                <a:cs typeface="Calibri" pitchFamily="34" charset="-120"/>
+              </a:rPr>
+              <a:t>Open the repository</a:t>
+            </a:r>
+            <a:endParaRPr lang="en-US" sz="1450" dirty="0"/>
+          </a:p>
+        </p:txBody>
+      </p:sp>
+      <p:pic>
+        <p:nvPicPr>
+          <p:cNvPr id="13" name="Image 1" descr="preencoded.png">    </p:cNvPr>
+          <p:cNvPicPr>
+            <a:picLocks noChangeAspect="1"/>
+          </p:cNvPicPr>
+          <p:nvPr/>
+        </p:nvPicPr>
+        <p:blipFill>
+          <a:blip r:embed="rId2"/>
+          <a:stretch>
+            <a:fillRect/>
+          </a:stretch>
+        </p:blipFill>
+        <p:spPr>
+          <a:xfrm>
+            <a:off x="822960" y="5458968"/>
+            <a:ext cx="256032" cy="256032"/>
+          </a:xfrm>
+          <a:prstGeom prst="rect">
+            <a:avLst/>
+          </a:prstGeom>
+        </p:spPr>
+      </p:pic>
+      <p:sp>
+        <p:nvSpPr>
+          <p:cNvPr id="14" name="Text 10"/>
+          <p:cNvSpPr txBox="1"/>
+          <p:nvPr/>
+        </p:nvSpPr>
+        <p:spPr>
+          <a:xfrm>
+            <a:off x="1188720" y="5367528"/>
+            <a:ext cx="4023360" cy="457200"/>
+          </a:xfrm>
+          <a:prstGeom prst="rect">
+            <a:avLst/>
+          </a:prstGeom>
+          <a:noFill/>
+          <a:ln/>
+        </p:spPr>
+        <p:txBody>
+          <a:bodyPr wrap="square" lIns="0" tIns="0" rIns="0" bIns="0" rtlCol="0" anchor="ctr"/>
+          <a:lstStyle/>
+          <a:p>
+            <a:pPr indent="0" marL="0">
+              <a:buNone/>
+            </a:pPr>
+            <a:r>
+              <a:rPr lang="en-US" sz="1250" dirty="0">
+                <a:solidFill>
+                  <a:srgbClr val="5C637A"/>
+                </a:solidFill>
+                <a:latin typeface="Calibri" pitchFamily="34" charset="0"/>
+                <a:ea typeface="Calibri" pitchFamily="34" charset="-122"/>
+                <a:cs typeface="Calibri" pitchFamily="34" charset="-120"/>
+              </a:rPr>
+              <a:t>“pytorch” was typed in the demo, so the repository name became a slot on its own.</a:t>
+            </a:r>
+            <a:endParaRPr lang="en-US" sz="1250" dirty="0"/>
+          </a:p>
+        </p:txBody>
+      </p:sp>
+      <p:sp>
+        <p:nvSpPr>
+          <p:cNvPr id="15" name="Shape 11"/>
+          <p:cNvSpPr/>
+          <p:nvPr/>
+        </p:nvSpPr>
+        <p:spPr>
+          <a:xfrm>
+            <a:off x="5669280" y="1554480"/>
+            <a:ext cx="5971032" cy="502920"/>
+          </a:xfrm>
+          <a:prstGeom prst="roundRect">
+            <a:avLst>
+              <a:gd name="adj" fmla="val 50000"/>
+            </a:avLst>
+          </a:prstGeom>
+          <a:solidFill>
+            <a:srgbClr val="121833"/>
+          </a:solidFill>
+          <a:ln w="12700">
+            <a:solidFill>
+              <a:srgbClr val="121833"/>
+            </a:solidFill>
+            <a:prstDash val="solid"/>
+          </a:ln>
+        </p:spPr>
+      </p:sp>
+      <p:sp>
+        <p:nvSpPr>
+          <p:cNvPr id="16" name="Shape 12"/>
+          <p:cNvSpPr/>
+          <p:nvPr/>
+        </p:nvSpPr>
+        <p:spPr>
+          <a:xfrm>
+            <a:off x="5733288" y="1618488"/>
+            <a:ext cx="374904" cy="374904"/>
+          </a:xfrm>
+          <a:prstGeom prst="ellipse">
+            <a:avLst/>
+          </a:prstGeom>
+          <a:solidFill>
+            <a:srgbClr val="FF5B3A"/>
+          </a:solidFill>
+          <a:ln w="12700">
+            <a:solidFill>
+              <a:srgbClr val="FF5B3A"/>
+            </a:solidFill>
+            <a:prstDash val="solid"/>
+          </a:ln>
+        </p:spPr>
+      </p:sp>
+      <p:pic>
+        <p:nvPicPr>
+          <p:cNvPr id="17" name="Image 2" descr="preencoded.png">    </p:cNvPr>
+          <p:cNvPicPr>
+            <a:picLocks noChangeAspect="1"/>
+          </p:cNvPicPr>
+          <p:nvPr/>
+        </p:nvPicPr>
+        <p:blipFill>
+          <a:blip r:embed="rId3"/>
+          <a:stretch>
+            <a:fillRect/>
+          </a:stretch>
+        </p:blipFill>
+        <p:spPr>
+          <a:xfrm>
+            <a:off x="5808269" y="1693469"/>
+            <a:ext cx="224942" cy="224942"/>
+          </a:xfrm>
+          <a:prstGeom prst="rect">
+            <a:avLst/>
+          </a:prstGeom>
+        </p:spPr>
+      </p:pic>
+      <p:sp>
+        <p:nvSpPr>
+          <p:cNvPr id="18" name="Text 13"/>
+          <p:cNvSpPr txBox="1"/>
+          <p:nvPr/>
+        </p:nvSpPr>
+        <p:spPr>
+          <a:xfrm>
+            <a:off x="6227064" y="1554480"/>
+            <a:ext cx="5321808" cy="502920"/>
+          </a:xfrm>
+          <a:prstGeom prst="rect">
+            <a:avLst/>
+          </a:prstGeom>
+          <a:noFill/>
+          <a:ln/>
+        </p:spPr>
+        <p:txBody>
+          <a:bodyPr wrap="square" lIns="0" tIns="0" rIns="0" bIns="0" rtlCol="0" anchor="ctr">
+            <a:normAutofit/>
+          </a:bodyPr>
+          <a:lstStyle/>
+          <a:p>
+            <a:pPr indent="0" marL="0">
+              <a:buNone/>
+            </a:pPr>
+            <a:r>
+              <a:rPr lang="en-US" sz="1400" i="1" dirty="0">
+                <a:solidFill>
+                  <a:srgbClr val="FFFFFF"/>
+                </a:solidFill>
+                <a:latin typeface="Calibri" pitchFamily="34" charset="0"/>
+                <a:ea typeface="Calibri" pitchFamily="34" charset="-122"/>
+                <a:cs typeface="Calibri" pitchFamily="34" charset="-120"/>
+              </a:rPr>
+              <a:t>“Open the tensorflow repository on GitHub”</a:t>
+            </a:r>
+            <a:endParaRPr lang="en-US" sz="1400" dirty="0"/>
+          </a:p>
+        </p:txBody>
+      </p:sp>
+      <p:pic>
+        <p:nvPicPr>
+          <p:cNvPr id="19" name="Image 3" descr="preencoded.png">    </p:cNvPr>
+          <p:cNvPicPr>
+            <a:picLocks noChangeAspect="1"/>
+          </p:cNvPicPr>
+          <p:nvPr/>
+        </p:nvPicPr>
+        <p:blipFill>
+          <a:blip r:embed="rId4"/>
+          <a:stretch>
+            <a:fillRect/>
+          </a:stretch>
+        </p:blipFill>
+        <p:spPr>
+          <a:xfrm>
+            <a:off x="5760720" y="2194560"/>
+            <a:ext cx="256032" cy="256032"/>
+          </a:xfrm>
+          <a:prstGeom prst="rect">
+            <a:avLst/>
+          </a:prstGeom>
+        </p:spPr>
+      </p:pic>
+      <p:sp>
+        <p:nvSpPr>
+          <p:cNvPr id="20" name="Text 14"/>
+          <p:cNvSpPr txBox="1"/>
+          <p:nvPr/>
+        </p:nvSpPr>
+        <p:spPr>
+          <a:xfrm>
+            <a:off x="6126480" y="2157984"/>
+            <a:ext cx="5486400" cy="329184"/>
+          </a:xfrm>
+          <a:prstGeom prst="rect">
+            <a:avLst/>
+          </a:prstGeom>
+          <a:noFill/>
+          <a:ln/>
+        </p:spPr>
+        <p:txBody>
+          <a:bodyPr wrap="square" lIns="0" tIns="0" rIns="0" bIns="0" rtlCol="0" anchor="ctr"/>
+          <a:lstStyle/>
+          <a:p>
+            <a:pPr indent="0" marL="0">
+              <a:buNone/>
+            </a:pPr>
+            <a:r>
+              <a:rPr lang="en-US" sz="1400" dirty="0">
+                <a:solidFill>
+                  <a:srgbClr val="1A1F36"/>
+                </a:solidFill>
+                <a:latin typeface="Calibri" pitchFamily="34" charset="0"/>
+                <a:ea typeface="Calibri" pitchFamily="34" charset="-122"/>
+                <a:cs typeface="Calibri" pitchFamily="34" charset="-120"/>
+              </a:rPr>
+              <a:t>tensorflow/tensorflow opened · 18 s · no LLM calls</a:t>
+            </a:r>
+            <a:endParaRPr lang="en-US" sz="1400" dirty="0"/>
+          </a:p>
+        </p:txBody>
+      </p:sp>
+      <p:sp>
+        <p:nvSpPr>
+          <p:cNvPr id="21" name="Shape 15"/>
+          <p:cNvSpPr/>
+          <p:nvPr/>
+        </p:nvSpPr>
+        <p:spPr>
+          <a:xfrm>
+            <a:off x="5669280" y="2670048"/>
+            <a:ext cx="5971032" cy="502920"/>
+          </a:xfrm>
+          <a:prstGeom prst="roundRect">
+            <a:avLst>
+              <a:gd name="adj" fmla="val 50000"/>
+            </a:avLst>
+          </a:prstGeom>
+          <a:solidFill>
+            <a:srgbClr val="121833"/>
+          </a:solidFill>
+          <a:ln w="12700">
+            <a:solidFill>
+              <a:srgbClr val="121833"/>
+            </a:solidFill>
+            <a:prstDash val="solid"/>
+          </a:ln>
+        </p:spPr>
+      </p:sp>
+      <p:sp>
+        <p:nvSpPr>
+          <p:cNvPr id="22" name="Shape 16"/>
+          <p:cNvSpPr/>
+          <p:nvPr/>
+        </p:nvSpPr>
+        <p:spPr>
+          <a:xfrm>
+            <a:off x="5733288" y="2734056"/>
+            <a:ext cx="374904" cy="374904"/>
+          </a:xfrm>
+          <a:prstGeom prst="ellipse">
+            <a:avLst/>
+          </a:prstGeom>
+          <a:solidFill>
+            <a:srgbClr val="FF5B3A"/>
+          </a:solidFill>
+          <a:ln w="12700">
+            <a:solidFill>
+              <a:srgbClr val="FF5B3A"/>
+            </a:solidFill>
+            <a:prstDash val="solid"/>
+          </a:ln>
+        </p:spPr>
+      </p:sp>
+      <p:pic>
+        <p:nvPicPr>
+          <p:cNvPr id="23" name="Image 4" descr="preencoded.png">    </p:cNvPr>
+          <p:cNvPicPr>
+            <a:picLocks noChangeAspect="1"/>
+          </p:cNvPicPr>
+          <p:nvPr/>
+        </p:nvPicPr>
+        <p:blipFill>
+          <a:blip r:embed="rId5"/>
+          <a:stretch>
+            <a:fillRect/>
+          </a:stretch>
+        </p:blipFill>
+        <p:spPr>
+          <a:xfrm>
+            <a:off x="5808269" y="2809037"/>
+            <a:ext cx="224942" cy="224942"/>
+          </a:xfrm>
+          <a:prstGeom prst="rect">
+            <a:avLst/>
+          </a:prstGeom>
+        </p:spPr>
+      </p:pic>
+      <p:sp>
+        <p:nvSpPr>
+          <p:cNvPr id="24" name="Text 17"/>
+          <p:cNvSpPr txBox="1"/>
+          <p:nvPr/>
+        </p:nvSpPr>
+        <p:spPr>
+          <a:xfrm>
+            <a:off x="6227064" y="2670048"/>
+            <a:ext cx="5321808" cy="502920"/>
+          </a:xfrm>
+          <a:prstGeom prst="rect">
+            <a:avLst/>
+          </a:prstGeom>
+          <a:noFill/>
+          <a:ln/>
+        </p:spPr>
+        <p:txBody>
+          <a:bodyPr wrap="square" lIns="0" tIns="0" rIns="0" bIns="0" rtlCol="0" anchor="ctr">
+            <a:normAutofit/>
+          </a:bodyPr>
+          <a:lstStyle/>
+          <a:p>
+            <a:pPr indent="0" marL="0">
+              <a:buNone/>
+            </a:pPr>
+            <a:r>
+              <a:rPr lang="en-US" sz="1400" i="1" dirty="0">
+                <a:solidFill>
+                  <a:srgbClr val="FFFFFF"/>
+                </a:solidFill>
+                <a:latin typeface="Calibri" pitchFamily="34" charset="0"/>
+                <a:ea typeface="Calibri" pitchFamily="34" charset="-122"/>
+                <a:cs typeface="Calibri" pitchFamily="34" charset="-120"/>
+              </a:rPr>
+              <a:t>“open the linux repository on github”</a:t>
+            </a:r>
+            <a:endParaRPr lang="en-US" sz="1400" dirty="0"/>
+          </a:p>
+        </p:txBody>
+      </p:sp>
+      <p:pic>
+        <p:nvPicPr>
+          <p:cNvPr id="25" name="Image 5" descr="preencoded.png">    </p:cNvPr>
+          <p:cNvPicPr>
+            <a:picLocks noChangeAspect="1"/>
+          </p:cNvPicPr>
+          <p:nvPr/>
+        </p:nvPicPr>
+        <p:blipFill>
+          <a:blip r:embed="rId6"/>
+          <a:stretch>
+            <a:fillRect/>
+          </a:stretch>
+        </p:blipFill>
+        <p:spPr>
+          <a:xfrm>
+            <a:off x="5760720" y="3310128"/>
+            <a:ext cx="256032" cy="256032"/>
+          </a:xfrm>
+          <a:prstGeom prst="rect">
+            <a:avLst/>
+          </a:prstGeom>
+        </p:spPr>
+      </p:pic>
+      <p:sp>
+        <p:nvSpPr>
+          <p:cNvPr id="26" name="Text 18"/>
+          <p:cNvSpPr txBox="1"/>
+          <p:nvPr/>
+        </p:nvSpPr>
+        <p:spPr>
+          <a:xfrm>
+            <a:off x="6126480" y="3273552"/>
+            <a:ext cx="5486400" cy="329184"/>
+          </a:xfrm>
+          <a:prstGeom prst="rect">
+            <a:avLst/>
+          </a:prstGeom>
+          <a:noFill/>
+          <a:ln/>
+        </p:spPr>
+        <p:txBody>
+          <a:bodyPr wrap="square" lIns="0" tIns="0" rIns="0" bIns="0" rtlCol="0" anchor="ctr"/>
+          <a:lstStyle/>
+          <a:p>
+            <a:pPr indent="0" marL="0">
+              <a:buNone/>
+            </a:pPr>
+            <a:r>
+              <a:rPr lang="en-US" sz="1400" dirty="0">
+                <a:solidFill>
+                  <a:srgbClr val="1A1F36"/>
+                </a:solidFill>
+                <a:latin typeface="Calibri" pitchFamily="34" charset="0"/>
+                <a:ea typeface="Calibri" pitchFamily="34" charset="-122"/>
+                <a:cs typeface="Calibri" pitchFamily="34" charset="-120"/>
+              </a:rPr>
+              <a:t>torvalds/linux opened · 17 s · no LLM calls</a:t>
+            </a:r>
+            <a:endParaRPr lang="en-US" sz="1400" dirty="0"/>
+          </a:p>
+        </p:txBody>
+      </p:sp>
+      <p:sp>
+        <p:nvSpPr>
+          <p:cNvPr id="27" name="Shape 19"/>
+          <p:cNvSpPr/>
+          <p:nvPr/>
+        </p:nvSpPr>
+        <p:spPr>
+          <a:xfrm>
+            <a:off x="5669280" y="3785616"/>
+            <a:ext cx="5971032" cy="502920"/>
+          </a:xfrm>
+          <a:prstGeom prst="roundRect">
+            <a:avLst>
+              <a:gd name="adj" fmla="val 50000"/>
+            </a:avLst>
+          </a:prstGeom>
+          <a:solidFill>
+            <a:srgbClr val="121833"/>
+          </a:solidFill>
+          <a:ln w="12700">
+            <a:solidFill>
+              <a:srgbClr val="121833"/>
+            </a:solidFill>
+            <a:prstDash val="solid"/>
+          </a:ln>
+        </p:spPr>
+      </p:sp>
+      <p:sp>
+        <p:nvSpPr>
+          <p:cNvPr id="28" name="Shape 20"/>
+          <p:cNvSpPr/>
+          <p:nvPr/>
+        </p:nvSpPr>
+        <p:spPr>
+          <a:xfrm>
+            <a:off x="5733288" y="3849624"/>
+            <a:ext cx="374904" cy="374904"/>
+          </a:xfrm>
+          <a:prstGeom prst="ellipse">
+            <a:avLst/>
+          </a:prstGeom>
+          <a:solidFill>
+            <a:srgbClr val="FF5B3A"/>
+          </a:solidFill>
+          <a:ln w="12700">
+            <a:solidFill>
+              <a:srgbClr val="FF5B3A"/>
+            </a:solidFill>
+            <a:prstDash val="solid"/>
+          </a:ln>
+        </p:spPr>
+      </p:sp>
+      <p:pic>
+        <p:nvPicPr>
+          <p:cNvPr id="29" name="Image 6" descr="preencoded.png">    </p:cNvPr>
+          <p:cNvPicPr>
+            <a:picLocks noChangeAspect="1"/>
+          </p:cNvPicPr>
+          <p:nvPr/>
+        </p:nvPicPr>
+        <p:blipFill>
+          <a:blip r:embed="rId7"/>
+          <a:stretch>
+            <a:fillRect/>
+          </a:stretch>
+        </p:blipFill>
+        <p:spPr>
+          <a:xfrm>
+            <a:off x="5808269" y="3924605"/>
+            <a:ext cx="224942" cy="224942"/>
+          </a:xfrm>
+          <a:prstGeom prst="rect">
+            <a:avLst/>
+          </a:prstGeom>
+        </p:spPr>
+      </p:pic>
+      <p:sp>
+        <p:nvSpPr>
+          <p:cNvPr id="30" name="Text 21"/>
+          <p:cNvSpPr txBox="1"/>
+          <p:nvPr/>
+        </p:nvSpPr>
+        <p:spPr>
+          <a:xfrm>
+            <a:off x="6227064" y="3785616"/>
+            <a:ext cx="5321808" cy="502920"/>
+          </a:xfrm>
+          <a:prstGeom prst="rect">
+            <a:avLst/>
+          </a:prstGeom>
+          <a:noFill/>
+          <a:ln/>
+        </p:spPr>
+        <p:txBody>
+          <a:bodyPr wrap="square" lIns="0" tIns="0" rIns="0" bIns="0" rtlCol="0" anchor="ctr">
+            <a:normAutofit/>
+          </a:bodyPr>
+          <a:lstStyle/>
+          <a:p>
+            <a:pPr indent="0" marL="0">
+              <a:buNone/>
+            </a:pPr>
+            <a:r>
+              <a:rPr lang="en-US" sz="1400" i="1" dirty="0">
+                <a:solidFill>
+                  <a:srgbClr val="FFFFFF"/>
+                </a:solidFill>
+                <a:latin typeface="Calibri" pitchFamily="34" charset="0"/>
+                <a:ea typeface="Calibri" pitchFamily="34" charset="-122"/>
+                <a:cs typeface="Calibri" pitchFamily="34" charset="-120"/>
+              </a:rPr>
+              <a:t>“show me the react repo on github”</a:t>
+            </a:r>
+            <a:endParaRPr lang="en-US" sz="1400" dirty="0"/>
+          </a:p>
+        </p:txBody>
+      </p:sp>
+      <p:pic>
+        <p:nvPicPr>
+          <p:cNvPr id="31" name="Image 7" descr="preencoded.png">    </p:cNvPr>
+          <p:cNvPicPr>
+            <a:picLocks noChangeAspect="1"/>
+          </p:cNvPicPr>
+          <p:nvPr/>
+        </p:nvPicPr>
+        <p:blipFill>
+          <a:blip r:embed="rId8"/>
+          <a:stretch>
+            <a:fillRect/>
+          </a:stretch>
+        </p:blipFill>
+        <p:spPr>
+          <a:xfrm>
+            <a:off x="5760720" y="4425696"/>
+            <a:ext cx="256032" cy="256032"/>
+          </a:xfrm>
+          <a:prstGeom prst="rect">
+            <a:avLst/>
+          </a:prstGeom>
+        </p:spPr>
+      </p:pic>
+      <p:sp>
+        <p:nvSpPr>
+          <p:cNvPr id="32" name="Text 22"/>
+          <p:cNvSpPr txBox="1"/>
+          <p:nvPr/>
+        </p:nvSpPr>
+        <p:spPr>
+          <a:xfrm>
+            <a:off x="6126480" y="4389120"/>
+            <a:ext cx="5486400" cy="329184"/>
+          </a:xfrm>
+          <a:prstGeom prst="rect">
+            <a:avLst/>
+          </a:prstGeom>
+          <a:noFill/>
+          <a:ln/>
+        </p:spPr>
+        <p:txBody>
+          <a:bodyPr wrap="square" lIns="0" tIns="0" rIns="0" bIns="0" rtlCol="0" anchor="ctr"/>
+          <a:lstStyle/>
+          <a:p>
+            <a:pPr indent="0" marL="0">
+              <a:buNone/>
+            </a:pPr>
+            <a:r>
+              <a:rPr lang="en-US" sz="1400" dirty="0">
+                <a:solidFill>
+                  <a:srgbClr val="1A1F36"/>
+                </a:solidFill>
+                <a:latin typeface="Calibri" pitchFamily="34" charset="0"/>
+                <a:ea typeface="Calibri" pitchFamily="34" charset="-122"/>
+                <a:cs typeface="Calibri" pitchFamily="34" charset="-120"/>
+              </a:rPr>
+              <a:t>a paraphrase: understood, and React’s repository opened</a:t>
+            </a:r>
+            <a:endParaRPr lang="en-US" sz="1400" dirty="0"/>
+          </a:p>
+        </p:txBody>
+      </p:sp>
+      <p:sp>
+        <p:nvSpPr>
+          <p:cNvPr id="33" name="Shape 23"/>
+          <p:cNvSpPr/>
+          <p:nvPr/>
+        </p:nvSpPr>
+        <p:spPr>
+          <a:xfrm>
+            <a:off x="5669280" y="4983480"/>
+            <a:ext cx="5971032" cy="1051560"/>
+          </a:xfrm>
+          <a:prstGeom prst="roundRect">
+            <a:avLst>
+              <a:gd name="adj" fmla="val 10435"/>
+            </a:avLst>
+          </a:prstGeom>
+          <a:solidFill>
+            <a:srgbClr val="121833"/>
+          </a:solidFill>
+          <a:ln w="12700">
+            <a:solidFill>
+              <a:srgbClr val="121833"/>
+            </a:solidFill>
+            <a:prstDash val="solid"/>
+          </a:ln>
+        </p:spPr>
+      </p:sp>
+      <p:sp>
+        <p:nvSpPr>
+          <p:cNvPr id="34" name="Text 24"/>
+          <p:cNvSpPr txBox="1"/>
+          <p:nvPr/>
+        </p:nvSpPr>
+        <p:spPr>
+          <a:xfrm>
+            <a:off x="5897880" y="4983480"/>
+            <a:ext cx="5577840" cy="1051560"/>
+          </a:xfrm>
+          <a:prstGeom prst="rect">
+            <a:avLst/>
+          </a:prstGeom>
+          <a:noFill/>
+          <a:ln/>
+        </p:spPr>
+        <p:txBody>
+          <a:bodyPr wrap="square" lIns="0" tIns="0" rIns="0" bIns="0" rtlCol="0" anchor="ctr"/>
+          <a:lstStyle/>
+          <a:p>
+            <a:pPr indent="0" marL="0">
+              <a:buNone/>
+            </a:pPr>
+            <a:r>
+              <a:rPr lang="en-US" sz="1350" dirty="0">
+                <a:solidFill>
+                  <a:srgbClr val="FFFFFF"/>
+                </a:solidFill>
+                <a:latin typeface="Calibri" pitchFamily="34" charset="0"/>
+                <a:ea typeface="Calibri" pitchFamily="34" charset="-122"/>
+                <a:cs typeface="Calibri" pitchFamily="34" charset="-120"/>
+              </a:rPr>
+              <a:t>There is no per-app code path — not for GitHub, and not for Zomato, Amazon or Myntra either. The same recorder, generaliser and replay engine learned this from one demonstration, the way a judge teaches a new flow.</a:t>
+            </a:r>
+            <a:endParaRPr lang="en-US" sz="1350" dirty="0"/>
+          </a:p>
+        </p:txBody>
+      </p:sp>
+      <p:sp>
+        <p:nvSpPr>
+          <p:cNvPr id="36" name="Text 25"/>
+          <p:cNvSpPr txBox="1"/>
+          <p:nvPr/>
+        </p:nvSpPr>
+        <p:spPr>
+          <a:xfrm>
+            <a:off x="548640" y="6473952"/>
+            <a:ext cx="7315200" cy="274320"/>
+          </a:xfrm>
+          <a:prstGeom prst="rect">
+            <a:avLst/>
+          </a:prstGeom>
+          <a:noFill/>
+          <a:ln/>
+        </p:spPr>
+        <p:txBody>
+          <a:bodyPr wrap="square" lIns="0" tIns="0" rIns="0" bIns="0" rtlCol="0" anchor="ctr"/>
+          <a:lstStyle/>
+          <a:p>
+            <a:pPr indent="0" marL="0">
+              <a:buNone/>
+            </a:pPr>
+            <a:r>
+              <a:rPr lang="en-US" sz="1000" dirty="0">
+                <a:solidFill>
+                  <a:srgbClr val="5C637A"/>
+                </a:solidFill>
+                <a:latin typeface="Calibri" pitchFamily="34" charset="0"/>
+                <a:ea typeface="Calibri" pitchFamily="34" charset="-122"/>
+                <a:cs typeface="Calibri" pitchFamily="34" charset="-120"/>
+              </a:rPr>
+              <a:t>Teachable Voice Automation · Theme 3 · Team Update, TIET</a:t>
+            </a:r>
+            <a:endParaRPr lang="en-US" sz="1000" dirty="0"/>
+          </a:p>
+        </p:txBody>
+      </p:sp>
+      <p:sp>
+        <p:nvSpPr>
+          <p:cNvPr id="37" name="Text 26"/>
+          <p:cNvSpPr txBox="1"/>
+          <p:nvPr/>
+        </p:nvSpPr>
+        <p:spPr>
+          <a:xfrm>
+            <a:off x="10728655" y="6473952"/>
+            <a:ext cx="914400" cy="274320"/>
+          </a:xfrm>
+          <a:prstGeom prst="rect">
+            <a:avLst/>
+          </a:prstGeom>
+          <a:noFill/>
+          <a:ln/>
+        </p:spPr>
+        <p:txBody>
+          <a:bodyPr wrap="square" lIns="0" tIns="0" rIns="0" bIns="0" rtlCol="0" anchor="ctr"/>
+          <a:lstStyle/>
+          <a:p>
+            <a:pPr algn="r" indent="0" marL="0">
+              <a:buNone/>
+            </a:pPr>
+            <a:r>
+              <a:rPr lang="en-US" sz="1000" dirty="0">
+                <a:solidFill>
+                  <a:srgbClr val="5C637A"/>
+                </a:solidFill>
+                <a:latin typeface="Calibri" pitchFamily="34" charset="0"/>
+                <a:ea typeface="Calibri" pitchFamily="34" charset="-122"/>
+                <a:cs typeface="Calibri" pitchFamily="34" charset="-120"/>
+              </a:rPr>
+              <a:t>10</a:t>
+            </a:r>
+            <a:endParaRPr lang="en-US" sz="1000" dirty="0"/>
+          </a:p>
+        </p:txBody>
+      </p:sp>
+    </p:spTree>
+  </p:cSld>
+  <p:clrMapOvr>
+    <a:masterClrMapping/>
+  </p:clrMapOvr>
+</p:sld>
+</file>
+
+<file path=ppt/slides/slide11.xml><?xml version="1.0" encoding="utf-8"?>
+<p:sld xmlns:a="http://schemas.openxmlformats.org/drawingml/2006/main" xmlns:r="http://schemas.openxmlformats.org/officeDocument/2006/relationships" xmlns:p="http://schemas.openxmlformats.org/presentationml/2006/main">
+  <p:cSld name="Slide 11">
+    <p:bg>
+      <p:bgPr>
+        <a:solidFill>
+          <a:srgbClr val="FFFFFF"/>
+        </a:solidFill>
+      </p:bgPr>
+    </p:bg>
+    <p:spTree>
+      <p:nvGrpSpPr>
+        <p:cNvPr id="1" name=""/>
+        <p:cNvGrpSpPr/>
+        <p:nvPr/>
+      </p:nvGrpSpPr>
+      <p:grpSpPr>
+        <a:xfrm>
+          <a:off x="0" y="0"/>
+          <a:ext cx="0" cy="0"/>
+          <a:chOff x="0" y="0"/>
+          <a:chExt cx="0" cy="0"/>
+        </a:xfrm>
+      </p:grpSpPr>
+      <p:sp>
+        <p:nvSpPr>
+          <p:cNvPr id="2" name="Text 0"/>
+          <p:cNvSpPr txBox="1"/>
+          <p:nvPr/>
+        </p:nvSpPr>
+        <p:spPr>
+          <a:xfrm>
+            <a:off x="548640" y="347472"/>
+            <a:ext cx="9144000" cy="274320"/>
+          </a:xfrm>
+          <a:prstGeom prst="rect">
+            <a:avLst/>
+          </a:prstGeom>
+          <a:noFill/>
+          <a:ln/>
+        </p:spPr>
+        <p:txBody>
+          <a:bodyPr wrap="square" lIns="0" tIns="0" rIns="0" bIns="0" rtlCol="0" anchor="ctr"/>
+          <a:lstStyle/>
+          <a:p>
+            <a:pPr indent="0" marL="0">
+              <a:buNone/>
+            </a:pPr>
+            <a:r>
+              <a:rPr lang="en-US" sz="1200" b="1" spc="300" kern="0" dirty="0">
+                <a:solidFill>
+                  <a:srgbClr val="FF5B3A"/>
+                </a:solidFill>
+                <a:latin typeface="Arial" pitchFamily="34" charset="0"/>
+                <a:ea typeface="Arial" pitchFamily="34" charset="-122"/>
+                <a:cs typeface="Arial" pitchFamily="34" charset="-120"/>
+              </a:rPr>
+              <a:t>THEME 3 TEST CASES</a:t>
+            </a:r>
+            <a:endParaRPr lang="en-US" sz="1200" dirty="0"/>
+          </a:p>
+        </p:txBody>
+      </p:sp>
+      <p:sp>
+        <p:nvSpPr>
+          <p:cNvPr id="3" name="Text 1"/>
+          <p:cNvSpPr txBox="1"/>
+          <p:nvPr/>
+        </p:nvSpPr>
+        <p:spPr>
+          <a:xfrm>
+            <a:off x="548640" y="640080"/>
+            <a:ext cx="11094415" cy="685800"/>
+          </a:xfrm>
+          <a:prstGeom prst="rect">
+            <a:avLst/>
+          </a:prstGeom>
+          <a:noFill/>
+          <a:ln/>
+        </p:spPr>
+        <p:txBody>
+          <a:bodyPr wrap="square" lIns="0" tIns="0" rIns="0" bIns="0" rtlCol="0" anchor="t"/>
+          <a:lstStyle/>
+          <a:p>
+            <a:pPr indent="0" marL="0">
+              <a:buNone/>
+            </a:pPr>
+            <a:r>
+              <a:rPr lang="en-US" sz="3000" b="1" dirty="0">
+                <a:solidFill>
+                  <a:srgbClr val="1A1F36"/>
+                </a:solidFill>
+                <a:latin typeface="Arial" pitchFamily="34" charset="0"/>
+                <a:ea typeface="Arial" pitchFamily="34" charset="-122"/>
+                <a:cs typeface="Arial" pitchFamily="34" charset="-120"/>
+              </a:rPr>
               <a:t>All 14 pass on our build, plus the three bonuses</a:t>
             </a:r>
             <a:endParaRPr lang="en-US" sz="3000" dirty="0"/>
@@ -2632,7 +4237,7 @@
       </p:sp>
       <p:graphicFrame>
         <p:nvGraphicFramePr>
-          <p:cNvPr id="11" name="Table 0"/>
+          <p:cNvPr id="12" name="Table 0"/>
           <p:cNvGraphicFramePr>
             <a:graphicFrameLocks noGrp="1"/>
           </p:cNvGraphicFramePr>
@@ -3339,7 +4944,7 @@
                           <a:ea typeface="Calibri" pitchFamily="34" charset="-122"/>
                           <a:cs typeface="Calibri" pitchFamily="34" charset="-120"/>
                         </a:rPr>
-                        <a:t>Farmhouse in cart; also another restaurant</a:t>
+                        <a:t>Farmhouse, garlic bread, another restaurant</a:t>
                       </a:r>
                       <a:endParaRPr lang="en-US" sz="1100" dirty="0">
                         <a:latin typeface="Calibri" charset="0"/>
@@ -4091,7 +5696,7 @@
       </p:graphicFrame>
       <p:graphicFrame>
         <p:nvGraphicFramePr>
-          <p:cNvPr id="21" name="Table 1"/>
+          <p:cNvPr id="23" name="Table 1"/>
           <p:cNvGraphicFramePr>
             <a:graphicFrameLocks noGrp="1"/>
           </p:cNvGraphicFramePr>
@@ -4369,7 +5974,7 @@
                           <a:ea typeface="Calibri" pitchFamily="34" charset="-122"/>
                           <a:cs typeface="Calibri" pitchFamily="34" charset="-120"/>
                         </a:rPr>
-                        <a:t>Signed out → stops in 2.8 s, no taps</a:t>
+                        <a:t>Signed out 2.8 s · app in Hindi 5 s · no taps</a:t>
                       </a:r>
                       <a:endParaRPr lang="en-US" sz="1100" dirty="0">
                         <a:latin typeface="Calibri" charset="0"/>
@@ -4512,7 +6117,7 @@
                           <a:ea typeface="Calibri" pitchFamily="34" charset="-122"/>
                           <a:cs typeface="Calibri" pitchFamily="34" charset="-120"/>
                         </a:rPr>
-                        <a:t>Stops at payment: “Your turn”</a:t>
+                        <a:t>Stops before paying: “Your turn.”</a:t>
                       </a:r>
                       <a:endParaRPr lang="en-US" sz="1100" dirty="0">
                         <a:latin typeface="Calibri" charset="0"/>
@@ -5477,7 +7082,7 @@
                 <a:ea typeface="Calibri" pitchFamily="34" charset="-122"/>
                 <a:cs typeface="Calibri" pitchFamily="34" charset="-120"/>
               </a:rPr>
-              <a:t>10</a:t>
+              <a:t>11</a:t>
             </a:r>
             <a:endParaRPr lang="en-US" sz="1000" dirty="0"/>
           </a:p>
@@ -5491,9 +7096,9 @@
 </p:sld>
 </file>
 
-<file path=ppt/slides/slide11.xml><?xml version="1.0" encoding="utf-8"?>
+<file path=ppt/slides/slide12.xml><?xml version="1.0" encoding="utf-8"?>
 <p:sld xmlns:a="http://schemas.openxmlformats.org/drawingml/2006/main" xmlns:r="http://schemas.openxmlformats.org/officeDocument/2006/relationships" xmlns:p="http://schemas.openxmlformats.org/presentationml/2006/main">
-  <p:cSld name="Slide 11">
+  <p:cSld name="Slide 12">
     <p:bg>
       <p:bgPr>
         <a:solidFill>
@@ -6589,7 +8194,7 @@
                 <a:ea typeface="Calibri" pitchFamily="34" charset="-122"/>
                 <a:cs typeface="Calibri" pitchFamily="34" charset="-120"/>
               </a:rPr>
-              <a:t>11</a:t>
+              <a:t>12</a:t>
             </a:r>
             <a:endParaRPr lang="en-US" sz="1000" dirty="0"/>
           </a:p>
@@ -6603,9 +8208,9 @@
 </p:sld>
 </file>
 
-<file path=ppt/slides/slide12.xml><?xml version="1.0" encoding="utf-8"?>
+<file path=ppt/slides/slide13.xml><?xml version="1.0" encoding="utf-8"?>
 <p:sld xmlns:a="http://schemas.openxmlformats.org/drawingml/2006/main" xmlns:r="http://schemas.openxmlformats.org/officeDocument/2006/relationships" xmlns:p="http://schemas.openxmlformats.org/presentationml/2006/main">
-  <p:cSld name="Slide 12">
+  <p:cSld name="Slide 13">
     <p:bg>
       <p:bgPr>
         <a:solidFill>
@@ -7685,7 +9290,7 @@
                 <a:ea typeface="Arial" pitchFamily="34" charset="-122"/>
                 <a:cs typeface="Arial" pitchFamily="34" charset="-120"/>
               </a:rPr>
-              <a:t>~4,000  </a:t>
+              <a:t>~4,300  </a:t>
             </a:r>
             <a:pPr indent="0" marL="0">
               <a:buNone/>
@@ -7791,7 +9396,7 @@
                 <a:ea typeface="Arial" pitchFamily="34" charset="-122"/>
                 <a:cs typeface="Arial" pitchFamily="34" charset="-120"/>
               </a:rPr>
-              <a:t>3.4 MB  </a:t>
+              <a:t>3.5 MB  </a:t>
             </a:r>
             <a:pPr indent="0" marL="0">
               <a:buNone/>
@@ -7936,7 +9541,7 @@
                 <a:ea typeface="Calibri" pitchFamily="34" charset="-122"/>
                 <a:cs typeface="Calibri" pitchFamily="34" charset="-120"/>
               </a:rPr>
-              <a:t>12</a:t>
+              <a:t>13</a:t>
             </a:r>
             <a:endParaRPr lang="en-US" sz="1000" dirty="0"/>
           </a:p>
@@ -7950,9 +9555,9 @@
 </p:sld>
 </file>
 
-<file path=ppt/slides/slide13.xml><?xml version="1.0" encoding="utf-8"?>
+<file path=ppt/slides/slide14.xml><?xml version="1.0" encoding="utf-8"?>
 <p:sld xmlns:a="http://schemas.openxmlformats.org/drawingml/2006/main" xmlns:r="http://schemas.openxmlformats.org/officeDocument/2006/relationships" xmlns:p="http://schemas.openxmlformats.org/presentationml/2006/main">
-  <p:cSld name="Slide 13">
+  <p:cSld name="Slide 14">
     <p:bg>
       <p:bgPr>
         <a:solidFill>
@@ -8060,12 +9665,12 @@
         </p:nvSpPr>
         <p:spPr>
           <a:xfrm>
-            <a:off x="548640" y="1554480"/>
-            <a:ext cx="5440680" cy="1280160"/>
+            <a:off x="548640" y="1508760"/>
+            <a:ext cx="5440680" cy="960120"/>
           </a:xfrm>
           <a:prstGeom prst="roundRect">
             <a:avLst>
-              <a:gd name="adj" fmla="val 8571"/>
+              <a:gd name="adj" fmla="val 11429"/>
             </a:avLst>
           </a:prstGeom>
           <a:solidFill>
@@ -8087,8 +9692,8 @@
         </p:nvSpPr>
         <p:spPr>
           <a:xfrm>
-            <a:off x="777240" y="1874520"/>
-            <a:ext cx="603504" cy="603504"/>
+            <a:off x="749808" y="1709928"/>
+            <a:ext cx="548640" cy="548640"/>
           </a:xfrm>
           <a:prstGeom prst="ellipse">
             <a:avLst/>
@@ -8120,8 +9725,8 @@
         </p:blipFill>
         <p:spPr>
           <a:xfrm>
-            <a:off x="910011" y="2007291"/>
-            <a:ext cx="337962" cy="337962"/>
+            <a:off x="870509" y="1830629"/>
+            <a:ext cx="307238" cy="307238"/>
           </a:xfrm>
           <a:prstGeom prst="rect">
             <a:avLst/>
@@ -8136,8 +9741,8 @@
         </p:nvSpPr>
         <p:spPr>
           <a:xfrm>
-            <a:off x="1554480" y="1719072"/>
-            <a:ext cx="4251960" cy="365760"/>
+            <a:off x="1463040" y="1618488"/>
+            <a:ext cx="4389120" cy="329184"/>
           </a:xfrm>
           <a:prstGeom prst="rect">
             <a:avLst/>
@@ -8153,7 +9758,7 @@
               <a:buNone/>
             </a:pPr>
             <a:r>
-              <a:rPr lang="en-US" sz="1500" b="1" dirty="0">
+              <a:rPr lang="en-US" sz="1450" b="1" dirty="0">
                 <a:solidFill>
                   <a:srgbClr val="1A1F36"/>
                 </a:solidFill>
@@ -8163,7 +9768,7 @@
               </a:rPr>
               <a:t>Paraphrases need the model</a:t>
             </a:r>
-            <a:endParaRPr lang="en-US" sz="1500" dirty="0"/>
+            <a:endParaRPr lang="en-US" sz="1450" dirty="0"/>
           </a:p>
         </p:txBody>
       </p:sp>
@@ -8175,8 +9780,8 @@
         </p:nvSpPr>
         <p:spPr>
           <a:xfrm>
-            <a:off x="1554480" y="2084832"/>
-            <a:ext cx="4251960" cy="685800"/>
+            <a:off x="1463040" y="1947672"/>
+            <a:ext cx="4389120" cy="475488"/>
           </a:xfrm>
           <a:prstGeom prst="rect">
             <a:avLst/>
@@ -8192,7 +9797,7 @@
               <a:buNone/>
             </a:pPr>
             <a:r>
-              <a:rPr lang="en-US" sz="1300" dirty="0">
+              <a:rPr lang="en-US" sz="1250" dirty="0">
                 <a:solidFill>
                   <a:srgbClr val="5C637A"/>
                 </a:solidFill>
@@ -8202,7 +9807,7 @@
               </a:rPr>
               <a:t>Pop-ups, paraphrases and questions use the LLM key; exact and template commands work offline.</a:t>
             </a:r>
-            <a:endParaRPr lang="en-US" sz="1300" dirty="0"/>
+            <a:endParaRPr lang="en-US" sz="1250" dirty="0"/>
           </a:p>
         </p:txBody>
       </p:sp>
@@ -8214,12 +9819,12 @@
         </p:nvSpPr>
         <p:spPr>
           <a:xfrm>
-            <a:off x="6190488" y="1554480"/>
-            <a:ext cx="5440680" cy="1280160"/>
+            <a:off x="6190488" y="1508760"/>
+            <a:ext cx="5440680" cy="960120"/>
           </a:xfrm>
           <a:prstGeom prst="roundRect">
             <a:avLst>
-              <a:gd name="adj" fmla="val 8571"/>
+              <a:gd name="adj" fmla="val 11429"/>
             </a:avLst>
           </a:prstGeom>
           <a:solidFill>
@@ -8241,8 +9846,8 @@
         </p:nvSpPr>
         <p:spPr>
           <a:xfrm>
-            <a:off x="6419088" y="1874520"/>
-            <a:ext cx="603504" cy="603504"/>
+            <a:off x="6391656" y="1709928"/>
+            <a:ext cx="548640" cy="548640"/>
           </a:xfrm>
           <a:prstGeom prst="ellipse">
             <a:avLst/>
@@ -8274,8 +9879,8 @@
         </p:blipFill>
         <p:spPr>
           <a:xfrm>
-            <a:off x="6551859" y="2007291"/>
-            <a:ext cx="337962" cy="337962"/>
+            <a:off x="6512357" y="1830629"/>
+            <a:ext cx="307238" cy="307238"/>
           </a:xfrm>
           <a:prstGeom prst="rect">
             <a:avLst/>
@@ -8290,8 +9895,8 @@
         </p:nvSpPr>
         <p:spPr>
           <a:xfrm>
-            <a:off x="7196328" y="1719072"/>
-            <a:ext cx="4251960" cy="365760"/>
+            <a:off x="7104888" y="1618488"/>
+            <a:ext cx="4389120" cy="329184"/>
           </a:xfrm>
           <a:prstGeom prst="rect">
             <a:avLst/>
@@ -8307,7 +9912,7 @@
               <a:buNone/>
             </a:pPr>
             <a:r>
-              <a:rPr lang="en-US" sz="1500" b="1" dirty="0">
+              <a:rPr lang="en-US" sz="1450" b="1" dirty="0">
                 <a:solidFill>
                   <a:srgbClr val="1A1F36"/>
                 </a:solidFill>
@@ -8317,7 +9922,7 @@
               </a:rPr>
               <a:t>Another app is slower</a:t>
             </a:r>
-            <a:endParaRPr lang="en-US" sz="1500" dirty="0"/>
+            <a:endParaRPr lang="en-US" sz="1450" dirty="0"/>
           </a:p>
         </p:txBody>
       </p:sp>
@@ -8329,8 +9934,8 @@
         </p:nvSpPr>
         <p:spPr>
           <a:xfrm>
-            <a:off x="7196328" y="2084832"/>
-            <a:ext cx="4251960" cy="685800"/>
+            <a:off x="7104888" y="1947672"/>
+            <a:ext cx="4389120" cy="475488"/>
           </a:xfrm>
           <a:prstGeom prst="rect">
             <a:avLst/>
@@ -8346,7 +9951,7 @@
               <a:buNone/>
             </a:pPr>
             <a:r>
-              <a:rPr lang="en-US" sz="1300" dirty="0">
+              <a:rPr lang="en-US" sz="1250" dirty="0">
                 <a:solidFill>
                   <a:srgbClr val="5C637A"/>
                 </a:solidFill>
@@ -8356,7 +9961,7 @@
               </a:rPr>
               <a:t>About 45–60 s on Myntra versus 35–50 s on Amazon: unfamiliar screens go to the model.</a:t>
             </a:r>
-            <a:endParaRPr lang="en-US" sz="1300" dirty="0"/>
+            <a:endParaRPr lang="en-US" sz="1250" dirty="0"/>
           </a:p>
         </p:txBody>
       </p:sp>
@@ -8368,12 +9973,12 @@
         </p:nvSpPr>
         <p:spPr>
           <a:xfrm>
-            <a:off x="548640" y="3017520"/>
-            <a:ext cx="5440680" cy="1280160"/>
+            <a:off x="548640" y="2606040"/>
+            <a:ext cx="5440680" cy="960120"/>
           </a:xfrm>
           <a:prstGeom prst="roundRect">
             <a:avLst>
-              <a:gd name="adj" fmla="val 8571"/>
+              <a:gd name="adj" fmla="val 11429"/>
             </a:avLst>
           </a:prstGeom>
           <a:solidFill>
@@ -8395,8 +10000,8 @@
         </p:nvSpPr>
         <p:spPr>
           <a:xfrm>
-            <a:off x="777240" y="3337560"/>
-            <a:ext cx="603504" cy="603504"/>
+            <a:off x="749808" y="2807208"/>
+            <a:ext cx="548640" cy="548640"/>
           </a:xfrm>
           <a:prstGeom prst="ellipse">
             <a:avLst/>
@@ -8428,8 +10033,8 @@
         </p:blipFill>
         <p:spPr>
           <a:xfrm>
-            <a:off x="910011" y="3470331"/>
-            <a:ext cx="337962" cy="337962"/>
+            <a:off x="870509" y="2927909"/>
+            <a:ext cx="307238" cy="307238"/>
           </a:xfrm>
           <a:prstGeom prst="rect">
             <a:avLst/>
@@ -8444,8 +10049,8 @@
         </p:nvSpPr>
         <p:spPr>
           <a:xfrm>
-            <a:off x="1554480" y="3182112"/>
-            <a:ext cx="4251960" cy="365760"/>
+            <a:off x="1463040" y="2715768"/>
+            <a:ext cx="4389120" cy="329184"/>
           </a:xfrm>
           <a:prstGeom prst="rect">
             <a:avLst/>
@@ -8461,7 +10066,7 @@
               <a:buNone/>
             </a:pPr>
             <a:r>
-              <a:rPr lang="en-US" sz="1500" b="1" dirty="0">
+              <a:rPr lang="en-US" sz="1450" b="1" dirty="0">
                 <a:solidFill>
                   <a:srgbClr val="1A1F36"/>
                 </a:solidFill>
@@ -8471,7 +10076,7 @@
               </a:rPr>
               <a:t>Screen on, phone unlocked</a:t>
             </a:r>
-            <a:endParaRPr lang="en-US" sz="1500" dirty="0"/>
+            <a:endParaRPr lang="en-US" sz="1450" dirty="0"/>
           </a:p>
         </p:txBody>
       </p:sp>
@@ -8483,8 +10088,8 @@
         </p:nvSpPr>
         <p:spPr>
           <a:xfrm>
-            <a:off x="1554480" y="3547872"/>
-            <a:ext cx="4251960" cy="685800"/>
+            <a:off x="1463040" y="3044952"/>
+            <a:ext cx="4389120" cy="475488"/>
           </a:xfrm>
           <a:prstGeom prst="rect">
             <a:avLst/>
@@ -8500,7 +10105,7 @@
               <a:buNone/>
             </a:pPr>
             <a:r>
-              <a:rPr lang="en-US" sz="1300" dirty="0">
+              <a:rPr lang="en-US" sz="1250" dirty="0">
                 <a:solidFill>
                   <a:srgbClr val="5C637A"/>
                 </a:solidFill>
@@ -8510,7 +10115,7 @@
               </a:rPr>
               <a:t>Accessibility services can’t act on a locked screen.</a:t>
             </a:r>
-            <a:endParaRPr lang="en-US" sz="1300" dirty="0"/>
+            <a:endParaRPr lang="en-US" sz="1250" dirty="0"/>
           </a:p>
         </p:txBody>
       </p:sp>
@@ -8522,12 +10127,12 @@
         </p:nvSpPr>
         <p:spPr>
           <a:xfrm>
-            <a:off x="6190488" y="3017520"/>
-            <a:ext cx="5440680" cy="1280160"/>
+            <a:off x="6190488" y="2606040"/>
+            <a:ext cx="5440680" cy="960120"/>
           </a:xfrm>
           <a:prstGeom prst="roundRect">
             <a:avLst>
-              <a:gd name="adj" fmla="val 8571"/>
+              <a:gd name="adj" fmla="val 11429"/>
             </a:avLst>
           </a:prstGeom>
           <a:solidFill>
@@ -8549,8 +10154,8 @@
         </p:nvSpPr>
         <p:spPr>
           <a:xfrm>
-            <a:off x="6419088" y="3337560"/>
-            <a:ext cx="603504" cy="603504"/>
+            <a:off x="6391656" y="2807208"/>
+            <a:ext cx="548640" cy="548640"/>
           </a:xfrm>
           <a:prstGeom prst="ellipse">
             <a:avLst/>
@@ -8582,8 +10187,8 @@
         </p:blipFill>
         <p:spPr>
           <a:xfrm>
-            <a:off x="6551859" y="3470331"/>
-            <a:ext cx="337962" cy="337962"/>
+            <a:off x="6512357" y="2927909"/>
+            <a:ext cx="307238" cy="307238"/>
           </a:xfrm>
           <a:prstGeom prst="rect">
             <a:avLst/>
@@ -8598,8 +10203,8 @@
         </p:nvSpPr>
         <p:spPr>
           <a:xfrm>
-            <a:off x="7196328" y="3182112"/>
-            <a:ext cx="4251960" cy="365760"/>
+            <a:off x="7104888" y="2715768"/>
+            <a:ext cx="4389120" cy="329184"/>
           </a:xfrm>
           <a:prstGeom prst="rect">
             <a:avLst/>
@@ -8615,7 +10220,7 @@
               <a:buNone/>
             </a:pPr>
             <a:r>
-              <a:rPr lang="en-US" sz="1500" b="1" dirty="0">
+              <a:rPr lang="en-US" sz="1450" b="1" dirty="0">
                 <a:solidFill>
                   <a:srgbClr val="1A1F36"/>
                 </a:solidFill>
@@ -8625,7 +10230,7 @@
               </a:rPr>
               <a:t>Sideloading in India</a:t>
             </a:r>
-            <a:endParaRPr lang="en-US" sz="1500" dirty="0"/>
+            <a:endParaRPr lang="en-US" sz="1450" dirty="0"/>
           </a:p>
         </p:txBody>
       </p:sp>
@@ -8637,8 +10242,8 @@
         </p:nvSpPr>
         <p:spPr>
           <a:xfrm>
-            <a:off x="7196328" y="3547872"/>
-            <a:ext cx="4251960" cy="685800"/>
+            <a:off x="7104888" y="3044952"/>
+            <a:ext cx="4389120" cy="475488"/>
           </a:xfrm>
           <a:prstGeom prst="rect">
             <a:avLst/>
@@ -8654,7 +10259,7 @@
               <a:buNone/>
             </a:pPr>
             <a:r>
-              <a:rPr lang="en-US" sz="1300" dirty="0">
+              <a:rPr lang="en-US" sz="1250" dirty="0">
                 <a:solidFill>
                   <a:srgbClr val="5C637A"/>
                 </a:solidFill>
@@ -8664,7 +10269,7 @@
               </a:rPr>
               <a:t>Play Protect blocks apps with an accessibility service from browsers and chat apps; install over USB or pause the scan.</a:t>
             </a:r>
-            <a:endParaRPr lang="en-US" sz="1300" dirty="0"/>
+            <a:endParaRPr lang="en-US" sz="1250" dirty="0"/>
           </a:p>
         </p:txBody>
       </p:sp>
@@ -8676,12 +10281,12 @@
         </p:nvSpPr>
         <p:spPr>
           <a:xfrm>
-            <a:off x="548640" y="4480560"/>
-            <a:ext cx="5440680" cy="1280160"/>
+            <a:off x="548640" y="3703320"/>
+            <a:ext cx="5440680" cy="960120"/>
           </a:xfrm>
           <a:prstGeom prst="roundRect">
             <a:avLst>
-              <a:gd name="adj" fmla="val 8571"/>
+              <a:gd name="adj" fmla="val 11429"/>
             </a:avLst>
           </a:prstGeom>
           <a:solidFill>
@@ -8703,8 +10308,8 @@
         </p:nvSpPr>
         <p:spPr>
           <a:xfrm>
-            <a:off x="777240" y="4800600"/>
-            <a:ext cx="603504" cy="603504"/>
+            <a:off x="749808" y="3904488"/>
+            <a:ext cx="548640" cy="548640"/>
           </a:xfrm>
           <a:prstGeom prst="ellipse">
             <a:avLst/>
@@ -8736,8 +10341,8 @@
         </p:blipFill>
         <p:spPr>
           <a:xfrm>
-            <a:off x="910011" y="4933371"/>
-            <a:ext cx="337962" cy="337962"/>
+            <a:off x="870509" y="4025189"/>
+            <a:ext cx="307238" cy="307238"/>
           </a:xfrm>
           <a:prstGeom prst="rect">
             <a:avLst/>
@@ -8752,8 +10357,8 @@
         </p:nvSpPr>
         <p:spPr>
           <a:xfrm>
-            <a:off x="1554480" y="4645152"/>
-            <a:ext cx="4251960" cy="365760"/>
+            <a:off x="1463040" y="3813048"/>
+            <a:ext cx="4389120" cy="329184"/>
           </a:xfrm>
           <a:prstGeom prst="rect">
             <a:avLst/>
@@ -8769,7 +10374,7 @@
               <a:buNone/>
             </a:pPr>
             <a:r>
-              <a:rPr lang="en-US" sz="1500" b="1" dirty="0">
+              <a:rPr lang="en-US" sz="1450" b="1" dirty="0">
                 <a:solidFill>
                   <a:srgbClr val="1A1F36"/>
                 </a:solidFill>
@@ -8779,7 +10384,7 @@
               </a:rPr>
               <a:t>Slow networks stall apps</a:t>
             </a:r>
-            <a:endParaRPr lang="en-US" sz="1500" dirty="0"/>
+            <a:endParaRPr lang="en-US" sz="1450" dirty="0"/>
           </a:p>
         </p:txBody>
       </p:sp>
@@ -8791,8 +10396,8 @@
         </p:nvSpPr>
         <p:spPr>
           <a:xfrm>
-            <a:off x="1554480" y="5010912"/>
-            <a:ext cx="4251960" cy="685800"/>
+            <a:off x="1463040" y="4142232"/>
+            <a:ext cx="4389120" cy="475488"/>
           </a:xfrm>
           <a:prstGeom prst="rect">
             <a:avLst/>
@@ -8808,7 +10413,7 @@
               <a:buNone/>
             </a:pPr>
             <a:r>
-              <a:rPr lang="en-US" sz="1300" dirty="0">
+              <a:rPr lang="en-US" sz="1250" dirty="0">
                 <a:solidFill>
                   <a:srgbClr val="5C637A"/>
                 </a:solidFill>
@@ -8818,7 +10423,7 @@
               </a:rPr>
               <a:t>It taps the app’s “Try Again” up to three times, then says where it stopped.</a:t>
             </a:r>
-            <a:endParaRPr lang="en-US" sz="1300" dirty="0"/>
+            <a:endParaRPr lang="en-US" sz="1250" dirty="0"/>
           </a:p>
         </p:txBody>
       </p:sp>
@@ -8830,12 +10435,12 @@
         </p:nvSpPr>
         <p:spPr>
           <a:xfrm>
-            <a:off x="6190488" y="4480560"/>
-            <a:ext cx="5440680" cy="1280160"/>
+            <a:off x="6190488" y="3703320"/>
+            <a:ext cx="5440680" cy="960120"/>
           </a:xfrm>
           <a:prstGeom prst="roundRect">
             <a:avLst>
-              <a:gd name="adj" fmla="val 8571"/>
+              <a:gd name="adj" fmla="val 11429"/>
             </a:avLst>
           </a:prstGeom>
           <a:solidFill>
@@ -8857,8 +10462,8 @@
         </p:nvSpPr>
         <p:spPr>
           <a:xfrm>
-            <a:off x="6419088" y="4800600"/>
-            <a:ext cx="603504" cy="603504"/>
+            <a:off x="6391656" y="3904488"/>
+            <a:ext cx="548640" cy="548640"/>
           </a:xfrm>
           <a:prstGeom prst="ellipse">
             <a:avLst/>
@@ -8890,8 +10495,8 @@
         </p:blipFill>
         <p:spPr>
           <a:xfrm>
-            <a:off x="6551859" y="4933371"/>
-            <a:ext cx="337962" cy="337962"/>
+            <a:off x="6512357" y="4025189"/>
+            <a:ext cx="307238" cy="307238"/>
           </a:xfrm>
           <a:prstGeom prst="rect">
             <a:avLst/>
@@ -8906,8 +10511,8 @@
         </p:nvSpPr>
         <p:spPr>
           <a:xfrm>
-            <a:off x="7196328" y="4645152"/>
-            <a:ext cx="4251960" cy="365760"/>
+            <a:off x="7104888" y="3813048"/>
+            <a:ext cx="4389120" cy="329184"/>
           </a:xfrm>
           <a:prstGeom prst="rect">
             <a:avLst/>
@@ -8923,7 +10528,7 @@
               <a:buNone/>
             </a:pPr>
             <a:r>
-              <a:rPr lang="en-US" sz="1500" b="1" dirty="0">
+              <a:rPr lang="en-US" sz="1450" b="1" dirty="0">
                 <a:solidFill>
                   <a:srgbClr val="1A1F36"/>
                 </a:solidFill>
@@ -8933,7 +10538,7 @@
               </a:rPr>
               <a:t>Speech is English (India)</a:t>
             </a:r>
-            <a:endParaRPr lang="en-US" sz="1500" dirty="0"/>
+            <a:endParaRPr lang="en-US" sz="1450" dirty="0"/>
           </a:p>
         </p:txBody>
       </p:sp>
@@ -8945,8 +10550,8 @@
         </p:nvSpPr>
         <p:spPr>
           <a:xfrm>
-            <a:off x="7196328" y="5010912"/>
-            <a:ext cx="4251960" cy="685800"/>
+            <a:off x="7104888" y="4142232"/>
+            <a:ext cx="4389120" cy="475488"/>
           </a:xfrm>
           <a:prstGeom prst="rect">
             <a:avLst/>
@@ -8962,7 +10567,7 @@
               <a:buNone/>
             </a:pPr>
             <a:r>
-              <a:rPr lang="en-US" sz="1300" dirty="0">
+              <a:rPr lang="en-US" sz="1250" dirty="0">
                 <a:solidFill>
                   <a:srgbClr val="5C637A"/>
                 </a:solidFill>
@@ -8972,20 +10577,96 @@
               </a:rPr>
               <a:t>Spoken answers use the phone’s recogniser; typing in the app works too.</a:t>
             </a:r>
-            <a:endParaRPr lang="en-US" sz="1300" dirty="0"/>
-          </a:p>
-        </p:txBody>
-      </p:sp>
-      <p:sp>
-        <p:nvSpPr>
-          <p:cNvPr id="35" name="Text 26"/>
-          <p:cNvSpPr txBox="1"/>
-          <p:nvPr/>
-        </p:nvSpPr>
-        <p:spPr>
-          <a:xfrm>
-            <a:off x="548640" y="6473952"/>
-            <a:ext cx="7315200" cy="274320"/>
+            <a:endParaRPr lang="en-US" sz="1250" dirty="0"/>
+          </a:p>
+        </p:txBody>
+      </p:sp>
+      <p:sp>
+        <p:nvSpPr>
+          <p:cNvPr id="34" name="Shape 26"/>
+          <p:cNvSpPr/>
+          <p:nvPr/>
+        </p:nvSpPr>
+        <p:spPr>
+          <a:xfrm>
+            <a:off x="548640" y="4800600"/>
+            <a:ext cx="5440680" cy="960120"/>
+          </a:xfrm>
+          <a:prstGeom prst="roundRect">
+            <a:avLst>
+              <a:gd name="adj" fmla="val 11429"/>
+            </a:avLst>
+          </a:prstGeom>
+          <a:solidFill>
+            <a:srgbClr val="F4F5FA"/>
+          </a:solidFill>
+          <a:ln w="12700">
+            <a:solidFill>
+              <a:srgbClr val="F4F5FA"/>
+            </a:solidFill>
+            <a:prstDash val="solid"/>
+          </a:ln>
+        </p:spPr>
+      </p:sp>
+      <p:sp>
+        <p:nvSpPr>
+          <p:cNvPr id="35" name="Shape 27"/>
+          <p:cNvSpPr/>
+          <p:nvPr/>
+        </p:nvSpPr>
+        <p:spPr>
+          <a:xfrm>
+            <a:off x="749808" y="5001768"/>
+            <a:ext cx="548640" cy="548640"/>
+          </a:xfrm>
+          <a:prstGeom prst="ellipse">
+            <a:avLst/>
+          </a:prstGeom>
+          <a:solidFill>
+            <a:srgbClr val="222B55"/>
+          </a:solidFill>
+          <a:ln w="12700">
+            <a:solidFill>
+              <a:srgbClr val="222B55"/>
+            </a:solidFill>
+            <a:prstDash val="solid"/>
+          </a:ln>
+        </p:spPr>
+      </p:sp>
+      <p:pic>
+        <p:nvPicPr>
+          <p:cNvPr id="36" name="Image 6" descr="preencoded.png">    </p:cNvPr>
+          <p:cNvPicPr>
+            <a:picLocks noChangeAspect="1"/>
+          </p:cNvPicPr>
+          <p:nvPr/>
+        </p:nvPicPr>
+        <p:blipFill>
+          <a:blip r:embed="rId7"/>
+          <a:stretch>
+            <a:fillRect/>
+          </a:stretch>
+        </p:blipFill>
+        <p:spPr>
+          <a:xfrm>
+            <a:off x="870509" y="5122469"/>
+            <a:ext cx="307238" cy="307238"/>
+          </a:xfrm>
+          <a:prstGeom prst="rect">
+            <a:avLst/>
+          </a:prstGeom>
+        </p:spPr>
+      </p:pic>
+      <p:sp>
+        <p:nvSpPr>
+          <p:cNvPr id="37" name="Text 28"/>
+          <p:cNvSpPr txBox="1"/>
+          <p:nvPr/>
+        </p:nvSpPr>
+        <p:spPr>
+          <a:xfrm>
+            <a:off x="1463040" y="4910328"/>
+            <a:ext cx="4389120" cy="329184"/>
           </a:xfrm>
           <a:prstGeom prst="rect">
             <a:avLst/>
@@ -9001,7 +10682,46 @@
               <a:buNone/>
             </a:pPr>
             <a:r>
-              <a:rPr lang="en-US" sz="1000" dirty="0">
+              <a:rPr lang="en-US" sz="1450" b="1" dirty="0">
+                <a:solidFill>
+                  <a:srgbClr val="1A1F36"/>
+                </a:solidFill>
+                <a:latin typeface="Arial" pitchFamily="34" charset="0"/>
+                <a:ea typeface="Arial" pitchFamily="34" charset="-122"/>
+                <a:cs typeface="Arial" pitchFamily="34" charset="-120"/>
+              </a:rPr>
+              <a:t>Taught in English, app now in Hindi</a:t>
+            </a:r>
+            <a:endParaRPr lang="en-US" sz="1450" dirty="0"/>
+          </a:p>
+        </p:txBody>
+      </p:sp>
+      <p:sp>
+        <p:nvSpPr>
+          <p:cNvPr id="38" name="Text 29"/>
+          <p:cNvSpPr txBox="1"/>
+          <p:nvPr/>
+        </p:nvSpPr>
+        <p:spPr>
+          <a:xfrm>
+            <a:off x="1463040" y="5239512"/>
+            <a:ext cx="4389120" cy="475488"/>
+          </a:xfrm>
+          <a:prstGeom prst="rect">
+            <a:avLst/>
+          </a:prstGeom>
+          <a:noFill/>
+          <a:ln/>
+        </p:spPr>
+        <p:txBody>
+          <a:bodyPr wrap="square" lIns="0" tIns="0" rIns="0" bIns="0" rtlCol="0" anchor="t"/>
+          <a:lstStyle/>
+          <a:p>
+            <a:pPr indent="0" marL="0">
+              <a:buNone/>
+            </a:pPr>
+            <a:r>
+              <a:rPr lang="en-US" sz="1250" dirty="0">
                 <a:solidFill>
                   <a:srgbClr val="5C637A"/>
                 </a:solidFill>
@@ -9009,22 +10729,98 @@
                 <a:ea typeface="Calibri" pitchFamily="34" charset="-122"/>
                 <a:cs typeface="Calibri" pitchFamily="34" charset="-120"/>
               </a:rPr>
-              <a:t>Teachable Voice Automation · Theme 3 · Team Update, TIET</a:t>
-            </a:r>
-            <a:endParaRPr lang="en-US" sz="1000" dirty="0"/>
-          </a:p>
-        </p:txBody>
-      </p:sp>
-      <p:sp>
-        <p:nvSpPr>
-          <p:cNvPr id="36" name="Text 27"/>
-          <p:cNvSpPr txBox="1"/>
-          <p:nvPr/>
-        </p:nvSpPr>
-        <p:spPr>
-          <a:xfrm>
-            <a:off x="10728655" y="6473952"/>
-            <a:ext cx="914400" cy="274320"/>
+              <a:t>It stops at the first step and says so; switch the app back or teach the task again in Hindi.</a:t>
+            </a:r>
+            <a:endParaRPr lang="en-US" sz="1250" dirty="0"/>
+          </a:p>
+        </p:txBody>
+      </p:sp>
+      <p:sp>
+        <p:nvSpPr>
+          <p:cNvPr id="39" name="Shape 30"/>
+          <p:cNvSpPr/>
+          <p:nvPr/>
+        </p:nvSpPr>
+        <p:spPr>
+          <a:xfrm>
+            <a:off x="6190488" y="4800600"/>
+            <a:ext cx="5440680" cy="960120"/>
+          </a:xfrm>
+          <a:prstGeom prst="roundRect">
+            <a:avLst>
+              <a:gd name="adj" fmla="val 11429"/>
+            </a:avLst>
+          </a:prstGeom>
+          <a:solidFill>
+            <a:srgbClr val="F4F5FA"/>
+          </a:solidFill>
+          <a:ln w="12700">
+            <a:solidFill>
+              <a:srgbClr val="F4F5FA"/>
+            </a:solidFill>
+            <a:prstDash val="solid"/>
+          </a:ln>
+        </p:spPr>
+      </p:sp>
+      <p:sp>
+        <p:nvSpPr>
+          <p:cNvPr id="40" name="Shape 31"/>
+          <p:cNvSpPr/>
+          <p:nvPr/>
+        </p:nvSpPr>
+        <p:spPr>
+          <a:xfrm>
+            <a:off x="6391656" y="5001768"/>
+            <a:ext cx="548640" cy="548640"/>
+          </a:xfrm>
+          <a:prstGeom prst="ellipse">
+            <a:avLst/>
+          </a:prstGeom>
+          <a:solidFill>
+            <a:srgbClr val="222B55"/>
+          </a:solidFill>
+          <a:ln w="12700">
+            <a:solidFill>
+              <a:srgbClr val="222B55"/>
+            </a:solidFill>
+            <a:prstDash val="solid"/>
+          </a:ln>
+        </p:spPr>
+      </p:sp>
+      <p:pic>
+        <p:nvPicPr>
+          <p:cNvPr id="41" name="Image 7" descr="preencoded.png">    </p:cNvPr>
+          <p:cNvPicPr>
+            <a:picLocks noChangeAspect="1"/>
+          </p:cNvPicPr>
+          <p:nvPr/>
+        </p:nvPicPr>
+        <p:blipFill>
+          <a:blip r:embed="rId8"/>
+          <a:stretch>
+            <a:fillRect/>
+          </a:stretch>
+        </p:blipFill>
+        <p:spPr>
+          <a:xfrm>
+            <a:off x="6512357" y="5122469"/>
+            <a:ext cx="307238" cy="307238"/>
+          </a:xfrm>
+          <a:prstGeom prst="rect">
+            <a:avLst/>
+          </a:prstGeom>
+        </p:spPr>
+      </p:pic>
+      <p:sp>
+        <p:nvSpPr>
+          <p:cNvPr id="42" name="Text 32"/>
+          <p:cNvSpPr txBox="1"/>
+          <p:nvPr/>
+        </p:nvSpPr>
+        <p:spPr>
+          <a:xfrm>
+            <a:off x="7104888" y="4910328"/>
+            <a:ext cx="4389120" cy="329184"/>
           </a:xfrm>
           <a:prstGeom prst="rect">
             <a:avLst/>
@@ -9036,11 +10832,50 @@
           <a:bodyPr wrap="square" lIns="0" tIns="0" rIns="0" bIns="0" rtlCol="0" anchor="ctr"/>
           <a:lstStyle/>
           <a:p>
-            <a:pPr algn="r" indent="0" marL="0">
-              <a:buNone/>
-            </a:pPr>
-            <a:r>
-              <a:rPr lang="en-US" sz="1000" dirty="0">
+            <a:pPr indent="0" marL="0">
+              <a:buNone/>
+            </a:pPr>
+            <a:r>
+              <a:rPr lang="en-US" sz="1450" b="1" dirty="0">
+                <a:solidFill>
+                  <a:srgbClr val="1A1F36"/>
+                </a:solidFill>
+                <a:latin typeface="Arial" pitchFamily="34" charset="0"/>
+                <a:ea typeface="Arial" pitchFamily="34" charset="-122"/>
+                <a:cs typeface="Arial" pitchFamily="34" charset="-120"/>
+              </a:rPr>
+              <a:t>Loose dish names</a:t>
+            </a:r>
+            <a:endParaRPr lang="en-US" sz="1450" dirty="0"/>
+          </a:p>
+        </p:txBody>
+      </p:sp>
+      <p:sp>
+        <p:nvSpPr>
+          <p:cNvPr id="43" name="Text 33"/>
+          <p:cNvSpPr txBox="1"/>
+          <p:nvPr/>
+        </p:nvSpPr>
+        <p:spPr>
+          <a:xfrm>
+            <a:off x="7104888" y="5239512"/>
+            <a:ext cx="4389120" cy="475488"/>
+          </a:xfrm>
+          <a:prstGeom prst="rect">
+            <a:avLst/>
+          </a:prstGeom>
+          <a:noFill/>
+          <a:ln/>
+        </p:spPr>
+        <p:txBody>
+          <a:bodyPr wrap="square" lIns="0" tIns="0" rIns="0" bIns="0" rtlCol="0" anchor="t"/>
+          <a:lstStyle/>
+          <a:p>
+            <a:pPr indent="0" marL="0">
+              <a:buNone/>
+            </a:pPr>
+            <a:r>
+              <a:rPr lang="en-US" sz="1250" dirty="0">
                 <a:solidFill>
                   <a:srgbClr val="5C637A"/>
                 </a:solidFill>
@@ -9048,7 +10883,85 @@
                 <a:ea typeface="Calibri" pitchFamily="34" charset="-122"/>
                 <a:cs typeface="Calibri" pitchFamily="34" charset="-120"/>
               </a:rPr>
-              <a:t>13</a:t>
+              <a:t>“Garlic bread” picks the closest name on screen (Classic Stuffed Garlic Bread); say the full name for a specific one.</a:t>
+            </a:r>
+            <a:endParaRPr lang="en-US" sz="1250" dirty="0"/>
+          </a:p>
+        </p:txBody>
+      </p:sp>
+      <p:sp>
+        <p:nvSpPr>
+          <p:cNvPr id="45" name="Text 34"/>
+          <p:cNvSpPr txBox="1"/>
+          <p:nvPr/>
+        </p:nvSpPr>
+        <p:spPr>
+          <a:xfrm>
+            <a:off x="548640" y="6473952"/>
+            <a:ext cx="7315200" cy="274320"/>
+          </a:xfrm>
+          <a:prstGeom prst="rect">
+            <a:avLst/>
+          </a:prstGeom>
+          <a:noFill/>
+          <a:ln/>
+        </p:spPr>
+        <p:txBody>
+          <a:bodyPr wrap="square" lIns="0" tIns="0" rIns="0" bIns="0" rtlCol="0" anchor="ctr"/>
+          <a:lstStyle/>
+          <a:p>
+            <a:pPr indent="0" marL="0">
+              <a:buNone/>
+            </a:pPr>
+            <a:r>
+              <a:rPr lang="en-US" sz="1000" dirty="0">
+                <a:solidFill>
+                  <a:srgbClr val="5C637A"/>
+                </a:solidFill>
+                <a:latin typeface="Calibri" pitchFamily="34" charset="0"/>
+                <a:ea typeface="Calibri" pitchFamily="34" charset="-122"/>
+                <a:cs typeface="Calibri" pitchFamily="34" charset="-120"/>
+              </a:rPr>
+              <a:t>Teachable Voice Automation · Theme 3 · Team Update, TIET</a:t>
+            </a:r>
+            <a:endParaRPr lang="en-US" sz="1000" dirty="0"/>
+          </a:p>
+        </p:txBody>
+      </p:sp>
+      <p:sp>
+        <p:nvSpPr>
+          <p:cNvPr id="46" name="Text 35"/>
+          <p:cNvSpPr txBox="1"/>
+          <p:nvPr/>
+        </p:nvSpPr>
+        <p:spPr>
+          <a:xfrm>
+            <a:off x="10728655" y="6473952"/>
+            <a:ext cx="914400" cy="274320"/>
+          </a:xfrm>
+          <a:prstGeom prst="rect">
+            <a:avLst/>
+          </a:prstGeom>
+          <a:noFill/>
+          <a:ln/>
+        </p:spPr>
+        <p:txBody>
+          <a:bodyPr wrap="square" lIns="0" tIns="0" rIns="0" bIns="0" rtlCol="0" anchor="ctr"/>
+          <a:lstStyle/>
+          <a:p>
+            <a:pPr algn="r" indent="0" marL="0">
+              <a:buNone/>
+            </a:pPr>
+            <a:r>
+              <a:rPr lang="en-US" sz="1000" dirty="0">
+                <a:solidFill>
+                  <a:srgbClr val="5C637A"/>
+                </a:solidFill>
+                <a:latin typeface="Calibri" pitchFamily="34" charset="0"/>
+                <a:ea typeface="Calibri" pitchFamily="34" charset="-122"/>
+                <a:cs typeface="Calibri" pitchFamily="34" charset="-120"/>
+              </a:rPr>
+              <a:t>14</a:t>
             </a:r>
             <a:endParaRPr lang="en-US" sz="1000" dirty="0"/>
           </a:p>
@@ -9062,9 +10975,9 @@
 </p:sld>
 </file>
 
-<file path=ppt/slides/slide14.xml><?xml version="1.0" encoding="utf-8"?>
+<file path=ppt/slides/slide15.xml><?xml version="1.0" encoding="utf-8"?>
 <p:sld xmlns:a="http://schemas.openxmlformats.org/drawingml/2006/main" xmlns:r="http://schemas.openxmlformats.org/officeDocument/2006/relationships" xmlns:p="http://schemas.openxmlformats.org/presentationml/2006/main">
-  <p:cSld name="Slide 14">
+  <p:cSld name="Slide 15">
     <p:bg>
       <p:bgPr>
         <a:solidFill>
@@ -10034,7 +11947,7 @@
                 <a:ea typeface="Calibri" pitchFamily="34" charset="-122"/>
                 <a:cs typeface="Calibri" pitchFamily="34" charset="-120"/>
               </a:rPr>
-              <a:t>14</a:t>
+              <a:t>15</a:t>
             </a:r>
             <a:endParaRPr lang="en-US" sz="1000" dirty="0"/>
           </a:p>
@@ -16675,7 +18588,7 @@
                 <a:ea typeface="Calibri" pitchFamily="34" charset="-122"/>
                 <a:cs typeface="Calibri" pitchFamily="34" charset="-120"/>
               </a:rPr>
-              <a:t>“I’ve stopped before checkout”</a:t>
+              <a:t>“…before paying. Your turn.”</a:t>
             </a:r>
             <a:endParaRPr lang="en-US" sz="1150" dirty="0"/>
           </a:p>
@@ -16990,7 +18903,7 @@
                 <a:ea typeface="Arial" pitchFamily="34" charset="-122"/>
                 <a:cs typeface="Arial" pitchFamily="34" charset="-120"/>
               </a:rPr>
-              <a:t>2.8 s</a:t>
+              <a:t>≤ 5 s</a:t>
             </a:r>
             <a:endParaRPr lang="en-US" sz="3400" dirty="0"/>
           </a:p>
@@ -17029,7 +18942,7 @@
                 <a:ea typeface="Calibri" pitchFamily="34" charset="-122"/>
                 <a:cs typeface="Calibri" pitchFamily="34" charset="-120"/>
               </a:rPr>
-              <a:t>to stop and say why when the app was signed out — no taps, no loop</a:t>
+              <a:t>to stop and say why when the app is signed out (2.8 s) or switched to Hindi (5 s) — no taps</a:t>
             </a:r>
             <a:endParaRPr lang="en-US" sz="1250" dirty="0"/>
           </a:p>
@@ -18110,7 +20023,7 @@
                 <a:ea typeface="Calibri" pitchFamily="34" charset="-122"/>
                 <a:cs typeface="Calibri" pitchFamily="34" charset="-120"/>
               </a:rPr>
-              <a:t>Stuck</a:t>
+              <a:t>Stuck: signed out, app in Hindi</a:t>
             </a:r>
             <a:endParaRPr lang="en-US" sz="1400" dirty="0"/>
           </a:p>
@@ -18127,7 +20040,7 @@
                 <a:ea typeface="Calibri" pitchFamily="34" charset="-122"/>
                 <a:cs typeface="Calibri" pitchFamily="34" charset="-120"/>
               </a:rPr>
-              <a:t>reports the step within 30 s</a:t>
+              <a:t>says why within 5 s, taps nothing</a:t>
             </a:r>
             <a:endParaRPr lang="en-US" sz="1400" dirty="0"/>
           </a:p>
@@ -19051,7 +20964,7 @@
                 <a:ea typeface="Calibri" pitchFamily="34" charset="-122"/>
                 <a:cs typeface="Calibri" pitchFamily="34" charset="-120"/>
               </a:rPr>
-              <a:t>Taught on Domino’s, ordered from Pizza Hut</a:t>
+              <a:t>Every judges’ sentence, verbatim</a:t>
             </a:r>
             <a:endParaRPr lang="en-US" sz="1400" dirty="0"/>
           </a:p>
@@ -19068,7 +20981,7 @@
                 <a:ea typeface="Calibri" pitchFamily="34" charset="-122"/>
                 <a:cs typeface="Calibri" pitchFamily="34" charset="-120"/>
               </a:rPr>
-              <a:t>outlet picker, menu search, the right Margherita — 64 s</a:t>
+              <a:t>exact, both paraphrases, Farmhouse, two pizzas, to Work, “Order pizza.”: all handled</a:t>
             </a:r>
             <a:endParaRPr lang="en-US" sz="1400" dirty="0"/>
           </a:p>
@@ -19131,7 +21044,7 @@
                 <a:ea typeface="Calibri" pitchFamily="34" charset="-122"/>
                 <a:cs typeface="Calibri" pitchFamily="34" charset="-120"/>
               </a:rPr>
-              <a:t>One Zomato demo, six new commands</a:t>
+              <a:t>“Order garlic bread from dominos”</a:t>
             </a:r>
             <a:endParaRPr lang="en-US" sz="1400" dirty="0"/>
           </a:p>
@@ -19148,7 +21061,7 @@
                 <a:ea typeface="Calibri" pitchFamily="34" charset="-122"/>
                 <a:cs typeface="Calibri" pitchFamily="34" charset="-120"/>
               </a:rPr>
-              <a:t>exact, paraphrase, new pizza, two pizzas, to Work, “order something”: 6/6</a:t>
+              <a:t>Classic Stuffed Garlic Bread in the cart — 58 s, no LLM calls</a:t>
             </a:r>
             <a:endParaRPr lang="en-US" sz="1400" dirty="0"/>
           </a:p>
@@ -19211,7 +21124,7 @@
                 <a:ea typeface="Calibri" pitchFamily="34" charset="-122"/>
                 <a:cs typeface="Calibri" pitchFamily="34" charset="-120"/>
               </a:rPr>
-              <a:t>Signed out of Zomato</a:t>
+              <a:t>Taught on Domino’s, ordered from Pizza Hut</a:t>
             </a:r>
             <a:endParaRPr lang="en-US" sz="1400" dirty="0"/>
           </a:p>
@@ -19228,7 +21141,7 @@
                 <a:ea typeface="Calibri" pitchFamily="34" charset="-122"/>
                 <a:cs typeface="Calibri" pitchFamily="34" charset="-120"/>
               </a:rPr>
-              <a:t>stopped in 2.8 s: “you seem to be signed out; please sign in”</a:t>
+              <a:t>outlet picker, menu search, the plain Margherita — 63 s</a:t>
             </a:r>
             <a:endParaRPr lang="en-US" sz="1400" dirty="0"/>
           </a:p>
@@ -19347,7 +21260,7 @@
                 <a:ea typeface="Calibri" pitchFamily="34" charset="-122"/>
                 <a:cs typeface="Calibri" pitchFamily="34" charset="-120"/>
               </a:rPr>
-              <a:t>Oppo Reno3, Android 12 · app force-stopped before every run · full tables and method in docs/ of the repository</a:t>
+              <a:t>Oppo Reno3, Android 12 · 28–30 Sep · app force-stopped before every run · full tables and method in docs/ of the repository</a:t>
             </a:r>
             <a:endParaRPr lang="en-US" sz="1100" dirty="0"/>
           </a:p>

</xml_diff>

<commit_message>
Deck slide 5: a five-step walkthrough from one Zomato task
Fresh phone captures (30 Sep): teaching, the learned task, a replay by
voice at step 7/11, the question for a missing restaurant, and the
hand-back at the payment page. Three more commands from the 30 Sep eval
as voice pills, and the demo-video line. Old slide images removed;
recon/demo_shots.sh and demo_run_shots.sh take the screenshots.

Co-Authored-By: Claude Opus 5.5 <noreply@anthropic.com>
Claude-Session: https://claude.ai/code/session_011KQSFKCwgub7G5EKjwmTaV
</commit_message>
<xml_diff>
--- a/TIET_Update_Submission_ppt.pptx
+++ b/TIET_Update_Submission_ppt.pptx
@@ -2208,7 +2208,7 @@
           <a:lstStyle/>
           <a:p>
             <a:r>
-              <a:t>Four moments from real runs: the teaching border with Done and Cancel; the learned Zomato task, in words, with its slots and the Veg filter marked not needed; a missing value asked mid-run; and on Myntra, a size question listing the sizes on offer. The demo video follows the order the theme asks for.</a:t>
+              <a:t>Five moments from one Zomato task, captured on the phone on 30 Sep. 1: teaching, the red border and the Teaching pill with Done and Cancel. 2: what it learned, the steps in words with the command's values as slots, and the Veg filter tap marked not needed. 3: a replay by voice, the pill shows step 7 of 11, Tap ADD next to margherita. 4: a command without a restaurant, so it asks at the step that needs one. 5: it stops at the payment page and hands back. Below: three more commands from the 30 Sep evaluation that ran the same task with new values, a quantity, and a restaurant it was never taught on.</a:t>
             </a:r>
           </a:p>
         </p:txBody>
@@ -19575,12 +19575,12 @@
         </p:nvSpPr>
         <p:spPr>
           <a:xfrm>
-            <a:off x="932688" y="1508760"/>
-            <a:ext cx="1918155" cy="3374136"/>
+            <a:off x="868680" y="1399032"/>
+            <a:ext cx="1804105" cy="2871216"/>
           </a:xfrm>
           <a:prstGeom prst="roundRect">
             <a:avLst>
-              <a:gd name="adj" fmla="val 10487"/>
+              <a:gd name="adj" fmla="val 11150"/>
             </a:avLst>
           </a:prstGeom>
           <a:solidFill>
@@ -19599,7 +19599,7 @@
       </p:sp>
       <p:pic>
         <p:nvPicPr>
-          <p:cNvPr id="121" name="Picture 120" descr="teach.png"/>
+          <p:cNvPr id="121" name="Picture 120" descr="w1_teach.png"/>
           <p:cNvPicPr>
             <a:picLocks noChangeAspect="1"/>
           </p:cNvPicPr>
@@ -19613,8 +19613,8 @@
         </p:blipFill>
         <p:spPr>
           <a:xfrm>
-            <a:off x="996696" y="1572768"/>
-            <a:ext cx="1790139" cy="3246120"/>
+            <a:off x="932688" y="1463040"/>
+            <a:ext cx="1676089" cy="2743200"/>
           </a:xfrm>
           <a:prstGeom prst="rect">
             <a:avLst/>
@@ -19623,14 +19623,140 @@
       </p:pic>
       <p:sp>
         <p:nvSpPr>
-          <p:cNvPr id="122" name="TextBox 121"/>
+          <p:cNvPr id="122" name="Chevron 121"/>
+          <p:cNvSpPr/>
+          <p:nvPr/>
+        </p:nvSpPr>
+        <p:spPr>
+          <a:xfrm>
+            <a:off x="2779659" y="2697480"/>
+            <a:ext cx="146304" cy="274320"/>
+          </a:xfrm>
+          <a:prstGeom prst="chevron">
+            <a:avLst/>
+          </a:prstGeom>
+          <a:solidFill>
+            <a:srgbClr val="6D28D9"/>
+          </a:solidFill>
+          <a:ln>
+            <a:noFill/>
+          </a:ln>
+          <a:effectLst/>
+        </p:spPr>
+        <p:txBody>
+          <a:bodyPr rtlCol="0" anchor="ctr"/>
+          <a:lstStyle/>
+          <a:p/>
+        </p:txBody>
+      </p:sp>
+      <p:sp>
+        <p:nvSpPr>
+          <p:cNvPr id="123" name="Oval 122"/>
+          <p:cNvSpPr/>
+          <p:nvPr/>
+        </p:nvSpPr>
+        <p:spPr>
+          <a:xfrm>
+            <a:off x="896112" y="4389120"/>
+            <a:ext cx="274320" cy="274320"/>
+          </a:xfrm>
+          <a:prstGeom prst="ellipse">
+            <a:avLst/>
+          </a:prstGeom>
+          <a:solidFill>
+            <a:srgbClr val="6D28D9"/>
+          </a:solidFill>
+          <a:ln>
+            <a:noFill/>
+          </a:ln>
+          <a:effectLst/>
+        </p:spPr>
+        <p:txBody>
+          <a:bodyPr rtlCol="0" anchor="ctr"/>
+          <a:lstStyle/>
+          <a:p/>
+        </p:txBody>
+      </p:sp>
+      <p:sp>
+        <p:nvSpPr>
+          <p:cNvPr id="124" name="TextBox 123"/>
           <p:cNvSpPr txBox="1"/>
           <p:nvPr/>
         </p:nvSpPr>
         <p:spPr>
           <a:xfrm>
-            <a:off x="950976" y="4956048"/>
-            <a:ext cx="2247339" cy="274320"/>
+            <a:off x="896112" y="4389120"/>
+            <a:ext cx="274320" cy="274320"/>
+          </a:xfrm>
+          <a:prstGeom prst="rect">
+            <a:avLst/>
+          </a:prstGeom>
+          <a:noFill/>
+        </p:spPr>
+        <p:txBody>
+          <a:bodyPr wrap="square" lIns="0" rIns="0" tIns="0" bIns="0" anchor="ctr">
+            <a:spAutoFit/>
+          </a:bodyPr>
+          <a:lstStyle/>
+          <a:p>
+            <a:pPr algn="ctr"/>
+            <a:r>
+              <a:rPr sz="1200" b="1" i="0">
+                <a:solidFill>
+                  <a:srgbClr val="FFFFFF"/>
+                </a:solidFill>
+                <a:latin typeface="Arial"/>
+              </a:rPr>
+              <a:t>1</a:t>
+            </a:r>
+          </a:p>
+        </p:txBody>
+      </p:sp>
+      <p:sp>
+        <p:nvSpPr>
+          <p:cNvPr id="125" name="TextBox 124"/>
+          <p:cNvSpPr txBox="1"/>
+          <p:nvPr/>
+        </p:nvSpPr>
+        <p:spPr>
+          <a:xfrm>
+            <a:off x="1243584" y="4389120"/>
+            <a:ext cx="1889837" cy="274320"/>
+          </a:xfrm>
+          <a:prstGeom prst="rect">
+            <a:avLst/>
+          </a:prstGeom>
+          <a:noFill/>
+        </p:spPr>
+        <p:txBody>
+          <a:bodyPr wrap="square" lIns="0" rIns="0" tIns="0" bIns="0" anchor="ctr">
+            <a:spAutoFit/>
+          </a:bodyPr>
+          <a:lstStyle/>
+          <a:p>
+            <a:pPr algn="l"/>
+            <a:r>
+              <a:rPr sz="1250" b="1" i="0">
+                <a:solidFill>
+                  <a:srgbClr val="14142B"/>
+                </a:solidFill>
+                <a:latin typeface="Arial"/>
+              </a:rPr>
+              <a:t>Teach it once</a:t>
+            </a:r>
+          </a:p>
+        </p:txBody>
+      </p:sp>
+      <p:sp>
+        <p:nvSpPr>
+          <p:cNvPr id="126" name="TextBox 125"/>
+          <p:cNvSpPr txBox="1"/>
+          <p:nvPr/>
+        </p:nvSpPr>
+        <p:spPr>
+          <a:xfrm>
+            <a:off x="896112" y="4727448"/>
+            <a:ext cx="2036141" cy="502920"/>
           </a:xfrm>
           <a:prstGeom prst="rect">
             <a:avLst/>
@@ -19645,66 +19771,31 @@
           <a:p>
             <a:pPr algn="l"/>
             <a:r>
-              <a:rPr sz="1350" b="1" i="0">
-                <a:solidFill>
-                  <a:srgbClr val="14142B"/>
-                </a:solidFill>
-                <a:latin typeface="Arial"/>
+              <a:rPr sz="1050" b="0" i="0">
+                <a:solidFill>
+                  <a:srgbClr val="5B5F77"/>
+                </a:solidFill>
+                <a:latin typeface="Calibri"/>
               </a:rPr>
-              <a:t>1  Teaching</a:t>
+              <a:t>Say the command, then do it. A red border and a “Teaching” pill while it watches.</a:t>
             </a:r>
           </a:p>
         </p:txBody>
       </p:sp>
       <p:sp>
         <p:nvSpPr>
-          <p:cNvPr id="123" name="TextBox 122"/>
-          <p:cNvSpPr txBox="1"/>
-          <p:nvPr/>
-        </p:nvSpPr>
-        <p:spPr>
-          <a:xfrm>
-            <a:off x="950976" y="5230368"/>
-            <a:ext cx="2293059" cy="548640"/>
-          </a:xfrm>
-          <a:prstGeom prst="rect">
-            <a:avLst/>
-          </a:prstGeom>
-          <a:noFill/>
-        </p:spPr>
-        <p:txBody>
-          <a:bodyPr wrap="square" lIns="0" rIns="0" tIns="0" bIns="0" anchor="t">
-            <a:spAutoFit/>
-          </a:bodyPr>
-          <a:lstStyle/>
-          <a:p>
-            <a:pPr algn="l"/>
-            <a:r>
-              <a:rPr sz="1100" b="0" i="0">
-                <a:solidFill>
-                  <a:srgbClr val="5B5F77"/>
-                </a:solidFill>
-                <a:latin typeface="Calibri"/>
-              </a:rPr>
-              <a:t>Say the command, then do it. A red border and “Done” while you show the task.</a:t>
-            </a:r>
-          </a:p>
-        </p:txBody>
-      </p:sp>
-      <p:sp>
-        <p:nvSpPr>
-          <p:cNvPr id="124" name="Rounded Rectangle 123"/>
+          <p:cNvPr id="127" name="Rounded Rectangle 126"/>
           <p:cNvSpPr/>
           <p:nvPr/>
         </p:nvSpPr>
         <p:spPr>
           <a:xfrm>
-            <a:off x="3780214" y="1508760"/>
-            <a:ext cx="1918155" cy="3374136"/>
+            <a:off x="3032837" y="1399032"/>
+            <a:ext cx="1804105" cy="2871216"/>
           </a:xfrm>
           <a:prstGeom prst="roundRect">
             <a:avLst>
-              <a:gd name="adj" fmla="val 10487"/>
+              <a:gd name="adj" fmla="val 11150"/>
             </a:avLst>
           </a:prstGeom>
           <a:solidFill>
@@ -19723,7 +19814,7 @@
       </p:sp>
       <p:pic>
         <p:nvPicPr>
-          <p:cNvPr id="125" name="Picture 124" descr="learned.png"/>
+          <p:cNvPr id="128" name="Picture 127" descr="w2_learned.png"/>
           <p:cNvPicPr>
             <a:picLocks noChangeAspect="1"/>
           </p:cNvPicPr>
@@ -19737,8 +19828,8 @@
         </p:blipFill>
         <p:spPr>
           <a:xfrm>
-            <a:off x="3844222" y="1572768"/>
-            <a:ext cx="1790139" cy="3246120"/>
+            <a:off x="3096845" y="1463040"/>
+            <a:ext cx="1676089" cy="2743200"/>
           </a:xfrm>
           <a:prstGeom prst="rect">
             <a:avLst/>
@@ -19747,14 +19838,140 @@
       </p:pic>
       <p:sp>
         <p:nvSpPr>
-          <p:cNvPr id="126" name="TextBox 125"/>
+          <p:cNvPr id="129" name="Chevron 128"/>
+          <p:cNvSpPr/>
+          <p:nvPr/>
+        </p:nvSpPr>
+        <p:spPr>
+          <a:xfrm>
+            <a:off x="4943817" y="2697480"/>
+            <a:ext cx="146304" cy="274320"/>
+          </a:xfrm>
+          <a:prstGeom prst="chevron">
+            <a:avLst/>
+          </a:prstGeom>
+          <a:solidFill>
+            <a:srgbClr val="6D28D9"/>
+          </a:solidFill>
+          <a:ln>
+            <a:noFill/>
+          </a:ln>
+          <a:effectLst/>
+        </p:spPr>
+        <p:txBody>
+          <a:bodyPr rtlCol="0" anchor="ctr"/>
+          <a:lstStyle/>
+          <a:p/>
+        </p:txBody>
+      </p:sp>
+      <p:sp>
+        <p:nvSpPr>
+          <p:cNvPr id="130" name="Oval 129"/>
+          <p:cNvSpPr/>
+          <p:nvPr/>
+        </p:nvSpPr>
+        <p:spPr>
+          <a:xfrm>
+            <a:off x="3060269" y="4389120"/>
+            <a:ext cx="274320" cy="274320"/>
+          </a:xfrm>
+          <a:prstGeom prst="ellipse">
+            <a:avLst/>
+          </a:prstGeom>
+          <a:solidFill>
+            <a:srgbClr val="6D28D9"/>
+          </a:solidFill>
+          <a:ln>
+            <a:noFill/>
+          </a:ln>
+          <a:effectLst/>
+        </p:spPr>
+        <p:txBody>
+          <a:bodyPr rtlCol="0" anchor="ctr"/>
+          <a:lstStyle/>
+          <a:p/>
+        </p:txBody>
+      </p:sp>
+      <p:sp>
+        <p:nvSpPr>
+          <p:cNvPr id="131" name="TextBox 130"/>
           <p:cNvSpPr txBox="1"/>
           <p:nvPr/>
         </p:nvSpPr>
         <p:spPr>
           <a:xfrm>
-            <a:off x="3798502" y="4956048"/>
-            <a:ext cx="2247339" cy="274320"/>
+            <a:off x="3060269" y="4389120"/>
+            <a:ext cx="274320" cy="274320"/>
+          </a:xfrm>
+          <a:prstGeom prst="rect">
+            <a:avLst/>
+          </a:prstGeom>
+          <a:noFill/>
+        </p:spPr>
+        <p:txBody>
+          <a:bodyPr wrap="square" lIns="0" rIns="0" tIns="0" bIns="0" anchor="ctr">
+            <a:spAutoFit/>
+          </a:bodyPr>
+          <a:lstStyle/>
+          <a:p>
+            <a:pPr algn="ctr"/>
+            <a:r>
+              <a:rPr sz="1200" b="1" i="0">
+                <a:solidFill>
+                  <a:srgbClr val="FFFFFF"/>
+                </a:solidFill>
+                <a:latin typeface="Arial"/>
+              </a:rPr>
+              <a:t>2</a:t>
+            </a:r>
+          </a:p>
+        </p:txBody>
+      </p:sp>
+      <p:sp>
+        <p:nvSpPr>
+          <p:cNvPr id="132" name="TextBox 131"/>
+          <p:cNvSpPr txBox="1"/>
+          <p:nvPr/>
+        </p:nvSpPr>
+        <p:spPr>
+          <a:xfrm>
+            <a:off x="3407741" y="4389120"/>
+            <a:ext cx="1889837" cy="274320"/>
+          </a:xfrm>
+          <a:prstGeom prst="rect">
+            <a:avLst/>
+          </a:prstGeom>
+          <a:noFill/>
+        </p:spPr>
+        <p:txBody>
+          <a:bodyPr wrap="square" lIns="0" rIns="0" tIns="0" bIns="0" anchor="ctr">
+            <a:spAutoFit/>
+          </a:bodyPr>
+          <a:lstStyle/>
+          <a:p>
+            <a:pPr algn="l"/>
+            <a:r>
+              <a:rPr sz="1250" b="1" i="0">
+                <a:solidFill>
+                  <a:srgbClr val="14142B"/>
+                </a:solidFill>
+                <a:latin typeface="Arial"/>
+              </a:rPr>
+              <a:t>It learns the task</a:t>
+            </a:r>
+          </a:p>
+        </p:txBody>
+      </p:sp>
+      <p:sp>
+        <p:nvSpPr>
+          <p:cNvPr id="133" name="TextBox 132"/>
+          <p:cNvSpPr txBox="1"/>
+          <p:nvPr/>
+        </p:nvSpPr>
+        <p:spPr>
+          <a:xfrm>
+            <a:off x="3060269" y="4727448"/>
+            <a:ext cx="2036141" cy="502920"/>
           </a:xfrm>
           <a:prstGeom prst="rect">
             <a:avLst/>
@@ -19769,66 +19986,31 @@
           <a:p>
             <a:pPr algn="l"/>
             <a:r>
-              <a:rPr sz="1350" b="1" i="0">
-                <a:solidFill>
-                  <a:srgbClr val="14142B"/>
-                </a:solidFill>
-                <a:latin typeface="Arial"/>
+              <a:rPr sz="1050" b="0" i="0">
+                <a:solidFill>
+                  <a:srgbClr val="5B5F77"/>
+                </a:solidFill>
+                <a:latin typeface="Calibri"/>
               </a:rPr>
-              <a:t>2  What it learned</a:t>
+              <a:t>Steps in words, your values as {slots}, the stray Veg filter tap marked “not needed”.</a:t>
             </a:r>
           </a:p>
         </p:txBody>
       </p:sp>
       <p:sp>
         <p:nvSpPr>
-          <p:cNvPr id="127" name="TextBox 126"/>
-          <p:cNvSpPr txBox="1"/>
-          <p:nvPr/>
-        </p:nvSpPr>
-        <p:spPr>
-          <a:xfrm>
-            <a:off x="3798502" y="5230368"/>
-            <a:ext cx="2293059" cy="548640"/>
-          </a:xfrm>
-          <a:prstGeom prst="rect">
-            <a:avLst/>
-          </a:prstGeom>
-          <a:noFill/>
-        </p:spPr>
-        <p:txBody>
-          <a:bodyPr wrap="square" lIns="0" rIns="0" tIns="0" bIns="0" anchor="t">
-            <a:spAutoFit/>
-          </a:bodyPr>
-          <a:lstStyle/>
-          <a:p>
-            <a:pPr algn="l"/>
-            <a:r>
-              <a:rPr sz="1100" b="0" i="0">
-                <a:solidFill>
-                  <a:srgbClr val="5B5F77"/>
-                </a:solidFill>
-                <a:latin typeface="Calibri"/>
-              </a:rPr>
-              <a:t>Steps in words, values in braces, the stray tap marked “not needed”.</a:t>
-            </a:r>
-          </a:p>
-        </p:txBody>
-      </p:sp>
-      <p:sp>
-        <p:nvSpPr>
-          <p:cNvPr id="128" name="Rounded Rectangle 127"/>
+          <p:cNvPr id="134" name="Rounded Rectangle 133"/>
           <p:cNvSpPr/>
           <p:nvPr/>
         </p:nvSpPr>
         <p:spPr>
           <a:xfrm>
-            <a:off x="6627741" y="1508760"/>
-            <a:ext cx="1918155" cy="3374136"/>
+            <a:off x="5196995" y="1399032"/>
+            <a:ext cx="1804105" cy="2871216"/>
           </a:xfrm>
           <a:prstGeom prst="roundRect">
             <a:avLst>
-              <a:gd name="adj" fmla="val 10487"/>
+              <a:gd name="adj" fmla="val 11150"/>
             </a:avLst>
           </a:prstGeom>
           <a:solidFill>
@@ -19847,7 +20029,7 @@
       </p:sp>
       <p:pic>
         <p:nvPicPr>
-          <p:cNvPr id="129" name="Picture 128" descr="ask.png"/>
+          <p:cNvPr id="135" name="Picture 134" descr="w3_run.png"/>
           <p:cNvPicPr>
             <a:picLocks noChangeAspect="1"/>
           </p:cNvPicPr>
@@ -19861,8 +20043,8 @@
         </p:blipFill>
         <p:spPr>
           <a:xfrm>
-            <a:off x="6691749" y="1572768"/>
-            <a:ext cx="1790139" cy="3246120"/>
+            <a:off x="5261003" y="1463040"/>
+            <a:ext cx="1676089" cy="2743200"/>
           </a:xfrm>
           <a:prstGeom prst="rect">
             <a:avLst/>
@@ -19871,14 +20053,140 @@
       </p:pic>
       <p:sp>
         <p:nvSpPr>
-          <p:cNvPr id="130" name="TextBox 129"/>
+          <p:cNvPr id="136" name="Chevron 135"/>
+          <p:cNvSpPr/>
+          <p:nvPr/>
+        </p:nvSpPr>
+        <p:spPr>
+          <a:xfrm>
+            <a:off x="7107974" y="2697480"/>
+            <a:ext cx="146304" cy="274320"/>
+          </a:xfrm>
+          <a:prstGeom prst="chevron">
+            <a:avLst/>
+          </a:prstGeom>
+          <a:solidFill>
+            <a:srgbClr val="6D28D9"/>
+          </a:solidFill>
+          <a:ln>
+            <a:noFill/>
+          </a:ln>
+          <a:effectLst/>
+        </p:spPr>
+        <p:txBody>
+          <a:bodyPr rtlCol="0" anchor="ctr"/>
+          <a:lstStyle/>
+          <a:p/>
+        </p:txBody>
+      </p:sp>
+      <p:sp>
+        <p:nvSpPr>
+          <p:cNvPr id="137" name="Oval 136"/>
+          <p:cNvSpPr/>
+          <p:nvPr/>
+        </p:nvSpPr>
+        <p:spPr>
+          <a:xfrm>
+            <a:off x="5224427" y="4389120"/>
+            <a:ext cx="274320" cy="274320"/>
+          </a:xfrm>
+          <a:prstGeom prst="ellipse">
+            <a:avLst/>
+          </a:prstGeom>
+          <a:solidFill>
+            <a:srgbClr val="6D28D9"/>
+          </a:solidFill>
+          <a:ln>
+            <a:noFill/>
+          </a:ln>
+          <a:effectLst/>
+        </p:spPr>
+        <p:txBody>
+          <a:bodyPr rtlCol="0" anchor="ctr"/>
+          <a:lstStyle/>
+          <a:p/>
+        </p:txBody>
+      </p:sp>
+      <p:sp>
+        <p:nvSpPr>
+          <p:cNvPr id="138" name="TextBox 137"/>
           <p:cNvSpPr txBox="1"/>
           <p:nvPr/>
         </p:nvSpPr>
         <p:spPr>
           <a:xfrm>
-            <a:off x="6646029" y="4956048"/>
-            <a:ext cx="2247339" cy="274320"/>
+            <a:off x="5224427" y="4389120"/>
+            <a:ext cx="274320" cy="274320"/>
+          </a:xfrm>
+          <a:prstGeom prst="rect">
+            <a:avLst/>
+          </a:prstGeom>
+          <a:noFill/>
+        </p:spPr>
+        <p:txBody>
+          <a:bodyPr wrap="square" lIns="0" rIns="0" tIns="0" bIns="0" anchor="ctr">
+            <a:spAutoFit/>
+          </a:bodyPr>
+          <a:lstStyle/>
+          <a:p>
+            <a:pPr algn="ctr"/>
+            <a:r>
+              <a:rPr sz="1200" b="1" i="0">
+                <a:solidFill>
+                  <a:srgbClr val="FFFFFF"/>
+                </a:solidFill>
+                <a:latin typeface="Arial"/>
+              </a:rPr>
+              <a:t>3</a:t>
+            </a:r>
+          </a:p>
+        </p:txBody>
+      </p:sp>
+      <p:sp>
+        <p:nvSpPr>
+          <p:cNvPr id="139" name="TextBox 138"/>
+          <p:cNvSpPr txBox="1"/>
+          <p:nvPr/>
+        </p:nvSpPr>
+        <p:spPr>
+          <a:xfrm>
+            <a:off x="5571899" y="4389120"/>
+            <a:ext cx="1889837" cy="274320"/>
+          </a:xfrm>
+          <a:prstGeom prst="rect">
+            <a:avLst/>
+          </a:prstGeom>
+          <a:noFill/>
+        </p:spPr>
+        <p:txBody>
+          <a:bodyPr wrap="square" lIns="0" rIns="0" tIns="0" bIns="0" anchor="ctr">
+            <a:spAutoFit/>
+          </a:bodyPr>
+          <a:lstStyle/>
+          <a:p>
+            <a:pPr algn="l"/>
+            <a:r>
+              <a:rPr sz="1250" b="1" i="0">
+                <a:solidFill>
+                  <a:srgbClr val="14142B"/>
+                </a:solidFill>
+                <a:latin typeface="Arial"/>
+              </a:rPr>
+              <a:t>Replay by voice</a:t>
+            </a:r>
+          </a:p>
+        </p:txBody>
+      </p:sp>
+      <p:sp>
+        <p:nvSpPr>
+          <p:cNvPr id="140" name="TextBox 139"/>
+          <p:cNvSpPr txBox="1"/>
+          <p:nvPr/>
+        </p:nvSpPr>
+        <p:spPr>
+          <a:xfrm>
+            <a:off x="5224427" y="4727448"/>
+            <a:ext cx="2036141" cy="502920"/>
           </a:xfrm>
           <a:prstGeom prst="rect">
             <a:avLst/>
@@ -19893,66 +20201,31 @@
           <a:p>
             <a:pPr algn="l"/>
             <a:r>
-              <a:rPr sz="1350" b="1" i="0">
-                <a:solidFill>
-                  <a:srgbClr val="14142B"/>
-                </a:solidFill>
-                <a:latin typeface="Arial"/>
+              <a:rPr sz="1050" b="0" i="0">
+                <a:solidFill>
+                  <a:srgbClr val="5B5F77"/>
+                </a:solidFill>
+                <a:latin typeface="Calibri"/>
               </a:rPr>
-              <a:t>3  A missing value</a:t>
+              <a:t>“Get me a margherita from dominos”: it runs the 11 steps and shows each one.</a:t>
             </a:r>
           </a:p>
         </p:txBody>
       </p:sp>
       <p:sp>
         <p:nvSpPr>
-          <p:cNvPr id="131" name="TextBox 130"/>
-          <p:cNvSpPr txBox="1"/>
-          <p:nvPr/>
-        </p:nvSpPr>
-        <p:spPr>
-          <a:xfrm>
-            <a:off x="6646029" y="5230368"/>
-            <a:ext cx="2293059" cy="548640"/>
-          </a:xfrm>
-          <a:prstGeom prst="rect">
-            <a:avLst/>
-          </a:prstGeom>
-          <a:noFill/>
-        </p:spPr>
-        <p:txBody>
-          <a:bodyPr wrap="square" lIns="0" rIns="0" tIns="0" bIns="0" anchor="t">
-            <a:spAutoFit/>
-          </a:bodyPr>
-          <a:lstStyle/>
-          <a:p>
-            <a:pPr algn="l"/>
-            <a:r>
-              <a:rPr sz="1100" b="0" i="0">
-                <a:solidFill>
-                  <a:srgbClr val="5B5F77"/>
-                </a:solidFill>
-                <a:latin typeface="Calibri"/>
-              </a:rPr>
-              <a:t>“Which product should I use?” — asked at the step that needs it.</a:t>
-            </a:r>
-          </a:p>
-        </p:txBody>
-      </p:sp>
-      <p:sp>
-        <p:nvSpPr>
-          <p:cNvPr id="132" name="Rounded Rectangle 131"/>
+          <p:cNvPr id="141" name="Rounded Rectangle 140"/>
           <p:cNvSpPr/>
           <p:nvPr/>
         </p:nvSpPr>
         <p:spPr>
           <a:xfrm>
-            <a:off x="9475268" y="1508760"/>
-            <a:ext cx="1918155" cy="3374136"/>
+            <a:off x="7361152" y="1399032"/>
+            <a:ext cx="1804105" cy="2871216"/>
           </a:xfrm>
           <a:prstGeom prst="roundRect">
             <a:avLst>
-              <a:gd name="adj" fmla="val 10487"/>
+              <a:gd name="adj" fmla="val 11150"/>
             </a:avLst>
           </a:prstGeom>
           <a:solidFill>
@@ -19971,7 +20244,7 @@
       </p:sp>
       <p:pic>
         <p:nvPicPr>
-          <p:cNvPr id="133" name="Picture 132" descr="size_q.png"/>
+          <p:cNvPr id="142" name="Picture 141" descr="w4_ask.png"/>
           <p:cNvPicPr>
             <a:picLocks noChangeAspect="1"/>
           </p:cNvPicPr>
@@ -19985,8 +20258,8 @@
         </p:blipFill>
         <p:spPr>
           <a:xfrm>
-            <a:off x="9539276" y="1572768"/>
-            <a:ext cx="1790139" cy="3246120"/>
+            <a:off x="7425160" y="1463040"/>
+            <a:ext cx="1676089" cy="2743200"/>
           </a:xfrm>
           <a:prstGeom prst="rect">
             <a:avLst/>
@@ -19995,14 +20268,140 @@
       </p:pic>
       <p:sp>
         <p:nvSpPr>
-          <p:cNvPr id="134" name="TextBox 133"/>
+          <p:cNvPr id="143" name="Chevron 142"/>
+          <p:cNvSpPr/>
+          <p:nvPr/>
+        </p:nvSpPr>
+        <p:spPr>
+          <a:xfrm>
+            <a:off x="9272132" y="2697480"/>
+            <a:ext cx="146304" cy="274320"/>
+          </a:xfrm>
+          <a:prstGeom prst="chevron">
+            <a:avLst/>
+          </a:prstGeom>
+          <a:solidFill>
+            <a:srgbClr val="6D28D9"/>
+          </a:solidFill>
+          <a:ln>
+            <a:noFill/>
+          </a:ln>
+          <a:effectLst/>
+        </p:spPr>
+        <p:txBody>
+          <a:bodyPr rtlCol="0" anchor="ctr"/>
+          <a:lstStyle/>
+          <a:p/>
+        </p:txBody>
+      </p:sp>
+      <p:sp>
+        <p:nvSpPr>
+          <p:cNvPr id="144" name="Oval 143"/>
+          <p:cNvSpPr/>
+          <p:nvPr/>
+        </p:nvSpPr>
+        <p:spPr>
+          <a:xfrm>
+            <a:off x="7388584" y="4389120"/>
+            <a:ext cx="274320" cy="274320"/>
+          </a:xfrm>
+          <a:prstGeom prst="ellipse">
+            <a:avLst/>
+          </a:prstGeom>
+          <a:solidFill>
+            <a:srgbClr val="6D28D9"/>
+          </a:solidFill>
+          <a:ln>
+            <a:noFill/>
+          </a:ln>
+          <a:effectLst/>
+        </p:spPr>
+        <p:txBody>
+          <a:bodyPr rtlCol="0" anchor="ctr"/>
+          <a:lstStyle/>
+          <a:p/>
+        </p:txBody>
+      </p:sp>
+      <p:sp>
+        <p:nvSpPr>
+          <p:cNvPr id="145" name="TextBox 144"/>
           <p:cNvSpPr txBox="1"/>
           <p:nvPr/>
         </p:nvSpPr>
         <p:spPr>
           <a:xfrm>
-            <a:off x="9493556" y="4956048"/>
-            <a:ext cx="2247339" cy="274320"/>
+            <a:off x="7388584" y="4389120"/>
+            <a:ext cx="274320" cy="274320"/>
+          </a:xfrm>
+          <a:prstGeom prst="rect">
+            <a:avLst/>
+          </a:prstGeom>
+          <a:noFill/>
+        </p:spPr>
+        <p:txBody>
+          <a:bodyPr wrap="square" lIns="0" rIns="0" tIns="0" bIns="0" anchor="ctr">
+            <a:spAutoFit/>
+          </a:bodyPr>
+          <a:lstStyle/>
+          <a:p>
+            <a:pPr algn="ctr"/>
+            <a:r>
+              <a:rPr sz="1200" b="1" i="0">
+                <a:solidFill>
+                  <a:srgbClr val="FFFFFF"/>
+                </a:solidFill>
+                <a:latin typeface="Arial"/>
+              </a:rPr>
+              <a:t>4</a:t>
+            </a:r>
+          </a:p>
+        </p:txBody>
+      </p:sp>
+      <p:sp>
+        <p:nvSpPr>
+          <p:cNvPr id="146" name="TextBox 145"/>
+          <p:cNvSpPr txBox="1"/>
+          <p:nvPr/>
+        </p:nvSpPr>
+        <p:spPr>
+          <a:xfrm>
+            <a:off x="7736056" y="4389120"/>
+            <a:ext cx="1889837" cy="274320"/>
+          </a:xfrm>
+          <a:prstGeom prst="rect">
+            <a:avLst/>
+          </a:prstGeom>
+          <a:noFill/>
+        </p:spPr>
+        <p:txBody>
+          <a:bodyPr wrap="square" lIns="0" rIns="0" tIns="0" bIns="0" anchor="ctr">
+            <a:spAutoFit/>
+          </a:bodyPr>
+          <a:lstStyle/>
+          <a:p>
+            <a:pPr algn="l"/>
+            <a:r>
+              <a:rPr sz="1250" b="1" i="0">
+                <a:solidFill>
+                  <a:srgbClr val="14142B"/>
+                </a:solidFill>
+                <a:latin typeface="Arial"/>
+              </a:rPr>
+              <a:t>Asks what’s missing</a:t>
+            </a:r>
+          </a:p>
+        </p:txBody>
+      </p:sp>
+      <p:sp>
+        <p:nvSpPr>
+          <p:cNvPr id="147" name="TextBox 146"/>
+          <p:cNvSpPr txBox="1"/>
+          <p:nvPr/>
+        </p:nvSpPr>
+        <p:spPr>
+          <a:xfrm>
+            <a:off x="7388584" y="4727448"/>
+            <a:ext cx="2036141" cy="502920"/>
           </a:xfrm>
           <a:prstGeom prst="rect">
             <a:avLst/>
@@ -20017,27 +20416,179 @@
           <a:p>
             <a:pPr algn="l"/>
             <a:r>
-              <a:rPr sz="1350" b="1" i="0">
-                <a:solidFill>
-                  <a:srgbClr val="14142B"/>
+              <a:rPr sz="1050" b="0" i="0">
+                <a:solidFill>
+                  <a:srgbClr val="5B5F77"/>
+                </a:solidFill>
+                <a:latin typeface="Calibri"/>
+              </a:rPr>
+              <a:t>No restaurant in the command? It asks at the step that needs one, then carries on.</a:t>
+            </a:r>
+          </a:p>
+        </p:txBody>
+      </p:sp>
+      <p:sp>
+        <p:nvSpPr>
+          <p:cNvPr id="148" name="Rounded Rectangle 147"/>
+          <p:cNvSpPr/>
+          <p:nvPr/>
+        </p:nvSpPr>
+        <p:spPr>
+          <a:xfrm>
+            <a:off x="9525310" y="1399032"/>
+            <a:ext cx="1804105" cy="2871216"/>
+          </a:xfrm>
+          <a:prstGeom prst="roundRect">
+            <a:avLst>
+              <a:gd name="adj" fmla="val 11150"/>
+            </a:avLst>
+          </a:prstGeom>
+          <a:solidFill>
+            <a:srgbClr val="14142B"/>
+          </a:solidFill>
+          <a:ln>
+            <a:noFill/>
+          </a:ln>
+          <a:effectLst/>
+        </p:spPr>
+        <p:txBody>
+          <a:bodyPr rtlCol="0" anchor="ctr"/>
+          <a:lstStyle/>
+          <a:p/>
+        </p:txBody>
+      </p:sp>
+      <p:pic>
+        <p:nvPicPr>
+          <p:cNvPr id="149" name="Picture 148" descr="w5_done.png"/>
+          <p:cNvPicPr>
+            <a:picLocks noChangeAspect="1"/>
+          </p:cNvPicPr>
+          <p:nvPr/>
+        </p:nvPicPr>
+        <p:blipFill>
+          <a:blip r:embed="rId7"/>
+          <a:stretch>
+            <a:fillRect/>
+          </a:stretch>
+        </p:blipFill>
+        <p:spPr>
+          <a:xfrm>
+            <a:off x="9589318" y="1463040"/>
+            <a:ext cx="1676089" cy="2743200"/>
+          </a:xfrm>
+          <a:prstGeom prst="rect">
+            <a:avLst/>
+          </a:prstGeom>
+        </p:spPr>
+      </p:pic>
+      <p:sp>
+        <p:nvSpPr>
+          <p:cNvPr id="150" name="Oval 149"/>
+          <p:cNvSpPr/>
+          <p:nvPr/>
+        </p:nvSpPr>
+        <p:spPr>
+          <a:xfrm>
+            <a:off x="9552742" y="4389120"/>
+            <a:ext cx="274320" cy="274320"/>
+          </a:xfrm>
+          <a:prstGeom prst="ellipse">
+            <a:avLst/>
+          </a:prstGeom>
+          <a:solidFill>
+            <a:srgbClr val="6D28D9"/>
+          </a:solidFill>
+          <a:ln>
+            <a:noFill/>
+          </a:ln>
+          <a:effectLst/>
+        </p:spPr>
+        <p:txBody>
+          <a:bodyPr rtlCol="0" anchor="ctr"/>
+          <a:lstStyle/>
+          <a:p/>
+        </p:txBody>
+      </p:sp>
+      <p:sp>
+        <p:nvSpPr>
+          <p:cNvPr id="151" name="TextBox 150"/>
+          <p:cNvSpPr txBox="1"/>
+          <p:nvPr/>
+        </p:nvSpPr>
+        <p:spPr>
+          <a:xfrm>
+            <a:off x="9552742" y="4389120"/>
+            <a:ext cx="274320" cy="274320"/>
+          </a:xfrm>
+          <a:prstGeom prst="rect">
+            <a:avLst/>
+          </a:prstGeom>
+          <a:noFill/>
+        </p:spPr>
+        <p:txBody>
+          <a:bodyPr wrap="square" lIns="0" rIns="0" tIns="0" bIns="0" anchor="ctr">
+            <a:spAutoFit/>
+          </a:bodyPr>
+          <a:lstStyle/>
+          <a:p>
+            <a:pPr algn="ctr"/>
+            <a:r>
+              <a:rPr sz="1200" b="1" i="0">
+                <a:solidFill>
+                  <a:srgbClr val="FFFFFF"/>
                 </a:solidFill>
                 <a:latin typeface="Arial"/>
               </a:rPr>
-              <a:t>4  A personal choice</a:t>
+              <a:t>5</a:t>
             </a:r>
           </a:p>
         </p:txBody>
       </p:sp>
       <p:sp>
         <p:nvSpPr>
-          <p:cNvPr id="135" name="TextBox 134"/>
+          <p:cNvPr id="152" name="TextBox 151"/>
           <p:cNvSpPr txBox="1"/>
           <p:nvPr/>
         </p:nvSpPr>
         <p:spPr>
           <a:xfrm>
-            <a:off x="9493556" y="5230368"/>
-            <a:ext cx="2293059" cy="548640"/>
+            <a:off x="9900214" y="4389120"/>
+            <a:ext cx="1889837" cy="274320"/>
+          </a:xfrm>
+          <a:prstGeom prst="rect">
+            <a:avLst/>
+          </a:prstGeom>
+          <a:noFill/>
+        </p:spPr>
+        <p:txBody>
+          <a:bodyPr wrap="square" lIns="0" rIns="0" tIns="0" bIns="0" anchor="ctr">
+            <a:spAutoFit/>
+          </a:bodyPr>
+          <a:lstStyle/>
+          <a:p>
+            <a:pPr algn="l"/>
+            <a:r>
+              <a:rPr sz="1250" b="1" i="0">
+                <a:solidFill>
+                  <a:srgbClr val="14142B"/>
+                </a:solidFill>
+                <a:latin typeface="Arial"/>
+              </a:rPr>
+              <a:t>Stops before paying</a:t>
+            </a:r>
+          </a:p>
+        </p:txBody>
+      </p:sp>
+      <p:sp>
+        <p:nvSpPr>
+          <p:cNvPr id="153" name="TextBox 152"/>
+          <p:cNvSpPr txBox="1"/>
+          <p:nvPr/>
+        </p:nvSpPr>
+        <p:spPr>
+          <a:xfrm>
+            <a:off x="9552742" y="4727448"/>
+            <a:ext cx="2036141" cy="502920"/>
           </a:xfrm>
           <a:prstGeom prst="rect">
             <a:avLst/>
@@ -20052,31 +20603,432 @@
           <a:p>
             <a:pPr algn="l"/>
             <a:r>
-              <a:rPr sz="1100" b="0" i="0">
+              <a:rPr sz="1050" b="0" i="0">
                 <a:solidFill>
                   <a:srgbClr val="5B5F77"/>
                 </a:solidFill>
                 <a:latin typeface="Calibri"/>
               </a:rPr>
-              <a:t>It asks for the size and lists what’s available. It never picks for you.</a:t>
+              <a:t>At the payment page it hands back: “Your turn.” It never pays or signs in.</a:t>
             </a:r>
           </a:p>
         </p:txBody>
       </p:sp>
       <p:sp>
         <p:nvSpPr>
-          <p:cNvPr id="136" name="Rounded Rectangle 135"/>
+          <p:cNvPr id="154" name="TextBox 153"/>
+          <p:cNvSpPr txBox="1"/>
+          <p:nvPr/>
+        </p:nvSpPr>
+        <p:spPr>
+          <a:xfrm>
+            <a:off x="932688" y="5330952"/>
+            <a:ext cx="10332720" cy="228600"/>
+          </a:xfrm>
+          <a:prstGeom prst="rect">
+            <a:avLst/>
+          </a:prstGeom>
+          <a:noFill/>
+        </p:spPr>
+        <p:txBody>
+          <a:bodyPr wrap="square" lIns="0" rIns="0" tIns="0" bIns="0" anchor="t">
+            <a:spAutoFit/>
+          </a:bodyPr>
+          <a:lstStyle/>
+          <a:p>
+            <a:pPr algn="l"/>
+            <a:r>
+              <a:rPr sz="1000" b="1" i="0">
+                <a:solidFill>
+                  <a:srgbClr val="6D28D9"/>
+                </a:solidFill>
+                <a:latin typeface="Arial"/>
+              </a:rPr>
+              <a:t>SAME TASK, OTHER WORDS AND VALUES</a:t>
+            </a:r>
+            <a:r>
+              <a:rPr sz="1000" b="0" i="0">
+                <a:solidFill>
+                  <a:srgbClr val="5B5F77"/>
+                </a:solidFill>
+                <a:latin typeface="Calibri"/>
+              </a:rPr>
+              <a:t>   each replayed on the phone to the checkout hand-back (eval, 30 Sep)</a:t>
+            </a:r>
+          </a:p>
+        </p:txBody>
+      </p:sp>
+      <p:sp>
+        <p:nvSpPr>
+          <p:cNvPr id="155" name="Rounded Rectangle 154"/>
           <p:cNvSpPr/>
           <p:nvPr/>
         </p:nvSpPr>
         <p:spPr>
           <a:xfrm>
-            <a:off x="932688" y="5833872"/>
-            <a:ext cx="10332720" cy="384048"/>
+            <a:off x="932688" y="5577840"/>
+            <a:ext cx="2397556" cy="365760"/>
           </a:xfrm>
           <a:prstGeom prst="roundRect">
             <a:avLst>
-              <a:gd name="adj" fmla="val 23809"/>
+              <a:gd name="adj" fmla="val 50000"/>
+            </a:avLst>
+          </a:prstGeom>
+          <a:solidFill>
+            <a:srgbClr val="FFFFFF"/>
+          </a:solidFill>
+          <a:ln w="12700">
+            <a:solidFill>
+              <a:srgbClr val="D9D3F0"/>
+            </a:solidFill>
+          </a:ln>
+          <a:effectLst/>
+        </p:spPr>
+        <p:txBody>
+          <a:bodyPr rtlCol="0" anchor="ctr"/>
+          <a:lstStyle/>
+          <a:p/>
+        </p:txBody>
+      </p:sp>
+      <p:sp>
+        <p:nvSpPr>
+          <p:cNvPr id="156" name="Oval 155"/>
+          <p:cNvSpPr/>
+          <p:nvPr/>
+        </p:nvSpPr>
+        <p:spPr>
+          <a:xfrm>
+            <a:off x="996696" y="5641848"/>
+            <a:ext cx="237744" cy="237744"/>
+          </a:xfrm>
+          <a:prstGeom prst="ellipse">
+            <a:avLst/>
+          </a:prstGeom>
+          <a:solidFill>
+            <a:srgbClr val="6D28D9"/>
+          </a:solidFill>
+          <a:ln>
+            <a:noFill/>
+          </a:ln>
+          <a:effectLst/>
+        </p:spPr>
+        <p:txBody>
+          <a:bodyPr rtlCol="0" anchor="ctr"/>
+          <a:lstStyle/>
+          <a:p/>
+        </p:txBody>
+      </p:sp>
+      <p:pic>
+        <p:nvPicPr>
+          <p:cNvPr id="157" name="Picture 156" descr="MdMic_FFFFFF.png"/>
+          <p:cNvPicPr>
+            <a:picLocks noChangeAspect="1"/>
+          </p:cNvPicPr>
+          <p:nvPr/>
+        </p:nvPicPr>
+        <p:blipFill>
+          <a:blip r:embed="rId8"/>
+          <a:stretch>
+            <a:fillRect/>
+          </a:stretch>
+        </p:blipFill>
+        <p:spPr>
+          <a:xfrm>
+            <a:off x="1044244" y="5689396"/>
+            <a:ext cx="142646" cy="142646"/>
+          </a:xfrm>
+          <a:prstGeom prst="rect">
+            <a:avLst/>
+          </a:prstGeom>
+        </p:spPr>
+      </p:pic>
+      <p:sp>
+        <p:nvSpPr>
+          <p:cNvPr id="158" name="TextBox 157"/>
+          <p:cNvSpPr txBox="1"/>
+          <p:nvPr/>
+        </p:nvSpPr>
+        <p:spPr>
+          <a:xfrm>
+            <a:off x="1371600" y="5577840"/>
+            <a:ext cx="1867204" cy="365760"/>
+          </a:xfrm>
+          <a:prstGeom prst="rect">
+            <a:avLst/>
+          </a:prstGeom>
+          <a:noFill/>
+        </p:spPr>
+        <p:txBody>
+          <a:bodyPr wrap="square" lIns="0" rIns="0" tIns="0" bIns="0" anchor="ctr">
+            <a:spAutoFit/>
+          </a:bodyPr>
+          <a:lstStyle/>
+          <a:p>
+            <a:pPr algn="l"/>
+            <a:r>
+              <a:rPr sz="1050" b="0" i="1">
+                <a:solidFill>
+                  <a:srgbClr val="1F2037"/>
+                </a:solidFill>
+                <a:latin typeface="Calibri"/>
+              </a:rPr>
+              <a:t>Order garlic bread from dominos</a:t>
+            </a:r>
+          </a:p>
+        </p:txBody>
+      </p:sp>
+      <p:sp>
+        <p:nvSpPr>
+          <p:cNvPr id="159" name="Rounded Rectangle 158"/>
+          <p:cNvSpPr/>
+          <p:nvPr/>
+        </p:nvSpPr>
+        <p:spPr>
+          <a:xfrm>
+            <a:off x="4106570" y="5577840"/>
+            <a:ext cx="2964484" cy="365760"/>
+          </a:xfrm>
+          <a:prstGeom prst="roundRect">
+            <a:avLst>
+              <a:gd name="adj" fmla="val 50000"/>
+            </a:avLst>
+          </a:prstGeom>
+          <a:solidFill>
+            <a:srgbClr val="FFFFFF"/>
+          </a:solidFill>
+          <a:ln w="12700">
+            <a:solidFill>
+              <a:srgbClr val="D9D3F0"/>
+            </a:solidFill>
+          </a:ln>
+          <a:effectLst/>
+        </p:spPr>
+        <p:txBody>
+          <a:bodyPr rtlCol="0" anchor="ctr"/>
+          <a:lstStyle/>
+          <a:p/>
+        </p:txBody>
+      </p:sp>
+      <p:sp>
+        <p:nvSpPr>
+          <p:cNvPr id="160" name="Oval 159"/>
+          <p:cNvSpPr/>
+          <p:nvPr/>
+        </p:nvSpPr>
+        <p:spPr>
+          <a:xfrm>
+            <a:off x="4170578" y="5641848"/>
+            <a:ext cx="237744" cy="237744"/>
+          </a:xfrm>
+          <a:prstGeom prst="ellipse">
+            <a:avLst/>
+          </a:prstGeom>
+          <a:solidFill>
+            <a:srgbClr val="6D28D9"/>
+          </a:solidFill>
+          <a:ln>
+            <a:noFill/>
+          </a:ln>
+          <a:effectLst/>
+        </p:spPr>
+        <p:txBody>
+          <a:bodyPr rtlCol="0" anchor="ctr"/>
+          <a:lstStyle/>
+          <a:p/>
+        </p:txBody>
+      </p:sp>
+      <p:pic>
+        <p:nvPicPr>
+          <p:cNvPr id="161" name="Picture 160" descr="MdMic_FFFFFF.png"/>
+          <p:cNvPicPr>
+            <a:picLocks noChangeAspect="1"/>
+          </p:cNvPicPr>
+          <p:nvPr/>
+        </p:nvPicPr>
+        <p:blipFill>
+          <a:blip r:embed="rId8"/>
+          <a:stretch>
+            <a:fillRect/>
+          </a:stretch>
+        </p:blipFill>
+        <p:spPr>
+          <a:xfrm>
+            <a:off x="4218127" y="5689396"/>
+            <a:ext cx="142646" cy="142646"/>
+          </a:xfrm>
+          <a:prstGeom prst="rect">
+            <a:avLst/>
+          </a:prstGeom>
+        </p:spPr>
+      </p:pic>
+      <p:sp>
+        <p:nvSpPr>
+          <p:cNvPr id="162" name="TextBox 161"/>
+          <p:cNvSpPr txBox="1"/>
+          <p:nvPr/>
+        </p:nvSpPr>
+        <p:spPr>
+          <a:xfrm>
+            <a:off x="4545482" y="5577840"/>
+            <a:ext cx="2434132" cy="365760"/>
+          </a:xfrm>
+          <a:prstGeom prst="rect">
+            <a:avLst/>
+          </a:prstGeom>
+          <a:noFill/>
+        </p:spPr>
+        <p:txBody>
+          <a:bodyPr wrap="square" lIns="0" rIns="0" tIns="0" bIns="0" anchor="ctr">
+            <a:spAutoFit/>
+          </a:bodyPr>
+          <a:lstStyle/>
+          <a:p>
+            <a:pPr algn="l"/>
+            <a:r>
+              <a:rPr sz="1050" b="0" i="1">
+                <a:solidFill>
+                  <a:srgbClr val="1F2037"/>
+                </a:solidFill>
+                <a:latin typeface="Calibri"/>
+              </a:rPr>
+              <a:t>Order two Margherita pizzas from Domino’s</a:t>
+            </a:r>
+          </a:p>
+        </p:txBody>
+      </p:sp>
+      <p:sp>
+        <p:nvSpPr>
+          <p:cNvPr id="163" name="Rounded Rectangle 162"/>
+          <p:cNvSpPr/>
+          <p:nvPr/>
+        </p:nvSpPr>
+        <p:spPr>
+          <a:xfrm>
+            <a:off x="7847380" y="5577840"/>
+            <a:ext cx="3418027" cy="365760"/>
+          </a:xfrm>
+          <a:prstGeom prst="roundRect">
+            <a:avLst>
+              <a:gd name="adj" fmla="val 50000"/>
+            </a:avLst>
+          </a:prstGeom>
+          <a:solidFill>
+            <a:srgbClr val="FFFFFF"/>
+          </a:solidFill>
+          <a:ln w="12700">
+            <a:solidFill>
+              <a:srgbClr val="D9D3F0"/>
+            </a:solidFill>
+          </a:ln>
+          <a:effectLst/>
+        </p:spPr>
+        <p:txBody>
+          <a:bodyPr rtlCol="0" anchor="ctr"/>
+          <a:lstStyle/>
+          <a:p/>
+        </p:txBody>
+      </p:sp>
+      <p:sp>
+        <p:nvSpPr>
+          <p:cNvPr id="164" name="Oval 163"/>
+          <p:cNvSpPr/>
+          <p:nvPr/>
+        </p:nvSpPr>
+        <p:spPr>
+          <a:xfrm>
+            <a:off x="7911388" y="5641848"/>
+            <a:ext cx="237744" cy="237744"/>
+          </a:xfrm>
+          <a:prstGeom prst="ellipse">
+            <a:avLst/>
+          </a:prstGeom>
+          <a:solidFill>
+            <a:srgbClr val="6D28D9"/>
+          </a:solidFill>
+          <a:ln>
+            <a:noFill/>
+          </a:ln>
+          <a:effectLst/>
+        </p:spPr>
+        <p:txBody>
+          <a:bodyPr rtlCol="0" anchor="ctr"/>
+          <a:lstStyle/>
+          <a:p/>
+        </p:txBody>
+      </p:sp>
+      <p:pic>
+        <p:nvPicPr>
+          <p:cNvPr id="165" name="Picture 164" descr="MdMic_FFFFFF.png"/>
+          <p:cNvPicPr>
+            <a:picLocks noChangeAspect="1"/>
+          </p:cNvPicPr>
+          <p:nvPr/>
+        </p:nvPicPr>
+        <p:blipFill>
+          <a:blip r:embed="rId8"/>
+          <a:stretch>
+            <a:fillRect/>
+          </a:stretch>
+        </p:blipFill>
+        <p:spPr>
+          <a:xfrm>
+            <a:off x="7958937" y="5689396"/>
+            <a:ext cx="142646" cy="142646"/>
+          </a:xfrm>
+          <a:prstGeom prst="rect">
+            <a:avLst/>
+          </a:prstGeom>
+        </p:spPr>
+      </p:pic>
+      <p:sp>
+        <p:nvSpPr>
+          <p:cNvPr id="166" name="TextBox 165"/>
+          <p:cNvSpPr txBox="1"/>
+          <p:nvPr/>
+        </p:nvSpPr>
+        <p:spPr>
+          <a:xfrm>
+            <a:off x="8286292" y="5577840"/>
+            <a:ext cx="2887675" cy="365760"/>
+          </a:xfrm>
+          <a:prstGeom prst="rect">
+            <a:avLst/>
+          </a:prstGeom>
+          <a:noFill/>
+        </p:spPr>
+        <p:txBody>
+          <a:bodyPr wrap="square" lIns="0" rIns="0" tIns="0" bIns="0" anchor="ctr">
+            <a:spAutoFit/>
+          </a:bodyPr>
+          <a:lstStyle/>
+          <a:p>
+            <a:pPr algn="l"/>
+            <a:r>
+              <a:rPr sz="1050" b="0" i="1">
+                <a:solidFill>
+                  <a:srgbClr val="1F2037"/>
+                </a:solidFill>
+                <a:latin typeface="Calibri"/>
+              </a:rPr>
+              <a:t>Order a margherita pizza from Pizza Hut on Zomato</a:t>
+            </a:r>
+          </a:p>
+        </p:txBody>
+      </p:sp>
+      <p:sp>
+        <p:nvSpPr>
+          <p:cNvPr id="167" name="Rounded Rectangle 166"/>
+          <p:cNvSpPr/>
+          <p:nvPr/>
+        </p:nvSpPr>
+        <p:spPr>
+          <a:xfrm>
+            <a:off x="932688" y="6053328"/>
+            <a:ext cx="10332720" cy="347472"/>
+          </a:xfrm>
+          <a:prstGeom prst="roundRect">
+            <a:avLst>
+              <a:gd name="adj" fmla="val 26315"/>
             </a:avLst>
           </a:prstGeom>
           <a:solidFill>
@@ -20095,14 +21047,14 @@
       </p:sp>
       <p:sp>
         <p:nvSpPr>
-          <p:cNvPr id="137" name="TextBox 136"/>
+          <p:cNvPr id="168" name="TextBox 167"/>
           <p:cNvSpPr txBox="1"/>
           <p:nvPr/>
         </p:nvSpPr>
         <p:spPr>
           <a:xfrm>
-            <a:off x="1115568" y="5833872"/>
-            <a:ext cx="9966960" cy="384048"/>
+            <a:off x="1115568" y="6053328"/>
+            <a:ext cx="9966960" cy="347472"/>
           </a:xfrm>
           <a:prstGeom prst="rect">
             <a:avLst/>
@@ -20117,7 +21069,7 @@
           <a:p>
             <a:pPr algn="l"/>
             <a:r>
-              <a:rPr sz="1150" b="1" i="0">
+              <a:rPr sz="1100" b="1" i="0">
                 <a:solidFill>
                   <a:srgbClr val="6D28D9"/>
                 </a:solidFill>
@@ -20126,13 +21078,13 @@
               <a:t>Demo video (≤ 5 min, one unedited take): </a:t>
             </a:r>
             <a:r>
-              <a:rPr sz="1150" b="0" i="0">
+              <a:rPr sz="1100" b="0" i="0">
                 <a:solidFill>
                   <a:srgbClr val="1F2037"/>
                 </a:solidFill>
                 <a:latin typeface="Calibri"/>
               </a:rPr>
-              <a:t>teach by voice + taps → exact replay → a paraphrase → a changed value → the assistant asking a question. Link in the README and the form.</a:t>
+              <a:t>teach by voice + taps → exact replay → a paraphrase → a changed value → a question. Link in the README and the form.</a:t>
             </a:r>
           </a:p>
         </p:txBody>

</xml_diff>

<commit_message>
AI disclosure, requirements.txt, and the deck's checklist
The submission form asks for an AI disclosure and a requirements file.
README: an AI disclosure section (gpt-oss-120b on Fireworks AI inside the
app, what it receives; Claude as the coding assistant), requirements.txt
in Build and in the repository table. requirements.txt lists the Python
packages for the deck generator; the recon scripts need only the
standard library and the app builds with Gradle. Deck checklist slide:
an AI disclosure row.

Co-Authored-By: Claude Opus 5.5 <noreply@anthropic.com>
Claude-Session: https://claude.ai/code/session_011KQSFKCwgub7G5EKjwmTaV
</commit_message>
<xml_diff>
--- a/TIET_Update_Submission_ppt.pptx
+++ b/TIET_Update_Submission_ppt.pptx
@@ -1705,7 +1705,7 @@
           <a:lstStyle/>
           <a:p>
             <a:r>
-              <a:t>Everything the submission asks for is in the public repository under the release tag: code, README with setup and a Dockerfile, the APK, the demo video link, this presentation, and the architecture and limitations the theme asks for.</a:t>
+              <a:t>Everything the submission asks for is in the public repository under the release tag: code, README with setup and a Dockerfile, the APK, the demo video link, this presentation, the architecture and limitations the theme asks for, and the AI disclosure.</a:t>
             </a:r>
           </a:p>
         </p:txBody>
@@ -14549,12 +14549,12 @@
         </p:nvSpPr>
         <p:spPr>
           <a:xfrm>
-            <a:off x="932688" y="1691640"/>
-            <a:ext cx="10332720" cy="731520"/>
+            <a:off x="932688" y="1627632"/>
+            <a:ext cx="10332720" cy="621792"/>
           </a:xfrm>
           <a:prstGeom prst="roundRect">
             <a:avLst>
-              <a:gd name="adj" fmla="val 10000"/>
+              <a:gd name="adj" fmla="val 11764"/>
             </a:avLst>
           </a:prstGeom>
           <a:solidFill>
@@ -14579,8 +14579,8 @@
         </p:nvSpPr>
         <p:spPr>
           <a:xfrm>
-            <a:off x="1115568" y="1837944"/>
-            <a:ext cx="438912" cy="438912"/>
+            <a:off x="1115568" y="1737360"/>
+            <a:ext cx="402336" cy="402336"/>
           </a:xfrm>
           <a:prstGeom prst="ellipse">
             <a:avLst/>
@@ -14607,8 +14607,8 @@
         </p:nvSpPr>
         <p:spPr>
           <a:xfrm>
-            <a:off x="1115568" y="1837944"/>
-            <a:ext cx="438912" cy="438912"/>
+            <a:off x="1115568" y="1737360"/>
+            <a:ext cx="402336" cy="402336"/>
           </a:xfrm>
           <a:prstGeom prst="rect">
             <a:avLst/>
@@ -14623,7 +14623,7 @@
           <a:p>
             <a:pPr algn="ctr"/>
             <a:r>
-              <a:rPr sz="1600" b="1" i="0">
+              <a:rPr sz="1500" b="1" i="0">
                 <a:solidFill>
                   <a:srgbClr val="FFFFFF"/>
                 </a:solidFill>
@@ -14642,8 +14642,8 @@
         </p:nvSpPr>
         <p:spPr>
           <a:xfrm>
-            <a:off x="1755648" y="1755648"/>
-            <a:ext cx="9326880" cy="621792"/>
+            <a:off x="1755648" y="1673352"/>
+            <a:ext cx="9326880" cy="530352"/>
           </a:xfrm>
           <a:prstGeom prst="rect">
             <a:avLst/>
@@ -14689,12 +14689,12 @@
         </p:nvSpPr>
         <p:spPr>
           <a:xfrm>
-            <a:off x="932688" y="2560320"/>
-            <a:ext cx="10332720" cy="731520"/>
+            <a:off x="932688" y="2359152"/>
+            <a:ext cx="10332720" cy="621792"/>
           </a:xfrm>
           <a:prstGeom prst="roundRect">
             <a:avLst>
-              <a:gd name="adj" fmla="val 10000"/>
+              <a:gd name="adj" fmla="val 11764"/>
             </a:avLst>
           </a:prstGeom>
           <a:solidFill>
@@ -14719,8 +14719,8 @@
         </p:nvSpPr>
         <p:spPr>
           <a:xfrm>
-            <a:off x="1115568" y="2706624"/>
-            <a:ext cx="438912" cy="438912"/>
+            <a:off x="1115568" y="2468880"/>
+            <a:ext cx="402336" cy="402336"/>
           </a:xfrm>
           <a:prstGeom prst="ellipse">
             <a:avLst/>
@@ -14747,8 +14747,8 @@
         </p:nvSpPr>
         <p:spPr>
           <a:xfrm>
-            <a:off x="1115568" y="2706624"/>
-            <a:ext cx="438912" cy="438912"/>
+            <a:off x="1115568" y="2468880"/>
+            <a:ext cx="402336" cy="402336"/>
           </a:xfrm>
           <a:prstGeom prst="rect">
             <a:avLst/>
@@ -14763,7 +14763,7 @@
           <a:p>
             <a:pPr algn="ctr"/>
             <a:r>
-              <a:rPr sz="1600" b="1" i="0">
+              <a:rPr sz="1500" b="1" i="0">
                 <a:solidFill>
                   <a:srgbClr val="FFFFFF"/>
                 </a:solidFill>
@@ -14782,8 +14782,8 @@
         </p:nvSpPr>
         <p:spPr>
           <a:xfrm>
-            <a:off x="1755648" y="2624327"/>
-            <a:ext cx="9326880" cy="621792"/>
+            <a:off x="1755648" y="2404872"/>
+            <a:ext cx="9326880" cy="530352"/>
           </a:xfrm>
           <a:prstGeom prst="rect">
             <a:avLst/>
@@ -14816,7 +14816,7 @@
                 </a:solidFill>
                 <a:latin typeface="Calibri"/>
               </a:rPr>
-              <a:t>README with setup steps, a Dockerfile that builds the APK, and the installable APK in the GitHub release</a:t>
+              <a:t>README with setup steps, requirements.txt, a Dockerfile that builds the APK, and the installable APK in the GitHub release</a:t>
             </a:r>
           </a:p>
         </p:txBody>
@@ -14829,12 +14829,12 @@
         </p:nvSpPr>
         <p:spPr>
           <a:xfrm>
-            <a:off x="932688" y="3429000"/>
-            <a:ext cx="10332720" cy="731520"/>
+            <a:off x="932688" y="3090672"/>
+            <a:ext cx="10332720" cy="621792"/>
           </a:xfrm>
           <a:prstGeom prst="roundRect">
             <a:avLst>
-              <a:gd name="adj" fmla="val 10000"/>
+              <a:gd name="adj" fmla="val 11764"/>
             </a:avLst>
           </a:prstGeom>
           <a:solidFill>
@@ -14859,8 +14859,8 @@
         </p:nvSpPr>
         <p:spPr>
           <a:xfrm>
-            <a:off x="1115568" y="3575304"/>
-            <a:ext cx="438912" cy="438912"/>
+            <a:off x="1115568" y="3200400"/>
+            <a:ext cx="402336" cy="402336"/>
           </a:xfrm>
           <a:prstGeom prst="ellipse">
             <a:avLst/>
@@ -14887,8 +14887,8 @@
         </p:nvSpPr>
         <p:spPr>
           <a:xfrm>
-            <a:off x="1115568" y="3575304"/>
-            <a:ext cx="438912" cy="438912"/>
+            <a:off x="1115568" y="3200400"/>
+            <a:ext cx="402336" cy="402336"/>
           </a:xfrm>
           <a:prstGeom prst="rect">
             <a:avLst/>
@@ -14903,7 +14903,7 @@
           <a:p>
             <a:pPr algn="ctr"/>
             <a:r>
-              <a:rPr sz="1600" b="1" i="0">
+              <a:rPr sz="1500" b="1" i="0">
                 <a:solidFill>
                   <a:srgbClr val="FFFFFF"/>
                 </a:solidFill>
@@ -14922,8 +14922,8 @@
         </p:nvSpPr>
         <p:spPr>
           <a:xfrm>
-            <a:off x="1755648" y="3493008"/>
-            <a:ext cx="9326880" cy="621792"/>
+            <a:off x="1755648" y="3136391"/>
+            <a:ext cx="9326880" cy="530352"/>
           </a:xfrm>
           <a:prstGeom prst="rect">
             <a:avLst/>
@@ -14969,12 +14969,12 @@
         </p:nvSpPr>
         <p:spPr>
           <a:xfrm>
-            <a:off x="932688" y="4297679"/>
-            <a:ext cx="10332720" cy="731520"/>
+            <a:off x="932688" y="3822192"/>
+            <a:ext cx="10332720" cy="621792"/>
           </a:xfrm>
           <a:prstGeom prst="roundRect">
             <a:avLst>
-              <a:gd name="adj" fmla="val 10000"/>
+              <a:gd name="adj" fmla="val 11764"/>
             </a:avLst>
           </a:prstGeom>
           <a:solidFill>
@@ -14999,8 +14999,8 @@
         </p:nvSpPr>
         <p:spPr>
           <a:xfrm>
-            <a:off x="1115568" y="4443983"/>
-            <a:ext cx="438912" cy="438912"/>
+            <a:off x="1115568" y="3931920"/>
+            <a:ext cx="402336" cy="402336"/>
           </a:xfrm>
           <a:prstGeom prst="ellipse">
             <a:avLst/>
@@ -15027,8 +15027,8 @@
         </p:nvSpPr>
         <p:spPr>
           <a:xfrm>
-            <a:off x="1115568" y="4443983"/>
-            <a:ext cx="438912" cy="438912"/>
+            <a:off x="1115568" y="3931920"/>
+            <a:ext cx="402336" cy="402336"/>
           </a:xfrm>
           <a:prstGeom prst="rect">
             <a:avLst/>
@@ -15043,7 +15043,7 @@
           <a:p>
             <a:pPr algn="ctr"/>
             <a:r>
-              <a:rPr sz="1600" b="1" i="0">
+              <a:rPr sz="1500" b="1" i="0">
                 <a:solidFill>
                   <a:srgbClr val="FFFFFF"/>
                 </a:solidFill>
@@ -15062,8 +15062,8 @@
         </p:nvSpPr>
         <p:spPr>
           <a:xfrm>
-            <a:off x="1755648" y="4361688"/>
-            <a:ext cx="9326880" cy="621792"/>
+            <a:off x="1755648" y="3867912"/>
+            <a:ext cx="9326880" cy="530352"/>
           </a:xfrm>
           <a:prstGeom prst="rect">
             <a:avLst/>
@@ -15109,12 +15109,12 @@
         </p:nvSpPr>
         <p:spPr>
           <a:xfrm>
-            <a:off x="932688" y="5166360"/>
-            <a:ext cx="10332720" cy="731520"/>
+            <a:off x="932688" y="4553712"/>
+            <a:ext cx="10332720" cy="621792"/>
           </a:xfrm>
           <a:prstGeom prst="roundRect">
             <a:avLst>
-              <a:gd name="adj" fmla="val 10000"/>
+              <a:gd name="adj" fmla="val 11764"/>
             </a:avLst>
           </a:prstGeom>
           <a:solidFill>
@@ -15139,8 +15139,8 @@
         </p:nvSpPr>
         <p:spPr>
           <a:xfrm>
-            <a:off x="1115568" y="5312664"/>
-            <a:ext cx="438912" cy="438912"/>
+            <a:off x="1115568" y="4663440"/>
+            <a:ext cx="402336" cy="402336"/>
           </a:xfrm>
           <a:prstGeom prst="ellipse">
             <a:avLst/>
@@ -15167,8 +15167,8 @@
         </p:nvSpPr>
         <p:spPr>
           <a:xfrm>
-            <a:off x="1115568" y="5312664"/>
-            <a:ext cx="438912" cy="438912"/>
+            <a:off x="1115568" y="4663440"/>
+            <a:ext cx="402336" cy="402336"/>
           </a:xfrm>
           <a:prstGeom prst="rect">
             <a:avLst/>
@@ -15183,7 +15183,7 @@
           <a:p>
             <a:pPr algn="ctr"/>
             <a:r>
-              <a:rPr sz="1600" b="1" i="0">
+              <a:rPr sz="1500" b="1" i="0">
                 <a:solidFill>
                   <a:srgbClr val="FFFFFF"/>
                 </a:solidFill>
@@ -15202,8 +15202,8 @@
         </p:nvSpPr>
         <p:spPr>
           <a:xfrm>
-            <a:off x="1755648" y="5230368"/>
-            <a:ext cx="9326880" cy="621792"/>
+            <a:off x="1755648" y="4599432"/>
+            <a:ext cx="9326880" cy="530352"/>
           </a:xfrm>
           <a:prstGeom prst="rect">
             <a:avLst/>
@@ -15237,6 +15237,146 @@
                 <a:latin typeface="Calibri"/>
               </a:rPr>
               <a:t>docs/architecture.md with diagrams; target apps and limitations in the README</a:t>
+            </a:r>
+          </a:p>
+        </p:txBody>
+      </p:sp>
+      <p:sp>
+        <p:nvSpPr>
+          <p:cNvPr id="176" name="Rounded Rectangle 175"/>
+          <p:cNvSpPr/>
+          <p:nvPr/>
+        </p:nvSpPr>
+        <p:spPr>
+          <a:xfrm>
+            <a:off x="932688" y="5285232"/>
+            <a:ext cx="10332720" cy="621792"/>
+          </a:xfrm>
+          <a:prstGeom prst="roundRect">
+            <a:avLst>
+              <a:gd name="adj" fmla="val 11764"/>
+            </a:avLst>
+          </a:prstGeom>
+          <a:solidFill>
+            <a:srgbClr val="F5F3FC"/>
+          </a:solidFill>
+          <a:ln>
+            <a:noFill/>
+          </a:ln>
+          <a:effectLst/>
+        </p:spPr>
+        <p:txBody>
+          <a:bodyPr rtlCol="0" anchor="ctr"/>
+          <a:lstStyle/>
+          <a:p/>
+        </p:txBody>
+      </p:sp>
+      <p:sp>
+        <p:nvSpPr>
+          <p:cNvPr id="177" name="Oval 176"/>
+          <p:cNvSpPr/>
+          <p:nvPr/>
+        </p:nvSpPr>
+        <p:spPr>
+          <a:xfrm>
+            <a:off x="1115568" y="5394960"/>
+            <a:ext cx="402336" cy="402336"/>
+          </a:xfrm>
+          <a:prstGeom prst="ellipse">
+            <a:avLst/>
+          </a:prstGeom>
+          <a:solidFill>
+            <a:srgbClr val="0E9F6E"/>
+          </a:solidFill>
+          <a:ln>
+            <a:noFill/>
+          </a:ln>
+          <a:effectLst/>
+        </p:spPr>
+        <p:txBody>
+          <a:bodyPr rtlCol="0" anchor="ctr"/>
+          <a:lstStyle/>
+          <a:p/>
+        </p:txBody>
+      </p:sp>
+      <p:sp>
+        <p:nvSpPr>
+          <p:cNvPr id="178" name="TextBox 177"/>
+          <p:cNvSpPr txBox="1"/>
+          <p:nvPr/>
+        </p:nvSpPr>
+        <p:spPr>
+          <a:xfrm>
+            <a:off x="1115568" y="5394960"/>
+            <a:ext cx="402336" cy="402336"/>
+          </a:xfrm>
+          <a:prstGeom prst="rect">
+            <a:avLst/>
+          </a:prstGeom>
+          <a:noFill/>
+        </p:spPr>
+        <p:txBody>
+          <a:bodyPr wrap="square" lIns="0" rIns="0" tIns="0" bIns="0" anchor="ctr">
+            <a:spAutoFit/>
+          </a:bodyPr>
+          <a:lstStyle/>
+          <a:p>
+            <a:pPr algn="ctr"/>
+            <a:r>
+              <a:rPr sz="1500" b="1" i="0">
+                <a:solidFill>
+                  <a:srgbClr val="FFFFFF"/>
+                </a:solidFill>
+                <a:latin typeface="Arial"/>
+              </a:rPr>
+              <a:t>Y</a:t>
+            </a:r>
+          </a:p>
+        </p:txBody>
+      </p:sp>
+      <p:sp>
+        <p:nvSpPr>
+          <p:cNvPr id="179" name="TextBox 178"/>
+          <p:cNvSpPr txBox="1"/>
+          <p:nvPr/>
+        </p:nvSpPr>
+        <p:spPr>
+          <a:xfrm>
+            <a:off x="1755648" y="5330952"/>
+            <a:ext cx="9326880" cy="530352"/>
+          </a:xfrm>
+          <a:prstGeom prst="rect">
+            <a:avLst/>
+          </a:prstGeom>
+          <a:noFill/>
+        </p:spPr>
+        <p:txBody>
+          <a:bodyPr wrap="square" lIns="0" rIns="0" tIns="0" bIns="0" anchor="ctr">
+            <a:spAutoFit/>
+          </a:bodyPr>
+          <a:lstStyle/>
+          <a:p>
+            <a:pPr algn="l"/>
+            <a:r>
+              <a:rPr sz="1400" b="1" i="0">
+                <a:solidFill>
+                  <a:srgbClr val="14142B"/>
+                </a:solidFill>
+                <a:latin typeface="Calibri"/>
+              </a:rPr>
+              <a:t>AI disclosure</a:t>
+            </a:r>
+          </a:p>
+          <a:p>
+            <a:pPr algn="l"/>
+            <a:r>
+              <a:rPr sz="1200" b="0" i="0">
+                <a:solidFill>
+                  <a:srgbClr val="5B5F77"/>
+                </a:solidFill>
+                <a:latin typeface="Calibri"/>
+              </a:rPr>
+              <a:t>README → AI disclosure: gpt-oss-120b on Fireworks AI inside the app; Claude (Anthropic) as our coding assistant</a:t>
             </a:r>
           </a:p>
         </p:txBody>

</xml_diff>

<commit_message>
Demo video link in the README and the deck
The 4:59 demo (one unedited take: teach by voice and taps, exact replay,
paraphrase, Farmhouse, the restaurant question) is on Google Drive, open
to anyone with the link. README: the link under the target apps, the
presentation and release pointers, and the pill's 🎤 Next. Deck: slide 5
links the video; slide 11 says where the link is.

Co-Authored-By: Claude Opus 5.5 <noreply@anthropic.com>
Claude-Session: https://claude.ai/code/session_011KQSFKCwgub7G5EKjwmTaV
</commit_message>
<xml_diff>
--- a/TIET_Update_Submission_ppt.pptx
+++ b/TIET_Update_Submission_ppt.pptx
@@ -14956,7 +14956,7 @@
                 </a:solidFill>
                 <a:latin typeface="Calibri"/>
               </a:rPr>
-              <a:t>One unedited take in the order the theme asks for; the link is in the README and the form</a:t>
+              <a:t>4:59, one unedited take in the order the theme asks for, on Google Drive; linked in the README and on slide 5</a:t>
             </a:r>
           </a:p>
         </p:txBody>
@@ -21215,7 +21215,7 @@
                 </a:solidFill>
                 <a:latin typeface="Calibri"/>
               </a:rPr>
-              <a:t>Demo video (≤ 5 min, one unedited take): </a:t>
+              <a:t>Demo video (4:59, one unedited take): </a:t>
             </a:r>
             <a:r>
               <a:rPr sz="1100" b="0" i="0">
@@ -21224,7 +21224,17 @@
                 </a:solidFill>
                 <a:latin typeface="Calibri"/>
               </a:rPr>
-              <a:t>teach by voice + taps → exact replay → a paraphrase → a changed value → a question. Link in the README and the form.</a:t>
+              <a:t>teach by voice + taps → exact replay → paraphrase → changed value → a question.  </a:t>
+            </a:r>
+            <a:r>
+              <a:rPr sz="1100" b="1" i="0" u="sng">
+                <a:solidFill>
+                  <a:srgbClr val="6D28D9"/>
+                </a:solidFill>
+                <a:latin typeface="Calibri"/>
+                <a:hlinkClick r:id="rId9"/>
+              </a:rPr>
+              <a:t>Watch it on Google Drive</a:t>
             </a:r>
           </a:p>
         </p:txBody>

</xml_diff>